<commit_message>
adding details in pp and creating merge of new and old list final lists
</commit_message>
<xml_diff>
--- a/docs/group_meeting_pp_turboid.pptx
+++ b/docs/group_meeting_pp_turboid.pptx
@@ -5,7 +5,7 @@
     <p:sldMasterId id="2147483713" r:id="rId1"/>
   </p:sldMasterIdLst>
   <p:notesMasterIdLst>
-    <p:notesMasterId r:id="rId26"/>
+    <p:notesMasterId r:id="rId33"/>
   </p:notesMasterIdLst>
   <p:sldIdLst>
     <p:sldId id="256" r:id="rId2"/>
@@ -32,6 +32,13 @@
     <p:sldId id="308" r:id="rId23"/>
     <p:sldId id="290" r:id="rId24"/>
     <p:sldId id="289" r:id="rId25"/>
+    <p:sldId id="318" r:id="rId26"/>
+    <p:sldId id="319" r:id="rId27"/>
+    <p:sldId id="321" r:id="rId28"/>
+    <p:sldId id="322" r:id="rId29"/>
+    <p:sldId id="325" r:id="rId30"/>
+    <p:sldId id="324" r:id="rId31"/>
+    <p:sldId id="326" r:id="rId32"/>
   </p:sldIdLst>
   <p:sldSz cx="12192000" cy="6858000"/>
   <p:notesSz cx="6858000" cy="9144000"/>
@@ -4086,7 +4093,7 @@
           <a:p>
             <a:fld id="{5D91BF4D-3201-F745-B932-E7F786B71255}" type="datetimeFigureOut">
               <a:rPr lang="en-US" smtClean="0"/>
-              <a:t>4/18/23</a:t>
+              <a:t>5/11/23</a:t>
             </a:fld>
             <a:endParaRPr lang="en-US"/>
           </a:p>
@@ -6920,6 +6927,510 @@
 </p:notes>
 </file>
 
+<file path=ppt/notesSlides/notesSlide22.xml><?xml version="1.0" encoding="utf-8"?>
+<p:notes xmlns:a="http://schemas.openxmlformats.org/drawingml/2006/main" xmlns:r="http://schemas.openxmlformats.org/officeDocument/2006/relationships" xmlns:p="http://schemas.openxmlformats.org/presentationml/2006/main">
+  <p:cSld>
+    <p:spTree>
+      <p:nvGrpSpPr>
+        <p:cNvPr id="1" name=""/>
+        <p:cNvGrpSpPr/>
+        <p:nvPr/>
+      </p:nvGrpSpPr>
+      <p:grpSpPr>
+        <a:xfrm>
+          <a:off x="0" y="0"/>
+          <a:ext cx="0" cy="0"/>
+          <a:chOff x="0" y="0"/>
+          <a:chExt cx="0" cy="0"/>
+        </a:xfrm>
+      </p:grpSpPr>
+      <p:sp>
+        <p:nvSpPr>
+          <p:cNvPr id="2" name="Slide Image Placeholder 1"/>
+          <p:cNvSpPr>
+            <a:spLocks noGrp="1" noRot="1" noChangeAspect="1"/>
+          </p:cNvSpPr>
+          <p:nvPr>
+            <p:ph type="sldImg"/>
+          </p:nvPr>
+        </p:nvSpPr>
+        <p:spPr/>
+      </p:sp>
+      <p:sp>
+        <p:nvSpPr>
+          <p:cNvPr id="3" name="Notes Placeholder 2"/>
+          <p:cNvSpPr>
+            <a:spLocks noGrp="1"/>
+          </p:cNvSpPr>
+          <p:nvPr>
+            <p:ph type="body" idx="1"/>
+          </p:nvPr>
+        </p:nvSpPr>
+        <p:spPr/>
+        <p:txBody>
+          <a:bodyPr/>
+          <a:lstStyle/>
+          <a:p>
+            <a:endParaRPr lang="en-US" dirty="0"/>
+          </a:p>
+        </p:txBody>
+      </p:sp>
+      <p:sp>
+        <p:nvSpPr>
+          <p:cNvPr id="4" name="Slide Number Placeholder 3"/>
+          <p:cNvSpPr>
+            <a:spLocks noGrp="1"/>
+          </p:cNvSpPr>
+          <p:nvPr>
+            <p:ph type="sldNum" sz="quarter" idx="5"/>
+          </p:nvPr>
+        </p:nvSpPr>
+        <p:spPr/>
+        <p:txBody>
+          <a:bodyPr/>
+          <a:lstStyle/>
+          <a:p>
+            <a:fld id="{5E3C3097-339F-D341-9AE2-47DB3DE0E34B}" type="slidenum">
+              <a:rPr lang="en-US" smtClean="0"/>
+              <a:t>25</a:t>
+            </a:fld>
+            <a:endParaRPr lang="en-US"/>
+          </a:p>
+        </p:txBody>
+      </p:sp>
+    </p:spTree>
+    <p:extLst>
+      <p:ext uri="{BB962C8B-B14F-4D97-AF65-F5344CB8AC3E}">
+        <p14:creationId xmlns:p14="http://schemas.microsoft.com/office/powerpoint/2010/main" val="3585033310"/>
+      </p:ext>
+    </p:extLst>
+  </p:cSld>
+  <p:clrMapOvr>
+    <a:masterClrMapping/>
+  </p:clrMapOvr>
+</p:notes>
+</file>
+
+<file path=ppt/notesSlides/notesSlide23.xml><?xml version="1.0" encoding="utf-8"?>
+<p:notes xmlns:a="http://schemas.openxmlformats.org/drawingml/2006/main" xmlns:r="http://schemas.openxmlformats.org/officeDocument/2006/relationships" xmlns:p="http://schemas.openxmlformats.org/presentationml/2006/main">
+  <p:cSld>
+    <p:spTree>
+      <p:nvGrpSpPr>
+        <p:cNvPr id="1" name=""/>
+        <p:cNvGrpSpPr/>
+        <p:nvPr/>
+      </p:nvGrpSpPr>
+      <p:grpSpPr>
+        <a:xfrm>
+          <a:off x="0" y="0"/>
+          <a:ext cx="0" cy="0"/>
+          <a:chOff x="0" y="0"/>
+          <a:chExt cx="0" cy="0"/>
+        </a:xfrm>
+      </p:grpSpPr>
+      <p:sp>
+        <p:nvSpPr>
+          <p:cNvPr id="2" name="Slide Image Placeholder 1"/>
+          <p:cNvSpPr>
+            <a:spLocks noGrp="1" noRot="1" noChangeAspect="1"/>
+          </p:cNvSpPr>
+          <p:nvPr>
+            <p:ph type="sldImg"/>
+          </p:nvPr>
+        </p:nvSpPr>
+        <p:spPr/>
+      </p:sp>
+      <p:sp>
+        <p:nvSpPr>
+          <p:cNvPr id="3" name="Notes Placeholder 2"/>
+          <p:cNvSpPr>
+            <a:spLocks noGrp="1"/>
+          </p:cNvSpPr>
+          <p:nvPr>
+            <p:ph type="body" idx="1"/>
+          </p:nvPr>
+        </p:nvSpPr>
+        <p:spPr/>
+        <p:txBody>
+          <a:bodyPr/>
+          <a:lstStyle/>
+          <a:p>
+            <a:endParaRPr lang="en-US" dirty="0"/>
+          </a:p>
+        </p:txBody>
+      </p:sp>
+      <p:sp>
+        <p:nvSpPr>
+          <p:cNvPr id="4" name="Slide Number Placeholder 3"/>
+          <p:cNvSpPr>
+            <a:spLocks noGrp="1"/>
+          </p:cNvSpPr>
+          <p:nvPr>
+            <p:ph type="sldNum" sz="quarter" idx="5"/>
+          </p:nvPr>
+        </p:nvSpPr>
+        <p:spPr/>
+        <p:txBody>
+          <a:bodyPr/>
+          <a:lstStyle/>
+          <a:p>
+            <a:fld id="{5E3C3097-339F-D341-9AE2-47DB3DE0E34B}" type="slidenum">
+              <a:rPr lang="en-US" smtClean="0"/>
+              <a:t>26</a:t>
+            </a:fld>
+            <a:endParaRPr lang="en-US"/>
+          </a:p>
+        </p:txBody>
+      </p:sp>
+    </p:spTree>
+    <p:extLst>
+      <p:ext uri="{BB962C8B-B14F-4D97-AF65-F5344CB8AC3E}">
+        <p14:creationId xmlns:p14="http://schemas.microsoft.com/office/powerpoint/2010/main" val="2766349677"/>
+      </p:ext>
+    </p:extLst>
+  </p:cSld>
+  <p:clrMapOvr>
+    <a:masterClrMapping/>
+  </p:clrMapOvr>
+</p:notes>
+</file>
+
+<file path=ppt/notesSlides/notesSlide24.xml><?xml version="1.0" encoding="utf-8"?>
+<p:notes xmlns:a="http://schemas.openxmlformats.org/drawingml/2006/main" xmlns:r="http://schemas.openxmlformats.org/officeDocument/2006/relationships" xmlns:p="http://schemas.openxmlformats.org/presentationml/2006/main">
+  <p:cSld>
+    <p:spTree>
+      <p:nvGrpSpPr>
+        <p:cNvPr id="1" name=""/>
+        <p:cNvGrpSpPr/>
+        <p:nvPr/>
+      </p:nvGrpSpPr>
+      <p:grpSpPr>
+        <a:xfrm>
+          <a:off x="0" y="0"/>
+          <a:ext cx="0" cy="0"/>
+          <a:chOff x="0" y="0"/>
+          <a:chExt cx="0" cy="0"/>
+        </a:xfrm>
+      </p:grpSpPr>
+      <p:sp>
+        <p:nvSpPr>
+          <p:cNvPr id="2" name="Slide Image Placeholder 1"/>
+          <p:cNvSpPr>
+            <a:spLocks noGrp="1" noRot="1" noChangeAspect="1"/>
+          </p:cNvSpPr>
+          <p:nvPr>
+            <p:ph type="sldImg"/>
+          </p:nvPr>
+        </p:nvSpPr>
+        <p:spPr/>
+      </p:sp>
+      <p:sp>
+        <p:nvSpPr>
+          <p:cNvPr id="3" name="Notes Placeholder 2"/>
+          <p:cNvSpPr>
+            <a:spLocks noGrp="1"/>
+          </p:cNvSpPr>
+          <p:nvPr>
+            <p:ph type="body" idx="1"/>
+          </p:nvPr>
+        </p:nvSpPr>
+        <p:spPr/>
+        <p:txBody>
+          <a:bodyPr/>
+          <a:lstStyle/>
+          <a:p>
+            <a:endParaRPr lang="en-US" dirty="0"/>
+          </a:p>
+        </p:txBody>
+      </p:sp>
+      <p:sp>
+        <p:nvSpPr>
+          <p:cNvPr id="4" name="Slide Number Placeholder 3"/>
+          <p:cNvSpPr>
+            <a:spLocks noGrp="1"/>
+          </p:cNvSpPr>
+          <p:nvPr>
+            <p:ph type="sldNum" sz="quarter" idx="5"/>
+          </p:nvPr>
+        </p:nvSpPr>
+        <p:spPr/>
+        <p:txBody>
+          <a:bodyPr/>
+          <a:lstStyle/>
+          <a:p>
+            <a:fld id="{5E3C3097-339F-D341-9AE2-47DB3DE0E34B}" type="slidenum">
+              <a:rPr lang="en-US" smtClean="0"/>
+              <a:t>27</a:t>
+            </a:fld>
+            <a:endParaRPr lang="en-US"/>
+          </a:p>
+        </p:txBody>
+      </p:sp>
+    </p:spTree>
+    <p:extLst>
+      <p:ext uri="{BB962C8B-B14F-4D97-AF65-F5344CB8AC3E}">
+        <p14:creationId xmlns:p14="http://schemas.microsoft.com/office/powerpoint/2010/main" val="724225446"/>
+      </p:ext>
+    </p:extLst>
+  </p:cSld>
+  <p:clrMapOvr>
+    <a:masterClrMapping/>
+  </p:clrMapOvr>
+</p:notes>
+</file>
+
+<file path=ppt/notesSlides/notesSlide25.xml><?xml version="1.0" encoding="utf-8"?>
+<p:notes xmlns:a="http://schemas.openxmlformats.org/drawingml/2006/main" xmlns:r="http://schemas.openxmlformats.org/officeDocument/2006/relationships" xmlns:p="http://schemas.openxmlformats.org/presentationml/2006/main">
+  <p:cSld>
+    <p:spTree>
+      <p:nvGrpSpPr>
+        <p:cNvPr id="1" name=""/>
+        <p:cNvGrpSpPr/>
+        <p:nvPr/>
+      </p:nvGrpSpPr>
+      <p:grpSpPr>
+        <a:xfrm>
+          <a:off x="0" y="0"/>
+          <a:ext cx="0" cy="0"/>
+          <a:chOff x="0" y="0"/>
+          <a:chExt cx="0" cy="0"/>
+        </a:xfrm>
+      </p:grpSpPr>
+      <p:sp>
+        <p:nvSpPr>
+          <p:cNvPr id="2" name="Slide Image Placeholder 1"/>
+          <p:cNvSpPr>
+            <a:spLocks noGrp="1" noRot="1" noChangeAspect="1"/>
+          </p:cNvSpPr>
+          <p:nvPr>
+            <p:ph type="sldImg"/>
+          </p:nvPr>
+        </p:nvSpPr>
+        <p:spPr/>
+      </p:sp>
+      <p:sp>
+        <p:nvSpPr>
+          <p:cNvPr id="3" name="Notes Placeholder 2"/>
+          <p:cNvSpPr>
+            <a:spLocks noGrp="1"/>
+          </p:cNvSpPr>
+          <p:nvPr>
+            <p:ph type="body" idx="1"/>
+          </p:nvPr>
+        </p:nvSpPr>
+        <p:spPr/>
+        <p:txBody>
+          <a:bodyPr/>
+          <a:lstStyle/>
+          <a:p>
+            <a:endParaRPr lang="en-US" dirty="0"/>
+          </a:p>
+        </p:txBody>
+      </p:sp>
+      <p:sp>
+        <p:nvSpPr>
+          <p:cNvPr id="4" name="Slide Number Placeholder 3"/>
+          <p:cNvSpPr>
+            <a:spLocks noGrp="1"/>
+          </p:cNvSpPr>
+          <p:nvPr>
+            <p:ph type="sldNum" sz="quarter" idx="5"/>
+          </p:nvPr>
+        </p:nvSpPr>
+        <p:spPr/>
+        <p:txBody>
+          <a:bodyPr/>
+          <a:lstStyle/>
+          <a:p>
+            <a:fld id="{5E3C3097-339F-D341-9AE2-47DB3DE0E34B}" type="slidenum">
+              <a:rPr lang="en-US" smtClean="0"/>
+              <a:t>28</a:t>
+            </a:fld>
+            <a:endParaRPr lang="en-US"/>
+          </a:p>
+        </p:txBody>
+      </p:sp>
+    </p:spTree>
+    <p:extLst>
+      <p:ext uri="{BB962C8B-B14F-4D97-AF65-F5344CB8AC3E}">
+        <p14:creationId xmlns:p14="http://schemas.microsoft.com/office/powerpoint/2010/main" val="538711350"/>
+      </p:ext>
+    </p:extLst>
+  </p:cSld>
+  <p:clrMapOvr>
+    <a:masterClrMapping/>
+  </p:clrMapOvr>
+</p:notes>
+</file>
+
+<file path=ppt/notesSlides/notesSlide26.xml><?xml version="1.0" encoding="utf-8"?>
+<p:notes xmlns:a="http://schemas.openxmlformats.org/drawingml/2006/main" xmlns:r="http://schemas.openxmlformats.org/officeDocument/2006/relationships" xmlns:p="http://schemas.openxmlformats.org/presentationml/2006/main">
+  <p:cSld>
+    <p:spTree>
+      <p:nvGrpSpPr>
+        <p:cNvPr id="1" name=""/>
+        <p:cNvGrpSpPr/>
+        <p:nvPr/>
+      </p:nvGrpSpPr>
+      <p:grpSpPr>
+        <a:xfrm>
+          <a:off x="0" y="0"/>
+          <a:ext cx="0" cy="0"/>
+          <a:chOff x="0" y="0"/>
+          <a:chExt cx="0" cy="0"/>
+        </a:xfrm>
+      </p:grpSpPr>
+      <p:sp>
+        <p:nvSpPr>
+          <p:cNvPr id="2" name="Slide Image Placeholder 1"/>
+          <p:cNvSpPr>
+            <a:spLocks noGrp="1" noRot="1" noChangeAspect="1"/>
+          </p:cNvSpPr>
+          <p:nvPr>
+            <p:ph type="sldImg"/>
+          </p:nvPr>
+        </p:nvSpPr>
+        <p:spPr/>
+      </p:sp>
+      <p:sp>
+        <p:nvSpPr>
+          <p:cNvPr id="3" name="Notes Placeholder 2"/>
+          <p:cNvSpPr>
+            <a:spLocks noGrp="1"/>
+          </p:cNvSpPr>
+          <p:nvPr>
+            <p:ph type="body" idx="1"/>
+          </p:nvPr>
+        </p:nvSpPr>
+        <p:spPr/>
+        <p:txBody>
+          <a:bodyPr/>
+          <a:lstStyle/>
+          <a:p>
+            <a:endParaRPr lang="en-US" dirty="0"/>
+          </a:p>
+        </p:txBody>
+      </p:sp>
+      <p:sp>
+        <p:nvSpPr>
+          <p:cNvPr id="4" name="Slide Number Placeholder 3"/>
+          <p:cNvSpPr>
+            <a:spLocks noGrp="1"/>
+          </p:cNvSpPr>
+          <p:nvPr>
+            <p:ph type="sldNum" sz="quarter" idx="5"/>
+          </p:nvPr>
+        </p:nvSpPr>
+        <p:spPr/>
+        <p:txBody>
+          <a:bodyPr/>
+          <a:lstStyle/>
+          <a:p>
+            <a:fld id="{5E3C3097-339F-D341-9AE2-47DB3DE0E34B}" type="slidenum">
+              <a:rPr lang="en-US" smtClean="0"/>
+              <a:t>29</a:t>
+            </a:fld>
+            <a:endParaRPr lang="en-US"/>
+          </a:p>
+        </p:txBody>
+      </p:sp>
+    </p:spTree>
+    <p:extLst>
+      <p:ext uri="{BB962C8B-B14F-4D97-AF65-F5344CB8AC3E}">
+        <p14:creationId xmlns:p14="http://schemas.microsoft.com/office/powerpoint/2010/main" val="1946830940"/>
+      </p:ext>
+    </p:extLst>
+  </p:cSld>
+  <p:clrMapOvr>
+    <a:masterClrMapping/>
+  </p:clrMapOvr>
+</p:notes>
+</file>
+
+<file path=ppt/notesSlides/notesSlide27.xml><?xml version="1.0" encoding="utf-8"?>
+<p:notes xmlns:a="http://schemas.openxmlformats.org/drawingml/2006/main" xmlns:r="http://schemas.openxmlformats.org/officeDocument/2006/relationships" xmlns:p="http://schemas.openxmlformats.org/presentationml/2006/main">
+  <p:cSld>
+    <p:spTree>
+      <p:nvGrpSpPr>
+        <p:cNvPr id="1" name=""/>
+        <p:cNvGrpSpPr/>
+        <p:nvPr/>
+      </p:nvGrpSpPr>
+      <p:grpSpPr>
+        <a:xfrm>
+          <a:off x="0" y="0"/>
+          <a:ext cx="0" cy="0"/>
+          <a:chOff x="0" y="0"/>
+          <a:chExt cx="0" cy="0"/>
+        </a:xfrm>
+      </p:grpSpPr>
+      <p:sp>
+        <p:nvSpPr>
+          <p:cNvPr id="2" name="Slide Image Placeholder 1"/>
+          <p:cNvSpPr>
+            <a:spLocks noGrp="1" noRot="1" noChangeAspect="1"/>
+          </p:cNvSpPr>
+          <p:nvPr>
+            <p:ph type="sldImg"/>
+          </p:nvPr>
+        </p:nvSpPr>
+        <p:spPr/>
+      </p:sp>
+      <p:sp>
+        <p:nvSpPr>
+          <p:cNvPr id="3" name="Notes Placeholder 2"/>
+          <p:cNvSpPr>
+            <a:spLocks noGrp="1"/>
+          </p:cNvSpPr>
+          <p:nvPr>
+            <p:ph type="body" idx="1"/>
+          </p:nvPr>
+        </p:nvSpPr>
+        <p:spPr/>
+        <p:txBody>
+          <a:bodyPr/>
+          <a:lstStyle/>
+          <a:p>
+            <a:endParaRPr lang="en-US" dirty="0"/>
+          </a:p>
+        </p:txBody>
+      </p:sp>
+      <p:sp>
+        <p:nvSpPr>
+          <p:cNvPr id="4" name="Slide Number Placeholder 3"/>
+          <p:cNvSpPr>
+            <a:spLocks noGrp="1"/>
+          </p:cNvSpPr>
+          <p:nvPr>
+            <p:ph type="sldNum" sz="quarter" idx="5"/>
+          </p:nvPr>
+        </p:nvSpPr>
+        <p:spPr/>
+        <p:txBody>
+          <a:bodyPr/>
+          <a:lstStyle/>
+          <a:p>
+            <a:fld id="{5E3C3097-339F-D341-9AE2-47DB3DE0E34B}" type="slidenum">
+              <a:rPr lang="en-US" smtClean="0"/>
+              <a:t>30</a:t>
+            </a:fld>
+            <a:endParaRPr lang="en-US"/>
+          </a:p>
+        </p:txBody>
+      </p:sp>
+    </p:spTree>
+    <p:extLst>
+      <p:ext uri="{BB962C8B-B14F-4D97-AF65-F5344CB8AC3E}">
+        <p14:creationId xmlns:p14="http://schemas.microsoft.com/office/powerpoint/2010/main" val="415904847"/>
+      </p:ext>
+    </p:extLst>
+  </p:cSld>
+  <p:clrMapOvr>
+    <a:masterClrMapping/>
+  </p:clrMapOvr>
+</p:notes>
+</file>
+
 <file path=ppt/notesSlides/notesSlide3.xml><?xml version="1.0" encoding="utf-8"?>
 <p:notes xmlns:a="http://schemas.openxmlformats.org/drawingml/2006/main" xmlns:r="http://schemas.openxmlformats.org/officeDocument/2006/relationships" xmlns:p="http://schemas.openxmlformats.org/presentationml/2006/main">
   <p:cSld>
@@ -7909,7 +8420,7 @@
           <a:p>
             <a:fld id="{4D82D62B-C5BC-9A48-B649-B612C2626DF0}" type="datetime2">
               <a:rPr lang="en-US" smtClean="0"/>
-              <a:t>Tuesday, April 18, 2023</a:t>
+              <a:t>Thursday, May 11, 2023</a:t>
             </a:fld>
             <a:endParaRPr lang="en-US" dirty="0"/>
           </a:p>
@@ -8112,7 +8623,7 @@
           <a:p>
             <a:fld id="{8C7BF22D-4351-7443-9203-BE328953BFC7}" type="datetime2">
               <a:rPr lang="en-US" smtClean="0"/>
-              <a:t>Tuesday, April 18, 2023</a:t>
+              <a:t>Thursday, May 11, 2023</a:t>
             </a:fld>
             <a:endParaRPr lang="en-US"/>
           </a:p>
@@ -8323,7 +8834,7 @@
           <a:p>
             <a:fld id="{9FDF6349-9520-004C-B410-2193F9372E49}" type="datetime2">
               <a:rPr lang="en-US" smtClean="0"/>
-              <a:t>Tuesday, April 18, 2023</a:t>
+              <a:t>Thursday, May 11, 2023</a:t>
             </a:fld>
             <a:endParaRPr lang="en-US"/>
           </a:p>
@@ -8524,7 +9035,7 @@
           <a:p>
             <a:fld id="{E9A10DC3-F6B5-014A-A9AD-0D47C6506BAB}" type="datetime2">
               <a:rPr lang="en-US" smtClean="0"/>
-              <a:t>Tuesday, April 18, 2023</a:t>
+              <a:t>Thursday, May 11, 2023</a:t>
             </a:fld>
             <a:endParaRPr lang="en-US" dirty="0"/>
           </a:p>
@@ -8804,7 +9315,7 @@
           <a:p>
             <a:fld id="{A049C287-8CF4-DC48-88B8-6E35669697EC}" type="datetime2">
               <a:rPr lang="en-US" smtClean="0"/>
-              <a:t>Tuesday, April 18, 2023</a:t>
+              <a:t>Thursday, May 11, 2023</a:t>
             </a:fld>
             <a:endParaRPr lang="en-US"/>
           </a:p>
@@ -9074,7 +9585,7 @@
           <a:p>
             <a:fld id="{ADEB5C39-7764-3744-BF89-1BA0C95D9B94}" type="datetime2">
               <a:rPr lang="en-US" smtClean="0"/>
-              <a:t>Tuesday, April 18, 2023</a:t>
+              <a:t>Thursday, May 11, 2023</a:t>
             </a:fld>
             <a:endParaRPr lang="en-US"/>
           </a:p>
@@ -9489,7 +10000,7 @@
           <a:p>
             <a:fld id="{4BAB7099-C23E-1745-AF03-0B0C40F6AA6C}" type="datetime2">
               <a:rPr lang="en-US" smtClean="0"/>
-              <a:t>Tuesday, April 18, 2023</a:t>
+              <a:t>Thursday, May 11, 2023</a:t>
             </a:fld>
             <a:endParaRPr lang="en-US"/>
           </a:p>
@@ -9633,7 +10144,7 @@
           <a:p>
             <a:fld id="{52B883A0-F701-0F49-9D67-42F97F0F4C65}" type="datetime2">
               <a:rPr lang="en-US" smtClean="0"/>
-              <a:t>Tuesday, April 18, 2023</a:t>
+              <a:t>Thursday, May 11, 2023</a:t>
             </a:fld>
             <a:endParaRPr lang="en-US"/>
           </a:p>
@@ -9749,7 +10260,7 @@
           <a:p>
             <a:fld id="{E6923127-F9F8-8B4E-9CEB-95BF7FFEA85F}" type="datetime2">
               <a:rPr lang="en-US" smtClean="0"/>
-              <a:t>Tuesday, April 18, 2023</a:t>
+              <a:t>Thursday, May 11, 2023</a:t>
             </a:fld>
             <a:endParaRPr lang="en-US"/>
           </a:p>
@@ -10063,7 +10574,7 @@
           <a:p>
             <a:fld id="{24AFEB34-53E9-8F42-9ED2-04274EE70207}" type="datetime2">
               <a:rPr lang="en-US" smtClean="0"/>
-              <a:t>Tuesday, April 18, 2023</a:t>
+              <a:t>Thursday, May 11, 2023</a:t>
             </a:fld>
             <a:endParaRPr lang="en-US"/>
           </a:p>
@@ -10354,7 +10865,7 @@
           <a:p>
             <a:fld id="{78864A2C-3282-224A-8A3B-B1B48911DC1D}" type="datetime2">
               <a:rPr lang="en-US" smtClean="0"/>
-              <a:t>Tuesday, April 18, 2023</a:t>
+              <a:t>Thursday, May 11, 2023</a:t>
             </a:fld>
             <a:endParaRPr lang="en-US"/>
           </a:p>
@@ -10598,7 +11109,7 @@
           <a:p>
             <a:fld id="{6A398F71-50EE-C442-9A03-D3A19758747B}" type="datetime2">
               <a:rPr lang="en-US" smtClean="0"/>
-              <a:t>Tuesday, April 18, 2023</a:t>
+              <a:t>Thursday, May 11, 2023</a:t>
             </a:fld>
             <a:endParaRPr lang="en-US" dirty="0"/>
           </a:p>
@@ -27248,6 +27759,2887 @@
 </p:sld>
 </file>
 
+<file path=ppt/slides/slide25.xml><?xml version="1.0" encoding="utf-8"?>
+<p:sld xmlns:a="http://schemas.openxmlformats.org/drawingml/2006/main" xmlns:r="http://schemas.openxmlformats.org/officeDocument/2006/relationships" xmlns:p="http://schemas.openxmlformats.org/presentationml/2006/main">
+  <p:cSld>
+    <p:spTree>
+      <p:nvGrpSpPr>
+        <p:cNvPr id="1" name=""/>
+        <p:cNvGrpSpPr/>
+        <p:nvPr/>
+      </p:nvGrpSpPr>
+      <p:grpSpPr>
+        <a:xfrm>
+          <a:off x="0" y="0"/>
+          <a:ext cx="0" cy="0"/>
+          <a:chOff x="0" y="0"/>
+          <a:chExt cx="0" cy="0"/>
+        </a:xfrm>
+      </p:grpSpPr>
+      <p:sp>
+        <p:nvSpPr>
+          <p:cNvPr id="4" name="Slide Number Placeholder 3">
+            <a:extLst>
+              <a:ext uri="{FF2B5EF4-FFF2-40B4-BE49-F238E27FC236}">
+                <a16:creationId xmlns:a16="http://schemas.microsoft.com/office/drawing/2014/main" id="{4383861C-DDFF-F94F-B844-7188E07B1951}"/>
+              </a:ext>
+            </a:extLst>
+          </p:cNvPr>
+          <p:cNvSpPr>
+            <a:spLocks noGrp="1"/>
+          </p:cNvSpPr>
+          <p:nvPr>
+            <p:ph type="sldNum" sz="quarter" idx="12"/>
+          </p:nvPr>
+        </p:nvSpPr>
+        <p:spPr/>
+        <p:txBody>
+          <a:bodyPr/>
+          <a:lstStyle/>
+          <a:p>
+            <a:fld id="{1621B6DD-29C1-4FEA-923F-71EA1347694C}" type="slidenum">
+              <a:rPr lang="en-US" smtClean="0"/>
+              <a:t>24</a:t>
+            </a:fld>
+            <a:endParaRPr lang="en-US"/>
+          </a:p>
+        </p:txBody>
+      </p:sp>
+      <p:sp>
+        <p:nvSpPr>
+          <p:cNvPr id="6" name="Title 1">
+            <a:extLst>
+              <a:ext uri="{FF2B5EF4-FFF2-40B4-BE49-F238E27FC236}">
+                <a16:creationId xmlns:a16="http://schemas.microsoft.com/office/drawing/2014/main" id="{8BB2DFB4-E4EC-CC46-BF2B-90B0CB50A619}"/>
+              </a:ext>
+            </a:extLst>
+          </p:cNvPr>
+          <p:cNvSpPr txBox="1">
+            <a:spLocks/>
+          </p:cNvSpPr>
+          <p:nvPr/>
+        </p:nvSpPr>
+        <p:spPr>
+          <a:xfrm>
+            <a:off x="720000" y="619200"/>
+            <a:ext cx="10728322" cy="666675"/>
+          </a:xfrm>
+          <a:prstGeom prst="rect">
+            <a:avLst/>
+          </a:prstGeom>
+        </p:spPr>
+        <p:txBody>
+          <a:bodyPr vert="horz" lIns="91440" tIns="45720" rIns="91440" bIns="45720" rtlCol="0" anchor="ctr">
+            <a:normAutofit fontScale="97500" lnSpcReduction="10000"/>
+          </a:bodyPr>
+          <a:lstStyle>
+            <a:lvl1pPr algn="l" defTabSz="914400" rtl="0" eaLnBrk="1" latinLnBrk="0" hangingPunct="1">
+              <a:lnSpc>
+                <a:spcPct val="90000"/>
+              </a:lnSpc>
+              <a:spcBef>
+                <a:spcPct val="0"/>
+              </a:spcBef>
+              <a:buNone/>
+              <a:defRPr sz="4400" kern="1200">
+                <a:solidFill>
+                  <a:schemeClr val="tx1"/>
+                </a:solidFill>
+                <a:latin typeface="+mj-lt"/>
+                <a:ea typeface="+mj-ea"/>
+                <a:cs typeface="+mj-cs"/>
+              </a:defRPr>
+            </a:lvl1pPr>
+          </a:lstStyle>
+          <a:p>
+            <a:r>
+              <a:rPr lang="en-US" sz="4400" b="1" dirty="0">
+                <a:latin typeface="Times New Roman" panose="02020603050405020304" pitchFamily="18" charset="0"/>
+                <a:cs typeface="Times New Roman" panose="02020603050405020304" pitchFamily="18" charset="0"/>
+              </a:rPr>
+              <a:t>Updates 04/12</a:t>
+            </a:r>
+            <a:endParaRPr lang="en-US" b="1" dirty="0">
+              <a:latin typeface="Times New Roman" panose="02020603050405020304" pitchFamily="18" charset="0"/>
+              <a:cs typeface="Times New Roman" panose="02020603050405020304" pitchFamily="18" charset="0"/>
+            </a:endParaRPr>
+          </a:p>
+        </p:txBody>
+      </p:sp>
+    </p:spTree>
+    <p:extLst>
+      <p:ext uri="{BB962C8B-B14F-4D97-AF65-F5344CB8AC3E}">
+        <p14:creationId xmlns:p14="http://schemas.microsoft.com/office/powerpoint/2010/main" val="2813102204"/>
+      </p:ext>
+    </p:extLst>
+  </p:cSld>
+  <p:clrMapOvr>
+    <a:masterClrMapping/>
+  </p:clrMapOvr>
+</p:sld>
+</file>
+
+<file path=ppt/slides/slide26.xml><?xml version="1.0" encoding="utf-8"?>
+<p:sld xmlns:a="http://schemas.openxmlformats.org/drawingml/2006/main" xmlns:r="http://schemas.openxmlformats.org/officeDocument/2006/relationships" xmlns:p="http://schemas.openxmlformats.org/presentationml/2006/main">
+  <p:cSld>
+    <p:spTree>
+      <p:nvGrpSpPr>
+        <p:cNvPr id="1" name=""/>
+        <p:cNvGrpSpPr/>
+        <p:nvPr/>
+      </p:nvGrpSpPr>
+      <p:grpSpPr>
+        <a:xfrm>
+          <a:off x="0" y="0"/>
+          <a:ext cx="0" cy="0"/>
+          <a:chOff x="0" y="0"/>
+          <a:chExt cx="0" cy="0"/>
+        </a:xfrm>
+      </p:grpSpPr>
+      <p:sp>
+        <p:nvSpPr>
+          <p:cNvPr id="4" name="Slide Number Placeholder 3">
+            <a:extLst>
+              <a:ext uri="{FF2B5EF4-FFF2-40B4-BE49-F238E27FC236}">
+                <a16:creationId xmlns:a16="http://schemas.microsoft.com/office/drawing/2014/main" id="{4383861C-DDFF-F94F-B844-7188E07B1951}"/>
+              </a:ext>
+            </a:extLst>
+          </p:cNvPr>
+          <p:cNvSpPr>
+            <a:spLocks noGrp="1"/>
+          </p:cNvSpPr>
+          <p:nvPr>
+            <p:ph type="sldNum" sz="quarter" idx="12"/>
+          </p:nvPr>
+        </p:nvSpPr>
+        <p:spPr/>
+        <p:txBody>
+          <a:bodyPr/>
+          <a:lstStyle/>
+          <a:p>
+            <a:fld id="{1621B6DD-29C1-4FEA-923F-71EA1347694C}" type="slidenum">
+              <a:rPr lang="en-US" smtClean="0"/>
+              <a:t>25</a:t>
+            </a:fld>
+            <a:endParaRPr lang="en-US"/>
+          </a:p>
+        </p:txBody>
+      </p:sp>
+      <p:sp>
+        <p:nvSpPr>
+          <p:cNvPr id="6" name="Title 1">
+            <a:extLst>
+              <a:ext uri="{FF2B5EF4-FFF2-40B4-BE49-F238E27FC236}">
+                <a16:creationId xmlns:a16="http://schemas.microsoft.com/office/drawing/2014/main" id="{8BB2DFB4-E4EC-CC46-BF2B-90B0CB50A619}"/>
+              </a:ext>
+            </a:extLst>
+          </p:cNvPr>
+          <p:cNvSpPr txBox="1">
+            <a:spLocks/>
+          </p:cNvSpPr>
+          <p:nvPr/>
+        </p:nvSpPr>
+        <p:spPr>
+          <a:xfrm>
+            <a:off x="720000" y="619200"/>
+            <a:ext cx="10728322" cy="666675"/>
+          </a:xfrm>
+          <a:prstGeom prst="rect">
+            <a:avLst/>
+          </a:prstGeom>
+        </p:spPr>
+        <p:txBody>
+          <a:bodyPr vert="horz" lIns="91440" tIns="45720" rIns="91440" bIns="45720" rtlCol="0" anchor="ctr">
+            <a:normAutofit fontScale="97500" lnSpcReduction="10000"/>
+          </a:bodyPr>
+          <a:lstStyle>
+            <a:lvl1pPr algn="l" defTabSz="914400" rtl="0" eaLnBrk="1" latinLnBrk="0" hangingPunct="1">
+              <a:lnSpc>
+                <a:spcPct val="90000"/>
+              </a:lnSpc>
+              <a:spcBef>
+                <a:spcPct val="0"/>
+              </a:spcBef>
+              <a:buNone/>
+              <a:defRPr sz="4400" kern="1200">
+                <a:solidFill>
+                  <a:schemeClr val="tx1"/>
+                </a:solidFill>
+                <a:latin typeface="+mj-lt"/>
+                <a:ea typeface="+mj-ea"/>
+                <a:cs typeface="+mj-cs"/>
+              </a:defRPr>
+            </a:lvl1pPr>
+          </a:lstStyle>
+          <a:p>
+            <a:r>
+              <a:rPr lang="en-US" sz="4400" b="1" dirty="0">
+                <a:latin typeface="Times New Roman" panose="02020603050405020304" pitchFamily="18" charset="0"/>
+                <a:cs typeface="Times New Roman" panose="02020603050405020304" pitchFamily="18" charset="0"/>
+              </a:rPr>
+              <a:t>Including </a:t>
+            </a:r>
+            <a:r>
+              <a:rPr lang="en-US" sz="4400" b="1" dirty="0" err="1">
+                <a:latin typeface="Times New Roman" panose="02020603050405020304" pitchFamily="18" charset="0"/>
+                <a:cs typeface="Times New Roman" panose="02020603050405020304" pitchFamily="18" charset="0"/>
+              </a:rPr>
+              <a:t>SignalP</a:t>
+            </a:r>
+            <a:r>
+              <a:rPr lang="en-US" sz="4400" b="1" dirty="0">
+                <a:latin typeface="Times New Roman" panose="02020603050405020304" pitchFamily="18" charset="0"/>
+                <a:cs typeface="Times New Roman" panose="02020603050405020304" pitchFamily="18" charset="0"/>
+              </a:rPr>
+              <a:t> prediction into TP list</a:t>
+            </a:r>
+            <a:endParaRPr lang="en-US" b="1" dirty="0">
+              <a:latin typeface="Times New Roman" panose="02020603050405020304" pitchFamily="18" charset="0"/>
+              <a:cs typeface="Times New Roman" panose="02020603050405020304" pitchFamily="18" charset="0"/>
+            </a:endParaRPr>
+          </a:p>
+        </p:txBody>
+      </p:sp>
+      <p:sp>
+        <p:nvSpPr>
+          <p:cNvPr id="5" name="Content Placeholder 2">
+            <a:extLst>
+              <a:ext uri="{FF2B5EF4-FFF2-40B4-BE49-F238E27FC236}">
+                <a16:creationId xmlns:a16="http://schemas.microsoft.com/office/drawing/2014/main" id="{D334BA8F-7D11-7C46-92B4-623B02C91ADB}"/>
+              </a:ext>
+            </a:extLst>
+          </p:cNvPr>
+          <p:cNvSpPr>
+            <a:spLocks noGrp="1"/>
+          </p:cNvSpPr>
+          <p:nvPr>
+            <p:ph idx="1"/>
+          </p:nvPr>
+        </p:nvSpPr>
+        <p:spPr>
+          <a:xfrm>
+            <a:off x="1106545" y="1764307"/>
+            <a:ext cx="9978909" cy="3864074"/>
+          </a:xfrm>
+        </p:spPr>
+        <p:txBody>
+          <a:bodyPr>
+            <a:normAutofit/>
+          </a:bodyPr>
+          <a:lstStyle/>
+          <a:p>
+            <a:pPr>
+              <a:lnSpc>
+                <a:spcPct val="120000"/>
+              </a:lnSpc>
+              <a:buClr>
+                <a:schemeClr val="tx1"/>
+              </a:buClr>
+              <a:defRPr/>
+            </a:pPr>
+            <a:r>
+              <a:rPr lang="en-US" sz="2000" i="0" spc="20" dirty="0">
+                <a:solidFill>
+                  <a:srgbClr val="000000"/>
+                </a:solidFill>
+                <a:latin typeface="Segoe UI" panose="020B0502040204020203" pitchFamily="34" charset="0"/>
+                <a:cs typeface="Segoe UI" panose="020B0502040204020203" pitchFamily="34" charset="0"/>
+              </a:rPr>
+              <a:t>Corey shared </a:t>
+            </a:r>
+            <a:r>
+              <a:rPr lang="en-US" sz="2000" spc="20" dirty="0" err="1">
+                <a:solidFill>
+                  <a:srgbClr val="000000"/>
+                </a:solidFill>
+                <a:latin typeface="Segoe UI" panose="020B0502040204020203" pitchFamily="34" charset="0"/>
+                <a:cs typeface="Segoe UI" panose="020B0502040204020203" pitchFamily="34" charset="0"/>
+              </a:rPr>
+              <a:t>SignalP</a:t>
+            </a:r>
+            <a:r>
+              <a:rPr lang="en-US" sz="2000" spc="20" dirty="0">
+                <a:solidFill>
+                  <a:srgbClr val="000000"/>
+                </a:solidFill>
+                <a:latin typeface="Segoe UI" panose="020B0502040204020203" pitchFamily="34" charset="0"/>
+                <a:cs typeface="Segoe UI" panose="020B0502040204020203" pitchFamily="34" charset="0"/>
+              </a:rPr>
+              <a:t> prediction list: </a:t>
+            </a:r>
+            <a:r>
+              <a:rPr lang="en-US" sz="2000" b="1" spc="20" dirty="0" err="1">
+                <a:solidFill>
+                  <a:srgbClr val="000000"/>
+                </a:solidFill>
+                <a:latin typeface="Segoe UI" panose="020B0502040204020203" pitchFamily="34" charset="0"/>
+                <a:cs typeface="Segoe UI" panose="020B0502040204020203" pitchFamily="34" charset="0"/>
+              </a:rPr>
+              <a:t>Secretion_Prediction_Resource.csv</a:t>
+            </a:r>
+            <a:endParaRPr lang="en-US" sz="2000" b="1" spc="20" dirty="0">
+              <a:solidFill>
+                <a:srgbClr val="000000"/>
+              </a:solidFill>
+              <a:latin typeface="Segoe UI" panose="020B0502040204020203" pitchFamily="34" charset="0"/>
+              <a:cs typeface="Segoe UI" panose="020B0502040204020203" pitchFamily="34" charset="0"/>
+            </a:endParaRPr>
+          </a:p>
+          <a:p>
+            <a:pPr marL="0" marR="0" algn="l">
+              <a:spcBef>
+                <a:spcPts val="0"/>
+              </a:spcBef>
+              <a:spcAft>
+                <a:spcPts val="0"/>
+              </a:spcAft>
+            </a:pPr>
+            <a:r>
+              <a:rPr lang="en-US" sz="2000" b="0" i="0" u="none" strike="noStrike" dirty="0">
+                <a:solidFill>
+                  <a:srgbClr val="000000"/>
+                </a:solidFill>
+                <a:effectLst/>
+                <a:latin typeface="Segoe UI" panose="020B0502040204020203" pitchFamily="34" charset="0"/>
+                <a:cs typeface="Segoe UI" panose="020B0502040204020203" pitchFamily="34" charset="0"/>
+              </a:rPr>
+              <a:t>For each </a:t>
+            </a:r>
+            <a:r>
+              <a:rPr lang="en-US" sz="2000" b="0" i="0" u="none" strike="noStrike" dirty="0" err="1">
+                <a:solidFill>
+                  <a:srgbClr val="000000"/>
+                </a:solidFill>
+                <a:effectLst/>
+                <a:latin typeface="Segoe UI" panose="020B0502040204020203" pitchFamily="34" charset="0"/>
+                <a:cs typeface="Segoe UI" panose="020B0502040204020203" pitchFamily="34" charset="0"/>
+              </a:rPr>
+              <a:t>uniprot</a:t>
+            </a:r>
+            <a:r>
+              <a:rPr lang="en-US" sz="2000" b="0" i="0" u="none" strike="noStrike" dirty="0">
+                <a:solidFill>
+                  <a:srgbClr val="000000"/>
+                </a:solidFill>
+                <a:effectLst/>
+                <a:latin typeface="Segoe UI" panose="020B0502040204020203" pitchFamily="34" charset="0"/>
+                <a:cs typeface="Segoe UI" panose="020B0502040204020203" pitchFamily="34" charset="0"/>
+              </a:rPr>
+              <a:t> id we check if the Subcellular location has any of these terms: </a:t>
+            </a:r>
+          </a:p>
+          <a:p>
+            <a:pPr marL="457200" lvl="1">
+              <a:spcBef>
+                <a:spcPts val="0"/>
+              </a:spcBef>
+            </a:pPr>
+            <a:r>
+              <a:rPr lang="en-US" sz="2000" b="0" i="0" u="none" strike="noStrike" dirty="0">
+                <a:solidFill>
+                  <a:srgbClr val="000000"/>
+                </a:solidFill>
+                <a:effectLst/>
+                <a:latin typeface="Segoe UI" panose="020B0502040204020203" pitchFamily="34" charset="0"/>
+                <a:cs typeface="Segoe UI" panose="020B0502040204020203" pitchFamily="34" charset="0"/>
+              </a:rPr>
+              <a:t>"Endoplasmic Reticulum", </a:t>
+            </a:r>
+          </a:p>
+          <a:p>
+            <a:pPr marL="457200" lvl="1">
+              <a:spcBef>
+                <a:spcPts val="0"/>
+              </a:spcBef>
+            </a:pPr>
+            <a:r>
+              <a:rPr lang="en-US" sz="2000" b="0" i="0" u="none" strike="noStrike" dirty="0">
+                <a:solidFill>
+                  <a:srgbClr val="000000"/>
+                </a:solidFill>
+                <a:effectLst/>
+                <a:latin typeface="Segoe UI" panose="020B0502040204020203" pitchFamily="34" charset="0"/>
+                <a:cs typeface="Segoe UI" panose="020B0502040204020203" pitchFamily="34" charset="0"/>
+              </a:rPr>
+              <a:t>"Rough endoplasmic reticulum", </a:t>
+            </a:r>
+          </a:p>
+          <a:p>
+            <a:pPr marL="457200" lvl="1">
+              <a:spcBef>
+                <a:spcPts val="0"/>
+              </a:spcBef>
+            </a:pPr>
+            <a:endParaRPr lang="en-US" sz="2000" b="0" i="0" u="none" strike="noStrike" dirty="0">
+              <a:solidFill>
+                <a:srgbClr val="000000"/>
+              </a:solidFill>
+              <a:effectLst/>
+              <a:latin typeface="Segoe UI" panose="020B0502040204020203" pitchFamily="34" charset="0"/>
+              <a:cs typeface="Segoe UI" panose="020B0502040204020203" pitchFamily="34" charset="0"/>
+            </a:endParaRPr>
+          </a:p>
+          <a:p>
+            <a:pPr marL="0" marR="0" algn="l">
+              <a:spcBef>
+                <a:spcPts val="0"/>
+              </a:spcBef>
+              <a:spcAft>
+                <a:spcPts val="0"/>
+              </a:spcAft>
+            </a:pPr>
+            <a:r>
+              <a:rPr lang="en-US" sz="2000" b="0" i="0" u="none" strike="noStrike" dirty="0">
+                <a:solidFill>
+                  <a:srgbClr val="000000"/>
+                </a:solidFill>
+                <a:effectLst/>
+                <a:latin typeface="Segoe UI" panose="020B0502040204020203" pitchFamily="34" charset="0"/>
+                <a:cs typeface="Segoe UI" panose="020B0502040204020203" pitchFamily="34" charset="0"/>
+              </a:rPr>
+              <a:t>If yes, then check if the </a:t>
+            </a:r>
+            <a:r>
+              <a:rPr lang="en-US" sz="2000" b="1" i="0" u="none" strike="noStrike" dirty="0">
+                <a:solidFill>
+                  <a:srgbClr val="000000"/>
+                </a:solidFill>
+                <a:effectLst/>
+                <a:latin typeface="Segoe UI" panose="020B0502040204020203" pitchFamily="34" charset="0"/>
+                <a:cs typeface="Segoe UI" panose="020B0502040204020203" pitchFamily="34" charset="0"/>
+              </a:rPr>
+              <a:t>score column </a:t>
+            </a:r>
+            <a:r>
+              <a:rPr lang="en-US" sz="2000" b="0" i="0" u="none" strike="noStrike" dirty="0">
+                <a:solidFill>
+                  <a:srgbClr val="000000"/>
+                </a:solidFill>
+                <a:effectLst/>
+                <a:latin typeface="Segoe UI" panose="020B0502040204020203" pitchFamily="34" charset="0"/>
+                <a:cs typeface="Segoe UI" panose="020B0502040204020203" pitchFamily="34" charset="0"/>
+              </a:rPr>
+              <a:t>has a value &gt;= 0.7 but the </a:t>
+            </a:r>
+            <a:r>
+              <a:rPr lang="en-US" sz="2000" b="1" i="0" u="none" strike="noStrike" dirty="0" err="1">
+                <a:solidFill>
+                  <a:srgbClr val="000000"/>
+                </a:solidFill>
+                <a:effectLst/>
+                <a:latin typeface="Segoe UI" panose="020B0502040204020203" pitchFamily="34" charset="0"/>
+                <a:cs typeface="Segoe UI" panose="020B0502040204020203" pitchFamily="34" charset="0"/>
+              </a:rPr>
+              <a:t>UPS_score</a:t>
+            </a:r>
+            <a:r>
+              <a:rPr lang="en-US" sz="2000" b="1" i="0" u="none" strike="noStrike" dirty="0">
+                <a:solidFill>
+                  <a:srgbClr val="000000"/>
+                </a:solidFill>
+                <a:effectLst/>
+                <a:latin typeface="Segoe UI" panose="020B0502040204020203" pitchFamily="34" charset="0"/>
+                <a:cs typeface="Segoe UI" panose="020B0502040204020203" pitchFamily="34" charset="0"/>
+              </a:rPr>
+              <a:t> </a:t>
+            </a:r>
+            <a:r>
+              <a:rPr lang="en-US" sz="2000" b="0" i="0" u="none" strike="noStrike" dirty="0">
+                <a:solidFill>
+                  <a:srgbClr val="000000"/>
+                </a:solidFill>
+                <a:effectLst/>
+                <a:latin typeface="Segoe UI" panose="020B0502040204020203" pitchFamily="34" charset="0"/>
+                <a:cs typeface="Segoe UI" panose="020B0502040204020203" pitchFamily="34" charset="0"/>
+              </a:rPr>
+              <a:t>column value is 0</a:t>
+            </a:r>
+          </a:p>
+          <a:p>
+            <a:pPr marL="0" marR="0" indent="0" algn="l">
+              <a:spcBef>
+                <a:spcPts val="0"/>
+              </a:spcBef>
+              <a:spcAft>
+                <a:spcPts val="0"/>
+              </a:spcAft>
+              <a:buNone/>
+            </a:pPr>
+            <a:endParaRPr lang="en-US" sz="2000" dirty="0">
+              <a:solidFill>
+                <a:srgbClr val="000000"/>
+              </a:solidFill>
+              <a:latin typeface="Segoe UI" panose="020B0502040204020203" pitchFamily="34" charset="0"/>
+              <a:cs typeface="Segoe UI" panose="020B0502040204020203" pitchFamily="34" charset="0"/>
+            </a:endParaRPr>
+          </a:p>
+          <a:p>
+            <a:pPr marL="0" marR="0" indent="0" algn="l">
+              <a:spcBef>
+                <a:spcPts val="0"/>
+              </a:spcBef>
+              <a:spcAft>
+                <a:spcPts val="0"/>
+              </a:spcAft>
+              <a:buNone/>
+            </a:pPr>
+            <a:r>
+              <a:rPr lang="en-US" sz="1400" b="0" u="none" strike="noStrike" dirty="0">
+                <a:solidFill>
+                  <a:srgbClr val="000000"/>
+                </a:solidFill>
+                <a:effectLst/>
+                <a:latin typeface="Calibri" panose="020F0502020204030204" pitchFamily="34" charset="0"/>
+              </a:rPr>
+              <a:t>Note from Corey: </a:t>
+            </a:r>
+            <a:r>
+              <a:rPr lang="en-US" sz="1400" b="0" i="1" u="none" strike="noStrike" dirty="0">
+                <a:solidFill>
+                  <a:srgbClr val="000000"/>
+                </a:solidFill>
+                <a:effectLst/>
+                <a:latin typeface="Calibri" panose="020F0502020204030204" pitchFamily="34" charset="0"/>
+              </a:rPr>
+              <a:t>The “score” column represents the likelihood of classical secretion, while the “</a:t>
+            </a:r>
+            <a:r>
+              <a:rPr lang="en-US" sz="1400" b="0" i="1" u="none" strike="noStrike" dirty="0" err="1">
+                <a:solidFill>
+                  <a:srgbClr val="000000"/>
+                </a:solidFill>
+                <a:effectLst/>
+                <a:latin typeface="Calibri" panose="020F0502020204030204" pitchFamily="34" charset="0"/>
+              </a:rPr>
+              <a:t>UPS_score</a:t>
+            </a:r>
+            <a:r>
+              <a:rPr lang="en-US" sz="1400" b="0" i="1" u="none" strike="noStrike" dirty="0">
+                <a:solidFill>
+                  <a:srgbClr val="000000"/>
+                </a:solidFill>
+                <a:effectLst/>
+                <a:latin typeface="Calibri" panose="020F0502020204030204" pitchFamily="34" charset="0"/>
+              </a:rPr>
+              <a:t>” is the likelihood of unclassical secretion. Because we expect to be tagging classically secreted proteins, I would actually </a:t>
+            </a:r>
+            <a:r>
+              <a:rPr lang="en-US" sz="1400" b="1" i="1" u="none" strike="noStrike" dirty="0">
+                <a:solidFill>
+                  <a:srgbClr val="000000"/>
+                </a:solidFill>
+                <a:effectLst/>
+                <a:latin typeface="Calibri" panose="020F0502020204030204" pitchFamily="34" charset="0"/>
+              </a:rPr>
+              <a:t>exclude</a:t>
+            </a:r>
+            <a:r>
+              <a:rPr lang="en-US" sz="1400" b="0" i="1" u="none" strike="noStrike" dirty="0">
+                <a:solidFill>
+                  <a:srgbClr val="000000"/>
+                </a:solidFill>
+                <a:effectLst/>
+                <a:latin typeface="Calibri" panose="020F0502020204030204" pitchFamily="34" charset="0"/>
+              </a:rPr>
+              <a:t> those proteins from the TP list that have a high </a:t>
+            </a:r>
+            <a:r>
+              <a:rPr lang="en-US" sz="1400" b="0" i="1" u="none" strike="noStrike" dirty="0" err="1">
+                <a:solidFill>
+                  <a:srgbClr val="000000"/>
+                </a:solidFill>
+                <a:effectLst/>
+                <a:latin typeface="Calibri" panose="020F0502020204030204" pitchFamily="34" charset="0"/>
+              </a:rPr>
+              <a:t>UPS_score</a:t>
+            </a:r>
+            <a:r>
+              <a:rPr lang="en-US" sz="1400" b="0" i="1" u="none" strike="noStrike" dirty="0">
+                <a:solidFill>
+                  <a:srgbClr val="000000"/>
+                </a:solidFill>
+                <a:effectLst/>
+                <a:latin typeface="Calibri" panose="020F0502020204030204" pitchFamily="34" charset="0"/>
+              </a:rPr>
+              <a:t>, as they may not be trafficked through the ER for secretion.</a:t>
+            </a:r>
+            <a:endParaRPr lang="en-US" sz="2000" b="0" i="1" u="none" strike="noStrike" dirty="0">
+              <a:solidFill>
+                <a:srgbClr val="000000"/>
+              </a:solidFill>
+              <a:effectLst/>
+              <a:latin typeface="Segoe UI" panose="020B0502040204020203" pitchFamily="34" charset="0"/>
+              <a:cs typeface="Segoe UI" panose="020B0502040204020203" pitchFamily="34" charset="0"/>
+            </a:endParaRPr>
+          </a:p>
+          <a:p>
+            <a:pPr marL="0" marR="0" indent="0" algn="l">
+              <a:spcBef>
+                <a:spcPts val="0"/>
+              </a:spcBef>
+              <a:spcAft>
+                <a:spcPts val="0"/>
+              </a:spcAft>
+              <a:buNone/>
+            </a:pPr>
+            <a:endParaRPr lang="en-US" sz="2000" b="0" i="0" u="none" strike="noStrike" dirty="0">
+              <a:solidFill>
+                <a:srgbClr val="000000"/>
+              </a:solidFill>
+              <a:effectLst/>
+              <a:latin typeface="Segoe UI" panose="020B0502040204020203" pitchFamily="34" charset="0"/>
+              <a:cs typeface="Segoe UI" panose="020B0502040204020203" pitchFamily="34" charset="0"/>
+            </a:endParaRPr>
+          </a:p>
+          <a:p>
+            <a:pPr marL="0" marR="0" algn="l">
+              <a:spcBef>
+                <a:spcPts val="0"/>
+              </a:spcBef>
+              <a:spcAft>
+                <a:spcPts val="0"/>
+              </a:spcAft>
+            </a:pPr>
+            <a:r>
+              <a:rPr lang="en-US" sz="2000" b="0" i="0" u="none" strike="noStrike" dirty="0">
+                <a:solidFill>
+                  <a:srgbClr val="000000"/>
+                </a:solidFill>
+                <a:effectLst/>
+                <a:latin typeface="Segoe UI" panose="020B0502040204020203" pitchFamily="34" charset="0"/>
+                <a:cs typeface="Segoe UI" panose="020B0502040204020203" pitchFamily="34" charset="0"/>
+              </a:rPr>
+              <a:t>Then for the FP lists use the </a:t>
+            </a:r>
+            <a:r>
+              <a:rPr lang="en-US" sz="2000" b="0" i="0" u="none" strike="noStrike" dirty="0" err="1">
+                <a:solidFill>
+                  <a:srgbClr val="000000"/>
+                </a:solidFill>
+                <a:effectLst/>
+                <a:latin typeface="Segoe UI" panose="020B0502040204020203" pitchFamily="34" charset="0"/>
+                <a:cs typeface="Segoe UI" panose="020B0502040204020203" pitchFamily="34" charset="0"/>
+              </a:rPr>
+              <a:t>mitomatrix</a:t>
+            </a:r>
+            <a:r>
+              <a:rPr lang="en-US" sz="2000" b="0" i="0" u="none" strike="noStrike" dirty="0">
+                <a:solidFill>
+                  <a:srgbClr val="000000"/>
+                </a:solidFill>
+                <a:effectLst/>
+                <a:latin typeface="Segoe UI" panose="020B0502040204020203" pitchFamily="34" charset="0"/>
+                <a:cs typeface="Segoe UI" panose="020B0502040204020203" pitchFamily="34" charset="0"/>
+              </a:rPr>
+              <a:t> list – but exclude the proteins with </a:t>
+            </a:r>
+            <a:r>
+              <a:rPr lang="en-US" sz="2000" b="1" i="0" u="none" strike="noStrike" dirty="0">
+                <a:solidFill>
+                  <a:srgbClr val="000000"/>
+                </a:solidFill>
+                <a:effectLst/>
+                <a:latin typeface="Segoe UI" panose="020B0502040204020203" pitchFamily="34" charset="0"/>
+                <a:cs typeface="Segoe UI" panose="020B0502040204020203" pitchFamily="34" charset="0"/>
+              </a:rPr>
+              <a:t>score column </a:t>
+            </a:r>
+            <a:r>
+              <a:rPr lang="en-US" sz="2000" b="0" i="0" u="none" strike="noStrike" dirty="0">
+                <a:solidFill>
+                  <a:srgbClr val="000000"/>
+                </a:solidFill>
+                <a:effectLst/>
+                <a:latin typeface="Segoe UI" panose="020B0502040204020203" pitchFamily="34" charset="0"/>
+                <a:cs typeface="Segoe UI" panose="020B0502040204020203" pitchFamily="34" charset="0"/>
+              </a:rPr>
+              <a:t>&gt;= 0.7 and </a:t>
+            </a:r>
+            <a:r>
+              <a:rPr lang="en-US" sz="2000" b="1" i="0" u="none" strike="noStrike" dirty="0" err="1">
+                <a:solidFill>
+                  <a:srgbClr val="000000"/>
+                </a:solidFill>
+                <a:effectLst/>
+                <a:latin typeface="Segoe UI" panose="020B0502040204020203" pitchFamily="34" charset="0"/>
+                <a:cs typeface="Segoe UI" panose="020B0502040204020203" pitchFamily="34" charset="0"/>
+              </a:rPr>
+              <a:t>UPS_score</a:t>
+            </a:r>
+            <a:r>
+              <a:rPr lang="en-US" sz="2000" b="1" i="0" u="none" strike="noStrike" dirty="0">
+                <a:solidFill>
+                  <a:srgbClr val="000000"/>
+                </a:solidFill>
+                <a:effectLst/>
+                <a:latin typeface="Segoe UI" panose="020B0502040204020203" pitchFamily="34" charset="0"/>
+                <a:cs typeface="Segoe UI" panose="020B0502040204020203" pitchFamily="34" charset="0"/>
+              </a:rPr>
+              <a:t> </a:t>
+            </a:r>
+            <a:r>
+              <a:rPr lang="en-US" sz="2000" b="0" i="0" u="none" strike="noStrike" dirty="0">
+                <a:solidFill>
+                  <a:srgbClr val="000000"/>
+                </a:solidFill>
+                <a:effectLst/>
+                <a:latin typeface="Segoe UI" panose="020B0502040204020203" pitchFamily="34" charset="0"/>
+                <a:cs typeface="Segoe UI" panose="020B0502040204020203" pitchFamily="34" charset="0"/>
+              </a:rPr>
+              <a:t>column value is 0</a:t>
+            </a:r>
+          </a:p>
+          <a:p>
+            <a:pPr marL="0" marR="0" indent="0" algn="l">
+              <a:spcBef>
+                <a:spcPts val="0"/>
+              </a:spcBef>
+              <a:spcAft>
+                <a:spcPts val="0"/>
+              </a:spcAft>
+              <a:buNone/>
+            </a:pPr>
+            <a:endParaRPr kumimoji="0" lang="en-US" sz="2000" b="0" i="0" u="none" strike="noStrike" kern="1200" cap="none" spc="20" normalizeH="0" baseline="0" noProof="0" dirty="0">
+              <a:ln>
+                <a:noFill/>
+              </a:ln>
+              <a:solidFill>
+                <a:srgbClr val="000000"/>
+              </a:solidFill>
+              <a:effectLst/>
+              <a:uLnTx/>
+              <a:uFillTx/>
+              <a:latin typeface="Avenir Next LT Pro"/>
+              <a:ea typeface="+mn-ea"/>
+              <a:cs typeface="+mn-cs"/>
+            </a:endParaRPr>
+          </a:p>
+          <a:p>
+            <a:pPr>
+              <a:buClr>
+                <a:srgbClr val="7BAF34"/>
+              </a:buClr>
+              <a:defRPr/>
+            </a:pPr>
+            <a:endParaRPr kumimoji="0" lang="en-US" sz="2000" b="0" i="0" u="none" strike="noStrike" kern="1200" cap="none" spc="20" normalizeH="0" baseline="0" noProof="0" dirty="0">
+              <a:ln>
+                <a:noFill/>
+              </a:ln>
+              <a:solidFill>
+                <a:srgbClr val="000000"/>
+              </a:solidFill>
+              <a:effectLst/>
+              <a:uLnTx/>
+              <a:uFillTx/>
+              <a:latin typeface="Avenir Next LT Pro"/>
+              <a:ea typeface="+mn-ea"/>
+              <a:cs typeface="+mn-cs"/>
+            </a:endParaRPr>
+          </a:p>
+          <a:p>
+            <a:pPr marL="0" marR="0" lvl="0" indent="0" algn="l" defTabSz="914400" rtl="0" eaLnBrk="1" fontAlgn="auto" latinLnBrk="0" hangingPunct="1">
+              <a:lnSpc>
+                <a:spcPct val="120000"/>
+              </a:lnSpc>
+              <a:spcBef>
+                <a:spcPts val="1000"/>
+              </a:spcBef>
+              <a:spcAft>
+                <a:spcPts val="0"/>
+              </a:spcAft>
+              <a:buClr>
+                <a:srgbClr val="7BAF34"/>
+              </a:buClr>
+              <a:buSzTx/>
+              <a:buNone/>
+              <a:tabLst/>
+              <a:defRPr/>
+            </a:pPr>
+            <a:endParaRPr kumimoji="0" lang="en-US" sz="2000" b="1" i="0" u="none" strike="noStrike" kern="1200" cap="none" spc="20" normalizeH="0" baseline="0" noProof="0" dirty="0">
+              <a:ln>
+                <a:noFill/>
+              </a:ln>
+              <a:solidFill>
+                <a:srgbClr val="000000"/>
+              </a:solidFill>
+              <a:effectLst/>
+              <a:uLnTx/>
+              <a:uFillTx/>
+              <a:latin typeface="Avenir Next LT Pro"/>
+              <a:ea typeface="+mn-ea"/>
+              <a:cs typeface="+mn-cs"/>
+            </a:endParaRPr>
+          </a:p>
+          <a:p>
+            <a:pPr marL="0" marR="0" lvl="0" indent="0" algn="l" defTabSz="914400" rtl="0" eaLnBrk="1" fontAlgn="auto" latinLnBrk="0" hangingPunct="1">
+              <a:lnSpc>
+                <a:spcPct val="120000"/>
+              </a:lnSpc>
+              <a:spcBef>
+                <a:spcPts val="1000"/>
+              </a:spcBef>
+              <a:spcAft>
+                <a:spcPts val="0"/>
+              </a:spcAft>
+              <a:buClr>
+                <a:srgbClr val="7BAF34"/>
+              </a:buClr>
+              <a:buSzTx/>
+              <a:buNone/>
+              <a:tabLst/>
+              <a:defRPr/>
+            </a:pPr>
+            <a:endParaRPr kumimoji="0" lang="en-US" sz="2000" b="0" i="0" u="none" strike="noStrike" kern="1200" cap="none" spc="20" normalizeH="0" baseline="0" noProof="0" dirty="0">
+              <a:ln>
+                <a:noFill/>
+              </a:ln>
+              <a:solidFill>
+                <a:srgbClr val="000000"/>
+              </a:solidFill>
+              <a:effectLst/>
+              <a:uLnTx/>
+              <a:uFillTx/>
+              <a:latin typeface="Avenir Next LT Pro"/>
+              <a:ea typeface="+mn-ea"/>
+              <a:cs typeface="+mn-cs"/>
+            </a:endParaRPr>
+          </a:p>
+          <a:p>
+            <a:pPr lvl="1">
+              <a:spcBef>
+                <a:spcPts val="1000"/>
+              </a:spcBef>
+              <a:buClr>
+                <a:srgbClr val="7BAF34"/>
+              </a:buClr>
+              <a:defRPr/>
+            </a:pPr>
+            <a:endParaRPr kumimoji="0" lang="en-US" b="0" i="0" u="none" strike="noStrike" kern="1200" cap="none" spc="20" normalizeH="0" baseline="0" noProof="0" dirty="0">
+              <a:ln>
+                <a:noFill/>
+              </a:ln>
+              <a:solidFill>
+                <a:srgbClr val="000000"/>
+              </a:solidFill>
+              <a:effectLst/>
+              <a:uLnTx/>
+              <a:uFillTx/>
+              <a:latin typeface="Avenir Next LT Pro"/>
+              <a:ea typeface="+mn-ea"/>
+              <a:cs typeface="+mn-cs"/>
+            </a:endParaRPr>
+          </a:p>
+          <a:p>
+            <a:pPr marL="228600" marR="0" lvl="0" indent="-228600" algn="l" defTabSz="914400" rtl="0" eaLnBrk="1" fontAlgn="auto" latinLnBrk="0" hangingPunct="1">
+              <a:lnSpc>
+                <a:spcPct val="120000"/>
+              </a:lnSpc>
+              <a:spcBef>
+                <a:spcPts val="1000"/>
+              </a:spcBef>
+              <a:spcAft>
+                <a:spcPts val="0"/>
+              </a:spcAft>
+              <a:buClr>
+                <a:srgbClr val="7BAF34"/>
+              </a:buClr>
+              <a:buSzTx/>
+              <a:buFont typeface="The Hand Extrablack" panose="03070A02030502020204" pitchFamily="66" charset="0"/>
+              <a:buChar char="•"/>
+              <a:tabLst/>
+              <a:defRPr/>
+            </a:pPr>
+            <a:endParaRPr lang="en-US" dirty="0">
+              <a:solidFill>
+                <a:srgbClr val="000000"/>
+              </a:solidFill>
+              <a:latin typeface="Avenir Next LT Pro"/>
+            </a:endParaRPr>
+          </a:p>
+          <a:p>
+            <a:pPr marL="0" marR="0" lvl="0" indent="0" algn="l" defTabSz="914400" rtl="0" eaLnBrk="1" fontAlgn="auto" latinLnBrk="0" hangingPunct="1">
+              <a:lnSpc>
+                <a:spcPct val="120000"/>
+              </a:lnSpc>
+              <a:spcBef>
+                <a:spcPts val="1000"/>
+              </a:spcBef>
+              <a:spcAft>
+                <a:spcPts val="0"/>
+              </a:spcAft>
+              <a:buClr>
+                <a:srgbClr val="7BAF34"/>
+              </a:buClr>
+              <a:buSzTx/>
+              <a:buNone/>
+              <a:tabLst/>
+              <a:defRPr/>
+            </a:pPr>
+            <a:endParaRPr kumimoji="0" lang="en-US" sz="2000" b="0" i="0" u="none" strike="noStrike" kern="1200" cap="none" spc="20" normalizeH="0" baseline="0" noProof="0" dirty="0">
+              <a:ln>
+                <a:noFill/>
+              </a:ln>
+              <a:solidFill>
+                <a:srgbClr val="000000"/>
+              </a:solidFill>
+              <a:effectLst/>
+              <a:uLnTx/>
+              <a:uFillTx/>
+              <a:latin typeface="Avenir Next LT Pro"/>
+              <a:ea typeface="+mn-ea"/>
+              <a:cs typeface="+mn-cs"/>
+            </a:endParaRPr>
+          </a:p>
+          <a:p>
+            <a:pPr marL="228600" marR="0" lvl="0" indent="-228600" algn="l" defTabSz="914400" rtl="0" eaLnBrk="1" fontAlgn="auto" latinLnBrk="0" hangingPunct="1">
+              <a:lnSpc>
+                <a:spcPct val="120000"/>
+              </a:lnSpc>
+              <a:spcBef>
+                <a:spcPts val="1000"/>
+              </a:spcBef>
+              <a:spcAft>
+                <a:spcPts val="0"/>
+              </a:spcAft>
+              <a:buClr>
+                <a:srgbClr val="7BAF34"/>
+              </a:buClr>
+              <a:buSzTx/>
+              <a:buFont typeface="The Hand Extrablack" panose="03070A02030502020204" pitchFamily="66" charset="0"/>
+              <a:buChar char="•"/>
+              <a:tabLst/>
+              <a:defRPr/>
+            </a:pPr>
+            <a:endParaRPr kumimoji="0" lang="en-US" sz="2000" b="0" i="0" u="none" strike="noStrike" kern="1200" cap="none" spc="20" normalizeH="0" baseline="0" noProof="0" dirty="0">
+              <a:ln>
+                <a:noFill/>
+              </a:ln>
+              <a:solidFill>
+                <a:srgbClr val="000000"/>
+              </a:solidFill>
+              <a:effectLst/>
+              <a:uLnTx/>
+              <a:uFillTx/>
+              <a:latin typeface="Avenir Next LT Pro"/>
+              <a:ea typeface="+mn-ea"/>
+              <a:cs typeface="+mn-cs"/>
+            </a:endParaRPr>
+          </a:p>
+        </p:txBody>
+      </p:sp>
+    </p:spTree>
+    <p:extLst>
+      <p:ext uri="{BB962C8B-B14F-4D97-AF65-F5344CB8AC3E}">
+        <p14:creationId xmlns:p14="http://schemas.microsoft.com/office/powerpoint/2010/main" val="787388046"/>
+      </p:ext>
+    </p:extLst>
+  </p:cSld>
+  <p:clrMapOvr>
+    <a:masterClrMapping/>
+  </p:clrMapOvr>
+</p:sld>
+</file>
+
+<file path=ppt/slides/slide27.xml><?xml version="1.0" encoding="utf-8"?>
+<p:sld xmlns:a="http://schemas.openxmlformats.org/drawingml/2006/main" xmlns:r="http://schemas.openxmlformats.org/officeDocument/2006/relationships" xmlns:p="http://schemas.openxmlformats.org/presentationml/2006/main">
+  <p:cSld>
+    <p:spTree>
+      <p:nvGrpSpPr>
+        <p:cNvPr id="1" name=""/>
+        <p:cNvGrpSpPr/>
+        <p:nvPr/>
+      </p:nvGrpSpPr>
+      <p:grpSpPr>
+        <a:xfrm>
+          <a:off x="0" y="0"/>
+          <a:ext cx="0" cy="0"/>
+          <a:chOff x="0" y="0"/>
+          <a:chExt cx="0" cy="0"/>
+        </a:xfrm>
+      </p:grpSpPr>
+      <p:sp>
+        <p:nvSpPr>
+          <p:cNvPr id="11" name="Rectangle 10">
+            <a:extLst>
+              <a:ext uri="{FF2B5EF4-FFF2-40B4-BE49-F238E27FC236}">
+                <a16:creationId xmlns:a16="http://schemas.microsoft.com/office/drawing/2014/main" id="{79FB9493-3B31-7442-A8F3-792E4A8E4E18}"/>
+              </a:ext>
+            </a:extLst>
+          </p:cNvPr>
+          <p:cNvSpPr/>
+          <p:nvPr/>
+        </p:nvSpPr>
+        <p:spPr>
+          <a:xfrm>
+            <a:off x="720000" y="3648545"/>
+            <a:ext cx="10881450" cy="1897380"/>
+          </a:xfrm>
+          <a:prstGeom prst="rect">
+            <a:avLst/>
+          </a:prstGeom>
+          <a:solidFill>
+            <a:schemeClr val="accent6">
+              <a:lumMod val="20000"/>
+              <a:lumOff val="80000"/>
+            </a:schemeClr>
+          </a:solidFill>
+          <a:ln>
+            <a:noFill/>
+          </a:ln>
+        </p:spPr>
+        <p:style>
+          <a:lnRef idx="2">
+            <a:schemeClr val="accent1">
+              <a:shade val="50000"/>
+            </a:schemeClr>
+          </a:lnRef>
+          <a:fillRef idx="1">
+            <a:schemeClr val="accent1"/>
+          </a:fillRef>
+          <a:effectRef idx="0">
+            <a:schemeClr val="accent1"/>
+          </a:effectRef>
+          <a:fontRef idx="minor">
+            <a:schemeClr val="lt1"/>
+          </a:fontRef>
+        </p:style>
+        <p:txBody>
+          <a:bodyPr rtlCol="0" anchor="ctr"/>
+          <a:lstStyle/>
+          <a:p>
+            <a:pPr algn="ctr"/>
+            <a:endParaRPr lang="en-US"/>
+          </a:p>
+        </p:txBody>
+      </p:sp>
+      <p:sp>
+        <p:nvSpPr>
+          <p:cNvPr id="2" name="Rectangle 1">
+            <a:extLst>
+              <a:ext uri="{FF2B5EF4-FFF2-40B4-BE49-F238E27FC236}">
+                <a16:creationId xmlns:a16="http://schemas.microsoft.com/office/drawing/2014/main" id="{0FDC7938-1D84-FF4D-83EF-7F7E750E52EB}"/>
+              </a:ext>
+            </a:extLst>
+          </p:cNvPr>
+          <p:cNvSpPr/>
+          <p:nvPr/>
+        </p:nvSpPr>
+        <p:spPr>
+          <a:xfrm>
+            <a:off x="720000" y="1611630"/>
+            <a:ext cx="10881450" cy="1897380"/>
+          </a:xfrm>
+          <a:prstGeom prst="rect">
+            <a:avLst/>
+          </a:prstGeom>
+          <a:solidFill>
+            <a:schemeClr val="accent2">
+              <a:lumMod val="20000"/>
+              <a:lumOff val="80000"/>
+            </a:schemeClr>
+          </a:solidFill>
+          <a:ln>
+            <a:noFill/>
+          </a:ln>
+        </p:spPr>
+        <p:style>
+          <a:lnRef idx="2">
+            <a:schemeClr val="accent1">
+              <a:shade val="50000"/>
+            </a:schemeClr>
+          </a:lnRef>
+          <a:fillRef idx="1">
+            <a:schemeClr val="accent1"/>
+          </a:fillRef>
+          <a:effectRef idx="0">
+            <a:schemeClr val="accent1"/>
+          </a:effectRef>
+          <a:fontRef idx="minor">
+            <a:schemeClr val="lt1"/>
+          </a:fontRef>
+        </p:style>
+        <p:txBody>
+          <a:bodyPr rtlCol="0" anchor="ctr"/>
+          <a:lstStyle/>
+          <a:p>
+            <a:pPr algn="ctr"/>
+            <a:endParaRPr lang="en-US"/>
+          </a:p>
+        </p:txBody>
+      </p:sp>
+      <p:sp>
+        <p:nvSpPr>
+          <p:cNvPr id="4" name="Slide Number Placeholder 3">
+            <a:extLst>
+              <a:ext uri="{FF2B5EF4-FFF2-40B4-BE49-F238E27FC236}">
+                <a16:creationId xmlns:a16="http://schemas.microsoft.com/office/drawing/2014/main" id="{4383861C-DDFF-F94F-B844-7188E07B1951}"/>
+              </a:ext>
+            </a:extLst>
+          </p:cNvPr>
+          <p:cNvSpPr>
+            <a:spLocks noGrp="1"/>
+          </p:cNvSpPr>
+          <p:nvPr>
+            <p:ph type="sldNum" sz="quarter" idx="12"/>
+          </p:nvPr>
+        </p:nvSpPr>
+        <p:spPr/>
+        <p:txBody>
+          <a:bodyPr/>
+          <a:lstStyle/>
+          <a:p>
+            <a:fld id="{1621B6DD-29C1-4FEA-923F-71EA1347694C}" type="slidenum">
+              <a:rPr lang="en-US" smtClean="0"/>
+              <a:t>26</a:t>
+            </a:fld>
+            <a:endParaRPr lang="en-US"/>
+          </a:p>
+        </p:txBody>
+      </p:sp>
+      <p:sp>
+        <p:nvSpPr>
+          <p:cNvPr id="6" name="Title 1">
+            <a:extLst>
+              <a:ext uri="{FF2B5EF4-FFF2-40B4-BE49-F238E27FC236}">
+                <a16:creationId xmlns:a16="http://schemas.microsoft.com/office/drawing/2014/main" id="{8BB2DFB4-E4EC-CC46-BF2B-90B0CB50A619}"/>
+              </a:ext>
+            </a:extLst>
+          </p:cNvPr>
+          <p:cNvSpPr txBox="1">
+            <a:spLocks/>
+          </p:cNvSpPr>
+          <p:nvPr/>
+        </p:nvSpPr>
+        <p:spPr>
+          <a:xfrm>
+            <a:off x="720000" y="619200"/>
+            <a:ext cx="10728322" cy="666675"/>
+          </a:xfrm>
+          <a:prstGeom prst="rect">
+            <a:avLst/>
+          </a:prstGeom>
+        </p:spPr>
+        <p:txBody>
+          <a:bodyPr vert="horz" lIns="91440" tIns="45720" rIns="91440" bIns="45720" rtlCol="0" anchor="ctr">
+            <a:normAutofit fontScale="97500" lnSpcReduction="10000"/>
+          </a:bodyPr>
+          <a:lstStyle>
+            <a:lvl1pPr algn="l" defTabSz="914400" rtl="0" eaLnBrk="1" latinLnBrk="0" hangingPunct="1">
+              <a:lnSpc>
+                <a:spcPct val="90000"/>
+              </a:lnSpc>
+              <a:spcBef>
+                <a:spcPct val="0"/>
+              </a:spcBef>
+              <a:buNone/>
+              <a:defRPr sz="4400" kern="1200">
+                <a:solidFill>
+                  <a:schemeClr val="tx1"/>
+                </a:solidFill>
+                <a:latin typeface="+mj-lt"/>
+                <a:ea typeface="+mj-ea"/>
+                <a:cs typeface="+mj-cs"/>
+              </a:defRPr>
+            </a:lvl1pPr>
+          </a:lstStyle>
+          <a:p>
+            <a:r>
+              <a:rPr lang="en-US" b="1" dirty="0">
+                <a:latin typeface="Times New Roman" panose="02020603050405020304" pitchFamily="18" charset="0"/>
+                <a:cs typeface="Times New Roman" panose="02020603050405020304" pitchFamily="18" charset="0"/>
+              </a:rPr>
+              <a:t>Total number of proteins in list </a:t>
+            </a:r>
+          </a:p>
+        </p:txBody>
+      </p:sp>
+      <p:sp>
+        <p:nvSpPr>
+          <p:cNvPr id="5" name="Content Placeholder 2">
+            <a:extLst>
+              <a:ext uri="{FF2B5EF4-FFF2-40B4-BE49-F238E27FC236}">
+                <a16:creationId xmlns:a16="http://schemas.microsoft.com/office/drawing/2014/main" id="{D334BA8F-7D11-7C46-92B4-623B02C91ADB}"/>
+              </a:ext>
+            </a:extLst>
+          </p:cNvPr>
+          <p:cNvSpPr>
+            <a:spLocks noGrp="1"/>
+          </p:cNvSpPr>
+          <p:nvPr>
+            <p:ph idx="1"/>
+          </p:nvPr>
+        </p:nvSpPr>
+        <p:spPr>
+          <a:xfrm>
+            <a:off x="1106545" y="1764307"/>
+            <a:ext cx="9978909" cy="3864074"/>
+          </a:xfrm>
+        </p:spPr>
+        <p:txBody>
+          <a:bodyPr>
+            <a:normAutofit/>
+          </a:bodyPr>
+          <a:lstStyle/>
+          <a:p>
+            <a:pPr marL="0" indent="0">
+              <a:lnSpc>
+                <a:spcPct val="120000"/>
+              </a:lnSpc>
+              <a:buClr>
+                <a:schemeClr val="tx1"/>
+              </a:buClr>
+              <a:buNone/>
+              <a:defRPr/>
+            </a:pPr>
+            <a:r>
+              <a:rPr lang="en-US" sz="2000" i="0" spc="20" dirty="0">
+                <a:solidFill>
+                  <a:srgbClr val="000000"/>
+                </a:solidFill>
+                <a:latin typeface="Segoe UI" panose="020B0502040204020203" pitchFamily="34" charset="0"/>
+                <a:cs typeface="Segoe UI" panose="020B0502040204020203" pitchFamily="34" charset="0"/>
+              </a:rPr>
+              <a:t>Old lists </a:t>
+            </a:r>
+            <a:endParaRPr lang="en-US" sz="2000" b="1" spc="20" dirty="0">
+              <a:solidFill>
+                <a:srgbClr val="000000"/>
+              </a:solidFill>
+              <a:latin typeface="Segoe UI" panose="020B0502040204020203" pitchFamily="34" charset="0"/>
+              <a:cs typeface="Segoe UI" panose="020B0502040204020203" pitchFamily="34" charset="0"/>
+            </a:endParaRPr>
+          </a:p>
+          <a:p>
+            <a:pPr>
+              <a:buClr>
+                <a:srgbClr val="7BAF34"/>
+              </a:buClr>
+              <a:defRPr/>
+            </a:pPr>
+            <a:endParaRPr kumimoji="0" lang="en-US" sz="2000" b="0" i="0" u="none" strike="noStrike" kern="1200" cap="none" spc="20" normalizeH="0" baseline="0" noProof="0" dirty="0">
+              <a:ln>
+                <a:noFill/>
+              </a:ln>
+              <a:solidFill>
+                <a:srgbClr val="000000"/>
+              </a:solidFill>
+              <a:effectLst/>
+              <a:uLnTx/>
+              <a:uFillTx/>
+              <a:latin typeface="Avenir Next LT Pro"/>
+              <a:ea typeface="+mn-ea"/>
+              <a:cs typeface="+mn-cs"/>
+            </a:endParaRPr>
+          </a:p>
+          <a:p>
+            <a:pPr marL="0" marR="0" lvl="0" indent="0" algn="l" defTabSz="914400" rtl="0" eaLnBrk="1" fontAlgn="auto" latinLnBrk="0" hangingPunct="1">
+              <a:lnSpc>
+                <a:spcPct val="120000"/>
+              </a:lnSpc>
+              <a:spcBef>
+                <a:spcPts val="1000"/>
+              </a:spcBef>
+              <a:spcAft>
+                <a:spcPts val="0"/>
+              </a:spcAft>
+              <a:buClr>
+                <a:srgbClr val="7BAF34"/>
+              </a:buClr>
+              <a:buSzTx/>
+              <a:buNone/>
+              <a:tabLst/>
+              <a:defRPr/>
+            </a:pPr>
+            <a:endParaRPr kumimoji="0" lang="en-US" sz="2000" b="1" i="0" u="none" strike="noStrike" kern="1200" cap="none" spc="20" normalizeH="0" baseline="0" noProof="0" dirty="0">
+              <a:ln>
+                <a:noFill/>
+              </a:ln>
+              <a:solidFill>
+                <a:srgbClr val="000000"/>
+              </a:solidFill>
+              <a:effectLst/>
+              <a:uLnTx/>
+              <a:uFillTx/>
+              <a:latin typeface="Avenir Next LT Pro"/>
+              <a:ea typeface="+mn-ea"/>
+              <a:cs typeface="+mn-cs"/>
+            </a:endParaRPr>
+          </a:p>
+          <a:p>
+            <a:pPr marL="0" marR="0" lvl="0" indent="0" algn="l" defTabSz="914400" rtl="0" eaLnBrk="1" fontAlgn="auto" latinLnBrk="0" hangingPunct="1">
+              <a:lnSpc>
+                <a:spcPct val="120000"/>
+              </a:lnSpc>
+              <a:spcBef>
+                <a:spcPts val="1000"/>
+              </a:spcBef>
+              <a:spcAft>
+                <a:spcPts val="0"/>
+              </a:spcAft>
+              <a:buClr>
+                <a:srgbClr val="7BAF34"/>
+              </a:buClr>
+              <a:buSzTx/>
+              <a:buNone/>
+              <a:tabLst/>
+              <a:defRPr/>
+            </a:pPr>
+            <a:endParaRPr kumimoji="0" lang="en-US" sz="2000" b="0" i="0" u="none" strike="noStrike" kern="1200" cap="none" spc="20" normalizeH="0" baseline="0" noProof="0" dirty="0">
+              <a:ln>
+                <a:noFill/>
+              </a:ln>
+              <a:solidFill>
+                <a:srgbClr val="000000"/>
+              </a:solidFill>
+              <a:effectLst/>
+              <a:uLnTx/>
+              <a:uFillTx/>
+              <a:latin typeface="Avenir Next LT Pro"/>
+              <a:ea typeface="+mn-ea"/>
+              <a:cs typeface="+mn-cs"/>
+            </a:endParaRPr>
+          </a:p>
+          <a:p>
+            <a:pPr marL="0" indent="0">
+              <a:lnSpc>
+                <a:spcPct val="120000"/>
+              </a:lnSpc>
+              <a:buClr>
+                <a:srgbClr val="7BAF34"/>
+              </a:buClr>
+              <a:buNone/>
+              <a:defRPr/>
+            </a:pPr>
+            <a:r>
+              <a:rPr lang="en-US" sz="2000" i="0" spc="20" dirty="0">
+                <a:solidFill>
+                  <a:srgbClr val="000000"/>
+                </a:solidFill>
+                <a:latin typeface="Segoe UI" panose="020B0502040204020203" pitchFamily="34" charset="0"/>
+                <a:cs typeface="Segoe UI" panose="020B0502040204020203" pitchFamily="34" charset="0"/>
+              </a:rPr>
+              <a:t>New lists (with </a:t>
+            </a:r>
+            <a:r>
+              <a:rPr lang="en-US" sz="2000" i="0" spc="20" dirty="0" err="1">
+                <a:solidFill>
+                  <a:srgbClr val="000000"/>
+                </a:solidFill>
+                <a:latin typeface="Segoe UI" panose="020B0502040204020203" pitchFamily="34" charset="0"/>
+                <a:cs typeface="Segoe UI" panose="020B0502040204020203" pitchFamily="34" charset="0"/>
+              </a:rPr>
+              <a:t>SignalP</a:t>
+            </a:r>
+            <a:r>
+              <a:rPr lang="en-US" sz="2000" spc="20" dirty="0">
+                <a:solidFill>
+                  <a:srgbClr val="000000"/>
+                </a:solidFill>
+                <a:latin typeface="Segoe UI" panose="020B0502040204020203" pitchFamily="34" charset="0"/>
+                <a:cs typeface="Segoe UI" panose="020B0502040204020203" pitchFamily="34" charset="0"/>
+              </a:rPr>
+              <a:t>)</a:t>
+            </a:r>
+            <a:endParaRPr lang="en-US" sz="2000" b="1" spc="20" dirty="0">
+              <a:solidFill>
+                <a:srgbClr val="000000"/>
+              </a:solidFill>
+              <a:latin typeface="Segoe UI" panose="020B0502040204020203" pitchFamily="34" charset="0"/>
+              <a:cs typeface="Segoe UI" panose="020B0502040204020203" pitchFamily="34" charset="0"/>
+            </a:endParaRPr>
+          </a:p>
+          <a:p>
+            <a:pPr marL="0" marR="0" lvl="0" indent="0" algn="l" defTabSz="914400" rtl="0" eaLnBrk="1" fontAlgn="auto" latinLnBrk="0" hangingPunct="1">
+              <a:lnSpc>
+                <a:spcPct val="120000"/>
+              </a:lnSpc>
+              <a:spcBef>
+                <a:spcPts val="1000"/>
+              </a:spcBef>
+              <a:spcAft>
+                <a:spcPts val="0"/>
+              </a:spcAft>
+              <a:buClr>
+                <a:srgbClr val="7BAF34"/>
+              </a:buClr>
+              <a:buSzTx/>
+              <a:buNone/>
+              <a:tabLst/>
+              <a:defRPr/>
+            </a:pPr>
+            <a:endParaRPr kumimoji="0" lang="en-US" sz="2000" b="0" i="0" u="none" strike="noStrike" kern="1200" cap="none" spc="20" normalizeH="0" baseline="0" noProof="0" dirty="0">
+              <a:ln>
+                <a:noFill/>
+              </a:ln>
+              <a:solidFill>
+                <a:srgbClr val="000000"/>
+              </a:solidFill>
+              <a:effectLst/>
+              <a:uLnTx/>
+              <a:uFillTx/>
+              <a:latin typeface="Avenir Next LT Pro"/>
+              <a:ea typeface="+mn-ea"/>
+              <a:cs typeface="+mn-cs"/>
+            </a:endParaRPr>
+          </a:p>
+          <a:p>
+            <a:pPr lvl="1">
+              <a:spcBef>
+                <a:spcPts val="1000"/>
+              </a:spcBef>
+              <a:buClr>
+                <a:srgbClr val="7BAF34"/>
+              </a:buClr>
+              <a:defRPr/>
+            </a:pPr>
+            <a:endParaRPr kumimoji="0" lang="en-US" b="0" i="0" u="none" strike="noStrike" kern="1200" cap="none" spc="20" normalizeH="0" baseline="0" noProof="0" dirty="0">
+              <a:ln>
+                <a:noFill/>
+              </a:ln>
+              <a:solidFill>
+                <a:srgbClr val="000000"/>
+              </a:solidFill>
+              <a:effectLst/>
+              <a:uLnTx/>
+              <a:uFillTx/>
+              <a:latin typeface="Avenir Next LT Pro"/>
+              <a:ea typeface="+mn-ea"/>
+              <a:cs typeface="+mn-cs"/>
+            </a:endParaRPr>
+          </a:p>
+          <a:p>
+            <a:pPr marL="228600" marR="0" lvl="0" indent="-228600" algn="l" defTabSz="914400" rtl="0" eaLnBrk="1" fontAlgn="auto" latinLnBrk="0" hangingPunct="1">
+              <a:lnSpc>
+                <a:spcPct val="120000"/>
+              </a:lnSpc>
+              <a:spcBef>
+                <a:spcPts val="1000"/>
+              </a:spcBef>
+              <a:spcAft>
+                <a:spcPts val="0"/>
+              </a:spcAft>
+              <a:buClr>
+                <a:srgbClr val="7BAF34"/>
+              </a:buClr>
+              <a:buSzTx/>
+              <a:buFont typeface="The Hand Extrablack" panose="03070A02030502020204" pitchFamily="66" charset="0"/>
+              <a:buChar char="•"/>
+              <a:tabLst/>
+              <a:defRPr/>
+            </a:pPr>
+            <a:endParaRPr lang="en-US" dirty="0">
+              <a:solidFill>
+                <a:srgbClr val="000000"/>
+              </a:solidFill>
+              <a:latin typeface="Avenir Next LT Pro"/>
+            </a:endParaRPr>
+          </a:p>
+          <a:p>
+            <a:pPr marL="0" marR="0" lvl="0" indent="0" algn="l" defTabSz="914400" rtl="0" eaLnBrk="1" fontAlgn="auto" latinLnBrk="0" hangingPunct="1">
+              <a:lnSpc>
+                <a:spcPct val="120000"/>
+              </a:lnSpc>
+              <a:spcBef>
+                <a:spcPts val="1000"/>
+              </a:spcBef>
+              <a:spcAft>
+                <a:spcPts val="0"/>
+              </a:spcAft>
+              <a:buClr>
+                <a:srgbClr val="7BAF34"/>
+              </a:buClr>
+              <a:buSzTx/>
+              <a:buNone/>
+              <a:tabLst/>
+              <a:defRPr/>
+            </a:pPr>
+            <a:endParaRPr kumimoji="0" lang="en-US" sz="2000" b="0" i="0" u="none" strike="noStrike" kern="1200" cap="none" spc="20" normalizeH="0" baseline="0" noProof="0" dirty="0">
+              <a:ln>
+                <a:noFill/>
+              </a:ln>
+              <a:solidFill>
+                <a:srgbClr val="000000"/>
+              </a:solidFill>
+              <a:effectLst/>
+              <a:uLnTx/>
+              <a:uFillTx/>
+              <a:latin typeface="Avenir Next LT Pro"/>
+              <a:ea typeface="+mn-ea"/>
+              <a:cs typeface="+mn-cs"/>
+            </a:endParaRPr>
+          </a:p>
+          <a:p>
+            <a:pPr marL="228600" marR="0" lvl="0" indent="-228600" algn="l" defTabSz="914400" rtl="0" eaLnBrk="1" fontAlgn="auto" latinLnBrk="0" hangingPunct="1">
+              <a:lnSpc>
+                <a:spcPct val="120000"/>
+              </a:lnSpc>
+              <a:spcBef>
+                <a:spcPts val="1000"/>
+              </a:spcBef>
+              <a:spcAft>
+                <a:spcPts val="0"/>
+              </a:spcAft>
+              <a:buClr>
+                <a:srgbClr val="7BAF34"/>
+              </a:buClr>
+              <a:buSzTx/>
+              <a:buFont typeface="The Hand Extrablack" panose="03070A02030502020204" pitchFamily="66" charset="0"/>
+              <a:buChar char="•"/>
+              <a:tabLst/>
+              <a:defRPr/>
+            </a:pPr>
+            <a:endParaRPr kumimoji="0" lang="en-US" sz="2000" b="0" i="0" u="none" strike="noStrike" kern="1200" cap="none" spc="20" normalizeH="0" baseline="0" noProof="0" dirty="0">
+              <a:ln>
+                <a:noFill/>
+              </a:ln>
+              <a:solidFill>
+                <a:srgbClr val="000000"/>
+              </a:solidFill>
+              <a:effectLst/>
+              <a:uLnTx/>
+              <a:uFillTx/>
+              <a:latin typeface="Avenir Next LT Pro"/>
+              <a:ea typeface="+mn-ea"/>
+              <a:cs typeface="+mn-cs"/>
+            </a:endParaRPr>
+          </a:p>
+        </p:txBody>
+      </p:sp>
+      <p:sp>
+        <p:nvSpPr>
+          <p:cNvPr id="7" name="Rectangle 6">
+            <a:extLst>
+              <a:ext uri="{FF2B5EF4-FFF2-40B4-BE49-F238E27FC236}">
+                <a16:creationId xmlns:a16="http://schemas.microsoft.com/office/drawing/2014/main" id="{03292042-6149-A447-BDAE-2B25DDEF63C4}"/>
+              </a:ext>
+            </a:extLst>
+          </p:cNvPr>
+          <p:cNvSpPr/>
+          <p:nvPr/>
+        </p:nvSpPr>
+        <p:spPr>
+          <a:xfrm>
+            <a:off x="2859766" y="2546812"/>
+            <a:ext cx="2738535" cy="406937"/>
+          </a:xfrm>
+          <a:prstGeom prst="rect">
+            <a:avLst/>
+          </a:prstGeom>
+          <a:solidFill>
+            <a:srgbClr val="008A00"/>
+          </a:solidFill>
+        </p:spPr>
+        <p:style>
+          <a:lnRef idx="1">
+            <a:schemeClr val="accent6"/>
+          </a:lnRef>
+          <a:fillRef idx="2">
+            <a:schemeClr val="accent6"/>
+          </a:fillRef>
+          <a:effectRef idx="1">
+            <a:schemeClr val="accent6"/>
+          </a:effectRef>
+          <a:fontRef idx="minor">
+            <a:schemeClr val="dk1"/>
+          </a:fontRef>
+        </p:style>
+        <p:txBody>
+          <a:bodyPr rtlCol="0" anchor="ctr"/>
+          <a:lstStyle/>
+          <a:p>
+            <a:pPr algn="ctr"/>
+            <a:r>
+              <a:rPr lang="en-US" dirty="0">
+                <a:solidFill>
+                  <a:schemeClr val="bg1"/>
+                </a:solidFill>
+              </a:rPr>
+              <a:t>TP list: </a:t>
+            </a:r>
+            <a:r>
+              <a:rPr lang="en-US" b="1" dirty="0">
+                <a:solidFill>
+                  <a:schemeClr val="bg1"/>
+                </a:solidFill>
+              </a:rPr>
+              <a:t>2806</a:t>
+            </a:r>
+            <a:r>
+              <a:rPr lang="en-US" dirty="0">
+                <a:solidFill>
+                  <a:schemeClr val="bg1"/>
+                </a:solidFill>
+              </a:rPr>
+              <a:t> Proteins</a:t>
+            </a:r>
+          </a:p>
+        </p:txBody>
+      </p:sp>
+      <p:sp>
+        <p:nvSpPr>
+          <p:cNvPr id="8" name="Rectangle 7">
+            <a:extLst>
+              <a:ext uri="{FF2B5EF4-FFF2-40B4-BE49-F238E27FC236}">
+                <a16:creationId xmlns:a16="http://schemas.microsoft.com/office/drawing/2014/main" id="{054423E0-2779-0145-99D5-394704B4A2D3}"/>
+              </a:ext>
+            </a:extLst>
+          </p:cNvPr>
+          <p:cNvSpPr/>
+          <p:nvPr/>
+        </p:nvSpPr>
+        <p:spPr>
+          <a:xfrm>
+            <a:off x="5872065" y="2546811"/>
+            <a:ext cx="2738535" cy="406937"/>
+          </a:xfrm>
+          <a:prstGeom prst="rect">
+            <a:avLst/>
+          </a:prstGeom>
+          <a:solidFill>
+            <a:srgbClr val="C00000"/>
+          </a:solidFill>
+          <a:ln>
+            <a:noFill/>
+          </a:ln>
+        </p:spPr>
+        <p:style>
+          <a:lnRef idx="1">
+            <a:schemeClr val="accent6"/>
+          </a:lnRef>
+          <a:fillRef idx="2">
+            <a:schemeClr val="accent6"/>
+          </a:fillRef>
+          <a:effectRef idx="1">
+            <a:schemeClr val="accent6"/>
+          </a:effectRef>
+          <a:fontRef idx="minor">
+            <a:schemeClr val="dk1"/>
+          </a:fontRef>
+        </p:style>
+        <p:txBody>
+          <a:bodyPr rtlCol="0" anchor="ctr"/>
+          <a:lstStyle/>
+          <a:p>
+            <a:pPr algn="ctr"/>
+            <a:r>
+              <a:rPr lang="en-US" dirty="0">
+                <a:solidFill>
+                  <a:schemeClr val="bg1"/>
+                </a:solidFill>
+              </a:rPr>
+              <a:t>FP list: </a:t>
+            </a:r>
+            <a:r>
+              <a:rPr lang="en-US" b="1" dirty="0">
+                <a:solidFill>
+                  <a:schemeClr val="bg1"/>
+                </a:solidFill>
+              </a:rPr>
+              <a:t>435</a:t>
+            </a:r>
+            <a:r>
+              <a:rPr lang="en-US" dirty="0">
+                <a:solidFill>
+                  <a:schemeClr val="bg1"/>
+                </a:solidFill>
+              </a:rPr>
+              <a:t> Proteins</a:t>
+            </a:r>
+          </a:p>
+        </p:txBody>
+      </p:sp>
+      <p:sp>
+        <p:nvSpPr>
+          <p:cNvPr id="9" name="Rectangle 8">
+            <a:extLst>
+              <a:ext uri="{FF2B5EF4-FFF2-40B4-BE49-F238E27FC236}">
+                <a16:creationId xmlns:a16="http://schemas.microsoft.com/office/drawing/2014/main" id="{69C8880B-A639-0D4A-BAE4-CDC36D688C9C}"/>
+              </a:ext>
+            </a:extLst>
+          </p:cNvPr>
+          <p:cNvSpPr/>
+          <p:nvPr/>
+        </p:nvSpPr>
+        <p:spPr>
+          <a:xfrm>
+            <a:off x="2859766" y="4690244"/>
+            <a:ext cx="2738535" cy="406937"/>
+          </a:xfrm>
+          <a:prstGeom prst="rect">
+            <a:avLst/>
+          </a:prstGeom>
+          <a:solidFill>
+            <a:srgbClr val="008A00"/>
+          </a:solidFill>
+        </p:spPr>
+        <p:style>
+          <a:lnRef idx="1">
+            <a:schemeClr val="accent6"/>
+          </a:lnRef>
+          <a:fillRef idx="2">
+            <a:schemeClr val="accent6"/>
+          </a:fillRef>
+          <a:effectRef idx="1">
+            <a:schemeClr val="accent6"/>
+          </a:effectRef>
+          <a:fontRef idx="minor">
+            <a:schemeClr val="dk1"/>
+          </a:fontRef>
+        </p:style>
+        <p:txBody>
+          <a:bodyPr rtlCol="0" anchor="ctr"/>
+          <a:lstStyle/>
+          <a:p>
+            <a:pPr algn="ctr"/>
+            <a:r>
+              <a:rPr lang="en-US" dirty="0">
+                <a:solidFill>
+                  <a:schemeClr val="bg1"/>
+                </a:solidFill>
+              </a:rPr>
+              <a:t>TP list: </a:t>
+            </a:r>
+            <a:r>
+              <a:rPr lang="en-US" b="1" dirty="0">
+                <a:solidFill>
+                  <a:schemeClr val="bg1"/>
+                </a:solidFill>
+              </a:rPr>
+              <a:t>348</a:t>
+            </a:r>
+            <a:r>
+              <a:rPr lang="en-US" dirty="0">
+                <a:solidFill>
+                  <a:schemeClr val="bg1"/>
+                </a:solidFill>
+              </a:rPr>
+              <a:t> Proteins</a:t>
+            </a:r>
+          </a:p>
+        </p:txBody>
+      </p:sp>
+      <p:sp>
+        <p:nvSpPr>
+          <p:cNvPr id="10" name="Rectangle 9">
+            <a:extLst>
+              <a:ext uri="{FF2B5EF4-FFF2-40B4-BE49-F238E27FC236}">
+                <a16:creationId xmlns:a16="http://schemas.microsoft.com/office/drawing/2014/main" id="{41E29D01-8C5D-2345-86EB-6062B1DFA413}"/>
+              </a:ext>
+            </a:extLst>
+          </p:cNvPr>
+          <p:cNvSpPr/>
+          <p:nvPr/>
+        </p:nvSpPr>
+        <p:spPr>
+          <a:xfrm>
+            <a:off x="5872065" y="4690243"/>
+            <a:ext cx="2738535" cy="406937"/>
+          </a:xfrm>
+          <a:prstGeom prst="rect">
+            <a:avLst/>
+          </a:prstGeom>
+          <a:solidFill>
+            <a:srgbClr val="C00000"/>
+          </a:solidFill>
+          <a:ln>
+            <a:noFill/>
+          </a:ln>
+        </p:spPr>
+        <p:style>
+          <a:lnRef idx="1">
+            <a:schemeClr val="accent6"/>
+          </a:lnRef>
+          <a:fillRef idx="2">
+            <a:schemeClr val="accent6"/>
+          </a:fillRef>
+          <a:effectRef idx="1">
+            <a:schemeClr val="accent6"/>
+          </a:effectRef>
+          <a:fontRef idx="minor">
+            <a:schemeClr val="dk1"/>
+          </a:fontRef>
+        </p:style>
+        <p:txBody>
+          <a:bodyPr rtlCol="0" anchor="ctr"/>
+          <a:lstStyle/>
+          <a:p>
+            <a:pPr algn="ctr"/>
+            <a:r>
+              <a:rPr lang="en-US" dirty="0">
+                <a:solidFill>
+                  <a:schemeClr val="bg1"/>
+                </a:solidFill>
+              </a:rPr>
+              <a:t>FP list: </a:t>
+            </a:r>
+            <a:r>
+              <a:rPr lang="en-US" b="1" dirty="0">
+                <a:solidFill>
+                  <a:schemeClr val="bg1"/>
+                </a:solidFill>
+              </a:rPr>
+              <a:t>393</a:t>
+            </a:r>
+            <a:r>
+              <a:rPr lang="en-US" dirty="0">
+                <a:solidFill>
+                  <a:schemeClr val="bg1"/>
+                </a:solidFill>
+              </a:rPr>
+              <a:t> Proteins</a:t>
+            </a:r>
+          </a:p>
+        </p:txBody>
+      </p:sp>
+    </p:spTree>
+    <p:extLst>
+      <p:ext uri="{BB962C8B-B14F-4D97-AF65-F5344CB8AC3E}">
+        <p14:creationId xmlns:p14="http://schemas.microsoft.com/office/powerpoint/2010/main" val="1874436980"/>
+      </p:ext>
+    </p:extLst>
+  </p:cSld>
+  <p:clrMapOvr>
+    <a:masterClrMapping/>
+  </p:clrMapOvr>
+  <p:timing>
+    <p:tnLst>
+      <p:par>
+        <p:cTn id="1" dur="indefinite" restart="never" nodeType="tmRoot">
+          <p:childTnLst>
+            <p:seq concurrent="1" nextAc="seek">
+              <p:cTn id="2" dur="indefinite" nodeType="mainSeq">
+                <p:childTnLst>
+                  <p:par>
+                    <p:cTn id="3" fill="hold">
+                      <p:stCondLst>
+                        <p:cond delay="indefinite"/>
+                      </p:stCondLst>
+                      <p:childTnLst>
+                        <p:par>
+                          <p:cTn id="4" fill="hold">
+                            <p:stCondLst>
+                              <p:cond delay="0"/>
+                            </p:stCondLst>
+                            <p:childTnLst>
+                              <p:par>
+                                <p:cTn id="5" presetID="1" presetClass="entr" presetSubtype="0" fill="hold" grpId="0" nodeType="clickEffect">
+                                  <p:stCondLst>
+                                    <p:cond delay="0"/>
+                                  </p:stCondLst>
+                                  <p:childTnLst>
+                                    <p:set>
+                                      <p:cBhvr>
+                                        <p:cTn id="6" dur="1" fill="hold">
+                                          <p:stCondLst>
+                                            <p:cond delay="0"/>
+                                          </p:stCondLst>
+                                        </p:cTn>
+                                        <p:tgtEl>
+                                          <p:spTgt spid="7"/>
+                                        </p:tgtEl>
+                                        <p:attrNameLst>
+                                          <p:attrName>style.visibility</p:attrName>
+                                        </p:attrNameLst>
+                                      </p:cBhvr>
+                                      <p:to>
+                                        <p:strVal val="visible"/>
+                                      </p:to>
+                                    </p:set>
+                                  </p:childTnLst>
+                                </p:cTn>
+                              </p:par>
+                              <p:par>
+                                <p:cTn id="7" presetID="1" presetClass="entr" presetSubtype="0" fill="hold" grpId="0" nodeType="withEffect">
+                                  <p:stCondLst>
+                                    <p:cond delay="0"/>
+                                  </p:stCondLst>
+                                  <p:childTnLst>
+                                    <p:set>
+                                      <p:cBhvr>
+                                        <p:cTn id="8" dur="1" fill="hold">
+                                          <p:stCondLst>
+                                            <p:cond delay="0"/>
+                                          </p:stCondLst>
+                                        </p:cTn>
+                                        <p:tgtEl>
+                                          <p:spTgt spid="8"/>
+                                        </p:tgtEl>
+                                        <p:attrNameLst>
+                                          <p:attrName>style.visibility</p:attrName>
+                                        </p:attrNameLst>
+                                      </p:cBhvr>
+                                      <p:to>
+                                        <p:strVal val="visible"/>
+                                      </p:to>
+                                    </p:set>
+                                  </p:childTnLst>
+                                </p:cTn>
+                              </p:par>
+                            </p:childTnLst>
+                          </p:cTn>
+                        </p:par>
+                      </p:childTnLst>
+                    </p:cTn>
+                  </p:par>
+                  <p:par>
+                    <p:cTn id="9" fill="hold">
+                      <p:stCondLst>
+                        <p:cond delay="indefinite"/>
+                      </p:stCondLst>
+                      <p:childTnLst>
+                        <p:par>
+                          <p:cTn id="10" fill="hold">
+                            <p:stCondLst>
+                              <p:cond delay="0"/>
+                            </p:stCondLst>
+                            <p:childTnLst>
+                              <p:par>
+                                <p:cTn id="11" presetID="1" presetClass="entr" presetSubtype="0" fill="hold" grpId="0" nodeType="clickEffect">
+                                  <p:stCondLst>
+                                    <p:cond delay="0"/>
+                                  </p:stCondLst>
+                                  <p:childTnLst>
+                                    <p:set>
+                                      <p:cBhvr>
+                                        <p:cTn id="12" dur="1" fill="hold">
+                                          <p:stCondLst>
+                                            <p:cond delay="0"/>
+                                          </p:stCondLst>
+                                        </p:cTn>
+                                        <p:tgtEl>
+                                          <p:spTgt spid="9"/>
+                                        </p:tgtEl>
+                                        <p:attrNameLst>
+                                          <p:attrName>style.visibility</p:attrName>
+                                        </p:attrNameLst>
+                                      </p:cBhvr>
+                                      <p:to>
+                                        <p:strVal val="visible"/>
+                                      </p:to>
+                                    </p:set>
+                                  </p:childTnLst>
+                                </p:cTn>
+                              </p:par>
+                              <p:par>
+                                <p:cTn id="13" presetID="1" presetClass="entr" presetSubtype="0" fill="hold" grpId="0" nodeType="withEffect">
+                                  <p:stCondLst>
+                                    <p:cond delay="0"/>
+                                  </p:stCondLst>
+                                  <p:childTnLst>
+                                    <p:set>
+                                      <p:cBhvr>
+                                        <p:cTn id="14" dur="1" fill="hold">
+                                          <p:stCondLst>
+                                            <p:cond delay="0"/>
+                                          </p:stCondLst>
+                                        </p:cTn>
+                                        <p:tgtEl>
+                                          <p:spTgt spid="10"/>
+                                        </p:tgtEl>
+                                        <p:attrNameLst>
+                                          <p:attrName>style.visibility</p:attrName>
+                                        </p:attrNameLst>
+                                      </p:cBhvr>
+                                      <p:to>
+                                        <p:strVal val="visible"/>
+                                      </p:to>
+                                    </p:set>
+                                  </p:childTnLst>
+                                </p:cTn>
+                              </p:par>
+                            </p:childTnLst>
+                          </p:cTn>
+                        </p:par>
+                      </p:childTnLst>
+                    </p:cTn>
+                  </p:par>
+                </p:childTnLst>
+              </p:cTn>
+              <p:prevCondLst>
+                <p:cond evt="onPrev" delay="0">
+                  <p:tgtEl>
+                    <p:sldTgt/>
+                  </p:tgtEl>
+                </p:cond>
+              </p:prevCondLst>
+              <p:nextCondLst>
+                <p:cond evt="onNext" delay="0">
+                  <p:tgtEl>
+                    <p:sldTgt/>
+                  </p:tgtEl>
+                </p:cond>
+              </p:nextCondLst>
+            </p:seq>
+          </p:childTnLst>
+        </p:cTn>
+      </p:par>
+    </p:tnLst>
+    <p:bldLst>
+      <p:bldP spid="7" grpId="0" animBg="1"/>
+      <p:bldP spid="8" grpId="0" animBg="1"/>
+      <p:bldP spid="9" grpId="0" animBg="1"/>
+      <p:bldP spid="10" grpId="0" animBg="1"/>
+    </p:bldLst>
+  </p:timing>
+</p:sld>
+</file>
+
+<file path=ppt/slides/slide28.xml><?xml version="1.0" encoding="utf-8"?>
+<p:sld xmlns:a="http://schemas.openxmlformats.org/drawingml/2006/main" xmlns:r="http://schemas.openxmlformats.org/officeDocument/2006/relationships" xmlns:p="http://schemas.openxmlformats.org/presentationml/2006/main">
+  <p:cSld>
+    <p:spTree>
+      <p:nvGrpSpPr>
+        <p:cNvPr id="1" name=""/>
+        <p:cNvGrpSpPr/>
+        <p:nvPr/>
+      </p:nvGrpSpPr>
+      <p:grpSpPr>
+        <a:xfrm>
+          <a:off x="0" y="0"/>
+          <a:ext cx="0" cy="0"/>
+          <a:chOff x="0" y="0"/>
+          <a:chExt cx="0" cy="0"/>
+        </a:xfrm>
+      </p:grpSpPr>
+      <p:sp>
+        <p:nvSpPr>
+          <p:cNvPr id="48" name="Rectangle 47">
+            <a:extLst>
+              <a:ext uri="{FF2B5EF4-FFF2-40B4-BE49-F238E27FC236}">
+                <a16:creationId xmlns:a16="http://schemas.microsoft.com/office/drawing/2014/main" id="{ED71B86B-BC2D-9047-8277-56342C96644B}"/>
+              </a:ext>
+            </a:extLst>
+          </p:cNvPr>
+          <p:cNvSpPr/>
+          <p:nvPr/>
+        </p:nvSpPr>
+        <p:spPr>
+          <a:xfrm>
+            <a:off x="185770" y="1223118"/>
+            <a:ext cx="11859994" cy="2772087"/>
+          </a:xfrm>
+          <a:prstGeom prst="rect">
+            <a:avLst/>
+          </a:prstGeom>
+          <a:solidFill>
+            <a:schemeClr val="accent2">
+              <a:lumMod val="20000"/>
+              <a:lumOff val="80000"/>
+            </a:schemeClr>
+          </a:solidFill>
+          <a:ln>
+            <a:noFill/>
+          </a:ln>
+        </p:spPr>
+        <p:style>
+          <a:lnRef idx="2">
+            <a:schemeClr val="accent1">
+              <a:shade val="50000"/>
+            </a:schemeClr>
+          </a:lnRef>
+          <a:fillRef idx="1">
+            <a:schemeClr val="accent1"/>
+          </a:fillRef>
+          <a:effectRef idx="0">
+            <a:schemeClr val="accent1"/>
+          </a:effectRef>
+          <a:fontRef idx="minor">
+            <a:schemeClr val="lt1"/>
+          </a:fontRef>
+        </p:style>
+        <p:txBody>
+          <a:bodyPr rtlCol="0" anchor="ctr"/>
+          <a:lstStyle/>
+          <a:p>
+            <a:pPr algn="ctr"/>
+            <a:endParaRPr lang="en-US"/>
+          </a:p>
+        </p:txBody>
+      </p:sp>
+      <p:sp>
+        <p:nvSpPr>
+          <p:cNvPr id="47" name="Rectangle 46">
+            <a:extLst>
+              <a:ext uri="{FF2B5EF4-FFF2-40B4-BE49-F238E27FC236}">
+                <a16:creationId xmlns:a16="http://schemas.microsoft.com/office/drawing/2014/main" id="{D78E196A-10A1-3D45-9865-B2B9D48AAD8B}"/>
+              </a:ext>
+            </a:extLst>
+          </p:cNvPr>
+          <p:cNvSpPr/>
+          <p:nvPr/>
+        </p:nvSpPr>
+        <p:spPr>
+          <a:xfrm>
+            <a:off x="166003" y="4019391"/>
+            <a:ext cx="11859994" cy="2772087"/>
+          </a:xfrm>
+          <a:prstGeom prst="rect">
+            <a:avLst/>
+          </a:prstGeom>
+          <a:solidFill>
+            <a:schemeClr val="accent6">
+              <a:lumMod val="20000"/>
+              <a:lumOff val="80000"/>
+            </a:schemeClr>
+          </a:solidFill>
+          <a:ln>
+            <a:noFill/>
+          </a:ln>
+        </p:spPr>
+        <p:style>
+          <a:lnRef idx="2">
+            <a:schemeClr val="accent1">
+              <a:shade val="50000"/>
+            </a:schemeClr>
+          </a:lnRef>
+          <a:fillRef idx="1">
+            <a:schemeClr val="accent1"/>
+          </a:fillRef>
+          <a:effectRef idx="0">
+            <a:schemeClr val="accent1"/>
+          </a:effectRef>
+          <a:fontRef idx="minor">
+            <a:schemeClr val="lt1"/>
+          </a:fontRef>
+        </p:style>
+        <p:txBody>
+          <a:bodyPr rtlCol="0" anchor="ctr"/>
+          <a:lstStyle/>
+          <a:p>
+            <a:pPr algn="ctr"/>
+            <a:endParaRPr lang="en-US"/>
+          </a:p>
+        </p:txBody>
+      </p:sp>
+      <p:sp>
+        <p:nvSpPr>
+          <p:cNvPr id="4" name="Slide Number Placeholder 3">
+            <a:extLst>
+              <a:ext uri="{FF2B5EF4-FFF2-40B4-BE49-F238E27FC236}">
+                <a16:creationId xmlns:a16="http://schemas.microsoft.com/office/drawing/2014/main" id="{4383861C-DDFF-F94F-B844-7188E07B1951}"/>
+              </a:ext>
+            </a:extLst>
+          </p:cNvPr>
+          <p:cNvSpPr>
+            <a:spLocks noGrp="1"/>
+          </p:cNvSpPr>
+          <p:nvPr>
+            <p:ph type="sldNum" sz="quarter" idx="12"/>
+          </p:nvPr>
+        </p:nvSpPr>
+        <p:spPr/>
+        <p:txBody>
+          <a:bodyPr/>
+          <a:lstStyle/>
+          <a:p>
+            <a:fld id="{1621B6DD-29C1-4FEA-923F-71EA1347694C}" type="slidenum">
+              <a:rPr lang="en-US" smtClean="0"/>
+              <a:t>27</a:t>
+            </a:fld>
+            <a:endParaRPr lang="en-US"/>
+          </a:p>
+        </p:txBody>
+      </p:sp>
+      <p:sp>
+        <p:nvSpPr>
+          <p:cNvPr id="6" name="Title 1">
+            <a:extLst>
+              <a:ext uri="{FF2B5EF4-FFF2-40B4-BE49-F238E27FC236}">
+                <a16:creationId xmlns:a16="http://schemas.microsoft.com/office/drawing/2014/main" id="{8BB2DFB4-E4EC-CC46-BF2B-90B0CB50A619}"/>
+              </a:ext>
+            </a:extLst>
+          </p:cNvPr>
+          <p:cNvSpPr txBox="1">
+            <a:spLocks/>
+          </p:cNvSpPr>
+          <p:nvPr/>
+        </p:nvSpPr>
+        <p:spPr>
+          <a:xfrm>
+            <a:off x="720000" y="619200"/>
+            <a:ext cx="10728322" cy="666675"/>
+          </a:xfrm>
+          <a:prstGeom prst="rect">
+            <a:avLst/>
+          </a:prstGeom>
+        </p:spPr>
+        <p:txBody>
+          <a:bodyPr vert="horz" lIns="91440" tIns="45720" rIns="91440" bIns="45720" rtlCol="0" anchor="ctr">
+            <a:normAutofit fontScale="97500" lnSpcReduction="10000"/>
+          </a:bodyPr>
+          <a:lstStyle>
+            <a:lvl1pPr algn="l" defTabSz="914400" rtl="0" eaLnBrk="1" latinLnBrk="0" hangingPunct="1">
+              <a:lnSpc>
+                <a:spcPct val="90000"/>
+              </a:lnSpc>
+              <a:spcBef>
+                <a:spcPct val="0"/>
+              </a:spcBef>
+              <a:buNone/>
+              <a:defRPr sz="4400" kern="1200">
+                <a:solidFill>
+                  <a:schemeClr val="tx1"/>
+                </a:solidFill>
+                <a:latin typeface="+mj-lt"/>
+                <a:ea typeface="+mj-ea"/>
+                <a:cs typeface="+mj-cs"/>
+              </a:defRPr>
+            </a:lvl1pPr>
+          </a:lstStyle>
+          <a:p>
+            <a:r>
+              <a:rPr lang="en-US" b="1" dirty="0">
+                <a:latin typeface="Times New Roman" panose="02020603050405020304" pitchFamily="18" charset="0"/>
+                <a:cs typeface="Times New Roman" panose="02020603050405020304" pitchFamily="18" charset="0"/>
+              </a:rPr>
+              <a:t>File 100A</a:t>
+            </a:r>
+          </a:p>
+        </p:txBody>
+      </p:sp>
+      <p:pic>
+        <p:nvPicPr>
+          <p:cNvPr id="18" name="Picture 17" descr="Chart, histogram&#10;&#10;Description automatically generated">
+            <a:extLst>
+              <a:ext uri="{FF2B5EF4-FFF2-40B4-BE49-F238E27FC236}">
+                <a16:creationId xmlns:a16="http://schemas.microsoft.com/office/drawing/2014/main" id="{95489256-47F2-BF44-BDFC-FA7090669E9D}"/>
+              </a:ext>
+            </a:extLst>
+          </p:cNvPr>
+          <p:cNvPicPr>
+            <a:picLocks noChangeAspect="1"/>
+          </p:cNvPicPr>
+          <p:nvPr/>
+        </p:nvPicPr>
+        <p:blipFill>
+          <a:blip r:embed="rId3"/>
+          <a:stretch>
+            <a:fillRect/>
+          </a:stretch>
+        </p:blipFill>
+        <p:spPr>
+          <a:xfrm>
+            <a:off x="4115264" y="4106331"/>
+            <a:ext cx="4027722" cy="2685148"/>
+          </a:xfrm>
+          <a:prstGeom prst="rect">
+            <a:avLst/>
+          </a:prstGeom>
+        </p:spPr>
+      </p:pic>
+      <p:pic>
+        <p:nvPicPr>
+          <p:cNvPr id="22" name="Picture 21" descr="Chart, histogram&#10;&#10;Description automatically generated">
+            <a:extLst>
+              <a:ext uri="{FF2B5EF4-FFF2-40B4-BE49-F238E27FC236}">
+                <a16:creationId xmlns:a16="http://schemas.microsoft.com/office/drawing/2014/main" id="{BEA2181E-EAEC-F347-80D6-7751373F5E5C}"/>
+              </a:ext>
+            </a:extLst>
+          </p:cNvPr>
+          <p:cNvPicPr>
+            <a:picLocks noChangeAspect="1"/>
+          </p:cNvPicPr>
+          <p:nvPr/>
+        </p:nvPicPr>
+        <p:blipFill>
+          <a:blip r:embed="rId4"/>
+          <a:stretch>
+            <a:fillRect/>
+          </a:stretch>
+        </p:blipFill>
+        <p:spPr>
+          <a:xfrm>
+            <a:off x="7998275" y="4110098"/>
+            <a:ext cx="4027722" cy="2685148"/>
+          </a:xfrm>
+          <a:prstGeom prst="rect">
+            <a:avLst/>
+          </a:prstGeom>
+        </p:spPr>
+      </p:pic>
+      <p:pic>
+        <p:nvPicPr>
+          <p:cNvPr id="26" name="Picture 25" descr="Chart&#10;&#10;Description automatically generated">
+            <a:extLst>
+              <a:ext uri="{FF2B5EF4-FFF2-40B4-BE49-F238E27FC236}">
+                <a16:creationId xmlns:a16="http://schemas.microsoft.com/office/drawing/2014/main" id="{827C3A6E-C342-AD4E-A8D7-5A8373465A5B}"/>
+              </a:ext>
+            </a:extLst>
+          </p:cNvPr>
+          <p:cNvPicPr>
+            <a:picLocks noChangeAspect="1"/>
+          </p:cNvPicPr>
+          <p:nvPr/>
+        </p:nvPicPr>
+        <p:blipFill>
+          <a:blip r:embed="rId5"/>
+          <a:stretch>
+            <a:fillRect/>
+          </a:stretch>
+        </p:blipFill>
+        <p:spPr>
+          <a:xfrm>
+            <a:off x="185770" y="4067763"/>
+            <a:ext cx="4185356" cy="2790237"/>
+          </a:xfrm>
+          <a:prstGeom prst="rect">
+            <a:avLst/>
+          </a:prstGeom>
+        </p:spPr>
+      </p:pic>
+      <p:pic>
+        <p:nvPicPr>
+          <p:cNvPr id="36" name="Picture 35" descr="Chart, bar chart&#10;&#10;Description automatically generated">
+            <a:extLst>
+              <a:ext uri="{FF2B5EF4-FFF2-40B4-BE49-F238E27FC236}">
+                <a16:creationId xmlns:a16="http://schemas.microsoft.com/office/drawing/2014/main" id="{EBF3E255-2A18-3143-9C31-70D177F0733F}"/>
+              </a:ext>
+            </a:extLst>
+          </p:cNvPr>
+          <p:cNvPicPr>
+            <a:picLocks noChangeAspect="1"/>
+          </p:cNvPicPr>
+          <p:nvPr/>
+        </p:nvPicPr>
+        <p:blipFill>
+          <a:blip r:embed="rId6"/>
+          <a:stretch>
+            <a:fillRect/>
+          </a:stretch>
+        </p:blipFill>
+        <p:spPr>
+          <a:xfrm>
+            <a:off x="185770" y="1244730"/>
+            <a:ext cx="4104141" cy="2736094"/>
+          </a:xfrm>
+          <a:prstGeom prst="rect">
+            <a:avLst/>
+          </a:prstGeom>
+        </p:spPr>
+      </p:pic>
+      <p:pic>
+        <p:nvPicPr>
+          <p:cNvPr id="38" name="Picture 37" descr="Chart, histogram&#10;&#10;Description automatically generated">
+            <a:extLst>
+              <a:ext uri="{FF2B5EF4-FFF2-40B4-BE49-F238E27FC236}">
+                <a16:creationId xmlns:a16="http://schemas.microsoft.com/office/drawing/2014/main" id="{E2229430-C6AC-FB4E-8AE2-51FAA7C72206}"/>
+              </a:ext>
+            </a:extLst>
+          </p:cNvPr>
+          <p:cNvPicPr>
+            <a:picLocks noChangeAspect="1"/>
+          </p:cNvPicPr>
+          <p:nvPr/>
+        </p:nvPicPr>
+        <p:blipFill>
+          <a:blip r:embed="rId7"/>
+          <a:stretch>
+            <a:fillRect/>
+          </a:stretch>
+        </p:blipFill>
+        <p:spPr>
+          <a:xfrm>
+            <a:off x="4140716" y="1329611"/>
+            <a:ext cx="3976819" cy="2651213"/>
+          </a:xfrm>
+          <a:prstGeom prst="rect">
+            <a:avLst/>
+          </a:prstGeom>
+        </p:spPr>
+      </p:pic>
+      <p:pic>
+        <p:nvPicPr>
+          <p:cNvPr id="46" name="Picture 45" descr="Chart, histogram&#10;&#10;Description automatically generated">
+            <a:extLst>
+              <a:ext uri="{FF2B5EF4-FFF2-40B4-BE49-F238E27FC236}">
+                <a16:creationId xmlns:a16="http://schemas.microsoft.com/office/drawing/2014/main" id="{EB35A27A-2051-1543-B964-8D1CD44D2D88}"/>
+              </a:ext>
+            </a:extLst>
+          </p:cNvPr>
+          <p:cNvPicPr>
+            <a:picLocks noChangeAspect="1"/>
+          </p:cNvPicPr>
+          <p:nvPr/>
+        </p:nvPicPr>
+        <p:blipFill>
+          <a:blip r:embed="rId8"/>
+          <a:stretch>
+            <a:fillRect/>
+          </a:stretch>
+        </p:blipFill>
+        <p:spPr>
+          <a:xfrm>
+            <a:off x="7968339" y="1334244"/>
+            <a:ext cx="4027722" cy="2685148"/>
+          </a:xfrm>
+          <a:prstGeom prst="rect">
+            <a:avLst/>
+          </a:prstGeom>
+        </p:spPr>
+      </p:pic>
+      <p:sp>
+        <p:nvSpPr>
+          <p:cNvPr id="49" name="Rectangle 48">
+            <a:extLst>
+              <a:ext uri="{FF2B5EF4-FFF2-40B4-BE49-F238E27FC236}">
+                <a16:creationId xmlns:a16="http://schemas.microsoft.com/office/drawing/2014/main" id="{88278AAC-7449-884D-A336-F515E54EDFFF}"/>
+              </a:ext>
+            </a:extLst>
+          </p:cNvPr>
+          <p:cNvSpPr/>
+          <p:nvPr/>
+        </p:nvSpPr>
+        <p:spPr>
+          <a:xfrm>
+            <a:off x="1851660" y="3657600"/>
+            <a:ext cx="902970" cy="295269"/>
+          </a:xfrm>
+          <a:prstGeom prst="rect">
+            <a:avLst/>
+          </a:prstGeom>
+          <a:noFill/>
+          <a:ln w="57150">
+            <a:solidFill>
+              <a:srgbClr val="C00000"/>
+            </a:solidFill>
+          </a:ln>
+        </p:spPr>
+        <p:style>
+          <a:lnRef idx="2">
+            <a:schemeClr val="accent1">
+              <a:shade val="50000"/>
+            </a:schemeClr>
+          </a:lnRef>
+          <a:fillRef idx="1">
+            <a:schemeClr val="accent1"/>
+          </a:fillRef>
+          <a:effectRef idx="0">
+            <a:schemeClr val="accent1"/>
+          </a:effectRef>
+          <a:fontRef idx="minor">
+            <a:schemeClr val="lt1"/>
+          </a:fontRef>
+        </p:style>
+        <p:txBody>
+          <a:bodyPr rtlCol="0" anchor="ctr"/>
+          <a:lstStyle/>
+          <a:p>
+            <a:pPr algn="ctr"/>
+            <a:endParaRPr lang="en-US"/>
+          </a:p>
+        </p:txBody>
+      </p:sp>
+      <p:sp>
+        <p:nvSpPr>
+          <p:cNvPr id="50" name="Rectangle 49">
+            <a:extLst>
+              <a:ext uri="{FF2B5EF4-FFF2-40B4-BE49-F238E27FC236}">
+                <a16:creationId xmlns:a16="http://schemas.microsoft.com/office/drawing/2014/main" id="{CF6BB9CF-2C8D-F64B-8901-04A6ECA672DA}"/>
+              </a:ext>
+            </a:extLst>
+          </p:cNvPr>
+          <p:cNvSpPr/>
+          <p:nvPr/>
+        </p:nvSpPr>
+        <p:spPr>
+          <a:xfrm>
+            <a:off x="1908810" y="6549390"/>
+            <a:ext cx="902970" cy="275349"/>
+          </a:xfrm>
+          <a:prstGeom prst="rect">
+            <a:avLst/>
+          </a:prstGeom>
+          <a:noFill/>
+          <a:ln w="57150">
+            <a:solidFill>
+              <a:srgbClr val="C00000"/>
+            </a:solidFill>
+          </a:ln>
+        </p:spPr>
+        <p:style>
+          <a:lnRef idx="2">
+            <a:schemeClr val="accent1">
+              <a:shade val="50000"/>
+            </a:schemeClr>
+          </a:lnRef>
+          <a:fillRef idx="1">
+            <a:schemeClr val="accent1"/>
+          </a:fillRef>
+          <a:effectRef idx="0">
+            <a:schemeClr val="accent1"/>
+          </a:effectRef>
+          <a:fontRef idx="minor">
+            <a:schemeClr val="lt1"/>
+          </a:fontRef>
+        </p:style>
+        <p:txBody>
+          <a:bodyPr rtlCol="0" anchor="ctr"/>
+          <a:lstStyle/>
+          <a:p>
+            <a:pPr algn="ctr"/>
+            <a:endParaRPr lang="en-US"/>
+          </a:p>
+        </p:txBody>
+      </p:sp>
+    </p:spTree>
+    <p:extLst>
+      <p:ext uri="{BB962C8B-B14F-4D97-AF65-F5344CB8AC3E}">
+        <p14:creationId xmlns:p14="http://schemas.microsoft.com/office/powerpoint/2010/main" val="2372763720"/>
+      </p:ext>
+    </p:extLst>
+  </p:cSld>
+  <p:clrMapOvr>
+    <a:masterClrMapping/>
+  </p:clrMapOvr>
+</p:sld>
+</file>
+
+<file path=ppt/slides/slide29.xml><?xml version="1.0" encoding="utf-8"?>
+<p:sld xmlns:a="http://schemas.openxmlformats.org/drawingml/2006/main" xmlns:r="http://schemas.openxmlformats.org/officeDocument/2006/relationships" xmlns:p="http://schemas.openxmlformats.org/presentationml/2006/main">
+  <p:cSld>
+    <p:spTree>
+      <p:nvGrpSpPr>
+        <p:cNvPr id="1" name=""/>
+        <p:cNvGrpSpPr/>
+        <p:nvPr/>
+      </p:nvGrpSpPr>
+      <p:grpSpPr>
+        <a:xfrm>
+          <a:off x="0" y="0"/>
+          <a:ext cx="0" cy="0"/>
+          <a:chOff x="0" y="0"/>
+          <a:chExt cx="0" cy="0"/>
+        </a:xfrm>
+      </p:grpSpPr>
+      <p:sp>
+        <p:nvSpPr>
+          <p:cNvPr id="48" name="Rectangle 47">
+            <a:extLst>
+              <a:ext uri="{FF2B5EF4-FFF2-40B4-BE49-F238E27FC236}">
+                <a16:creationId xmlns:a16="http://schemas.microsoft.com/office/drawing/2014/main" id="{ED71B86B-BC2D-9047-8277-56342C96644B}"/>
+              </a:ext>
+            </a:extLst>
+          </p:cNvPr>
+          <p:cNvSpPr/>
+          <p:nvPr/>
+        </p:nvSpPr>
+        <p:spPr>
+          <a:xfrm>
+            <a:off x="185770" y="1223118"/>
+            <a:ext cx="11859994" cy="2772087"/>
+          </a:xfrm>
+          <a:prstGeom prst="rect">
+            <a:avLst/>
+          </a:prstGeom>
+          <a:solidFill>
+            <a:schemeClr val="accent2">
+              <a:lumMod val="20000"/>
+              <a:lumOff val="80000"/>
+            </a:schemeClr>
+          </a:solidFill>
+          <a:ln>
+            <a:noFill/>
+          </a:ln>
+        </p:spPr>
+        <p:style>
+          <a:lnRef idx="2">
+            <a:schemeClr val="accent1">
+              <a:shade val="50000"/>
+            </a:schemeClr>
+          </a:lnRef>
+          <a:fillRef idx="1">
+            <a:schemeClr val="accent1"/>
+          </a:fillRef>
+          <a:effectRef idx="0">
+            <a:schemeClr val="accent1"/>
+          </a:effectRef>
+          <a:fontRef idx="minor">
+            <a:schemeClr val="lt1"/>
+          </a:fontRef>
+        </p:style>
+        <p:txBody>
+          <a:bodyPr rtlCol="0" anchor="ctr"/>
+          <a:lstStyle/>
+          <a:p>
+            <a:pPr algn="ctr"/>
+            <a:endParaRPr lang="en-US"/>
+          </a:p>
+        </p:txBody>
+      </p:sp>
+      <p:sp>
+        <p:nvSpPr>
+          <p:cNvPr id="47" name="Rectangle 46">
+            <a:extLst>
+              <a:ext uri="{FF2B5EF4-FFF2-40B4-BE49-F238E27FC236}">
+                <a16:creationId xmlns:a16="http://schemas.microsoft.com/office/drawing/2014/main" id="{D78E196A-10A1-3D45-9865-B2B9D48AAD8B}"/>
+              </a:ext>
+            </a:extLst>
+          </p:cNvPr>
+          <p:cNvSpPr/>
+          <p:nvPr/>
+        </p:nvSpPr>
+        <p:spPr>
+          <a:xfrm>
+            <a:off x="166003" y="4019391"/>
+            <a:ext cx="11859994" cy="2772087"/>
+          </a:xfrm>
+          <a:prstGeom prst="rect">
+            <a:avLst/>
+          </a:prstGeom>
+          <a:solidFill>
+            <a:schemeClr val="accent6">
+              <a:lumMod val="20000"/>
+              <a:lumOff val="80000"/>
+            </a:schemeClr>
+          </a:solidFill>
+          <a:ln>
+            <a:noFill/>
+          </a:ln>
+        </p:spPr>
+        <p:style>
+          <a:lnRef idx="2">
+            <a:schemeClr val="accent1">
+              <a:shade val="50000"/>
+            </a:schemeClr>
+          </a:lnRef>
+          <a:fillRef idx="1">
+            <a:schemeClr val="accent1"/>
+          </a:fillRef>
+          <a:effectRef idx="0">
+            <a:schemeClr val="accent1"/>
+          </a:effectRef>
+          <a:fontRef idx="minor">
+            <a:schemeClr val="lt1"/>
+          </a:fontRef>
+        </p:style>
+        <p:txBody>
+          <a:bodyPr rtlCol="0" anchor="ctr"/>
+          <a:lstStyle/>
+          <a:p>
+            <a:pPr algn="ctr"/>
+            <a:endParaRPr lang="en-US"/>
+          </a:p>
+        </p:txBody>
+      </p:sp>
+      <p:sp>
+        <p:nvSpPr>
+          <p:cNvPr id="4" name="Slide Number Placeholder 3">
+            <a:extLst>
+              <a:ext uri="{FF2B5EF4-FFF2-40B4-BE49-F238E27FC236}">
+                <a16:creationId xmlns:a16="http://schemas.microsoft.com/office/drawing/2014/main" id="{4383861C-DDFF-F94F-B844-7188E07B1951}"/>
+              </a:ext>
+            </a:extLst>
+          </p:cNvPr>
+          <p:cNvSpPr>
+            <a:spLocks noGrp="1"/>
+          </p:cNvSpPr>
+          <p:nvPr>
+            <p:ph type="sldNum" sz="quarter" idx="12"/>
+          </p:nvPr>
+        </p:nvSpPr>
+        <p:spPr/>
+        <p:txBody>
+          <a:bodyPr/>
+          <a:lstStyle/>
+          <a:p>
+            <a:fld id="{1621B6DD-29C1-4FEA-923F-71EA1347694C}" type="slidenum">
+              <a:rPr lang="en-US" smtClean="0"/>
+              <a:t>28</a:t>
+            </a:fld>
+            <a:endParaRPr lang="en-US"/>
+          </a:p>
+        </p:txBody>
+      </p:sp>
+      <p:sp>
+        <p:nvSpPr>
+          <p:cNvPr id="6" name="Title 1">
+            <a:extLst>
+              <a:ext uri="{FF2B5EF4-FFF2-40B4-BE49-F238E27FC236}">
+                <a16:creationId xmlns:a16="http://schemas.microsoft.com/office/drawing/2014/main" id="{8BB2DFB4-E4EC-CC46-BF2B-90B0CB50A619}"/>
+              </a:ext>
+            </a:extLst>
+          </p:cNvPr>
+          <p:cNvSpPr txBox="1">
+            <a:spLocks/>
+          </p:cNvSpPr>
+          <p:nvPr/>
+        </p:nvSpPr>
+        <p:spPr>
+          <a:xfrm>
+            <a:off x="720000" y="619200"/>
+            <a:ext cx="10728322" cy="666675"/>
+          </a:xfrm>
+          <a:prstGeom prst="rect">
+            <a:avLst/>
+          </a:prstGeom>
+        </p:spPr>
+        <p:txBody>
+          <a:bodyPr vert="horz" lIns="91440" tIns="45720" rIns="91440" bIns="45720" rtlCol="0" anchor="ctr">
+            <a:normAutofit fontScale="97500" lnSpcReduction="10000"/>
+          </a:bodyPr>
+          <a:lstStyle>
+            <a:lvl1pPr algn="l" defTabSz="914400" rtl="0" eaLnBrk="1" latinLnBrk="0" hangingPunct="1">
+              <a:lnSpc>
+                <a:spcPct val="90000"/>
+              </a:lnSpc>
+              <a:spcBef>
+                <a:spcPct val="0"/>
+              </a:spcBef>
+              <a:buNone/>
+              <a:defRPr sz="4400" kern="1200">
+                <a:solidFill>
+                  <a:schemeClr val="tx1"/>
+                </a:solidFill>
+                <a:latin typeface="+mj-lt"/>
+                <a:ea typeface="+mj-ea"/>
+                <a:cs typeface="+mj-cs"/>
+              </a:defRPr>
+            </a:lvl1pPr>
+          </a:lstStyle>
+          <a:p>
+            <a:r>
+              <a:rPr lang="en-US" b="1" dirty="0">
+                <a:latin typeface="Times New Roman" panose="02020603050405020304" pitchFamily="18" charset="0"/>
+                <a:cs typeface="Times New Roman" panose="02020603050405020304" pitchFamily="18" charset="0"/>
+              </a:rPr>
+              <a:t>File 100A</a:t>
+            </a:r>
+          </a:p>
+        </p:txBody>
+      </p:sp>
+      <p:pic>
+        <p:nvPicPr>
+          <p:cNvPr id="3" name="Picture 2" descr="Chart, waterfall chart&#10;&#10;Description automatically generated">
+            <a:extLst>
+              <a:ext uri="{FF2B5EF4-FFF2-40B4-BE49-F238E27FC236}">
+                <a16:creationId xmlns:a16="http://schemas.microsoft.com/office/drawing/2014/main" id="{F39FC88D-A1B8-3744-8F86-CFD0967311EC}"/>
+              </a:ext>
+            </a:extLst>
+          </p:cNvPr>
+          <p:cNvPicPr>
+            <a:picLocks noChangeAspect="1"/>
+          </p:cNvPicPr>
+          <p:nvPr/>
+        </p:nvPicPr>
+        <p:blipFill>
+          <a:blip r:embed="rId3"/>
+          <a:stretch>
+            <a:fillRect/>
+          </a:stretch>
+        </p:blipFill>
+        <p:spPr>
+          <a:xfrm>
+            <a:off x="1775359" y="4028366"/>
+            <a:ext cx="4039664" cy="2693109"/>
+          </a:xfrm>
+          <a:prstGeom prst="rect">
+            <a:avLst/>
+          </a:prstGeom>
+        </p:spPr>
+      </p:pic>
+      <p:pic>
+        <p:nvPicPr>
+          <p:cNvPr id="7" name="Picture 6" descr="Chart&#10;&#10;Description automatically generated">
+            <a:extLst>
+              <a:ext uri="{FF2B5EF4-FFF2-40B4-BE49-F238E27FC236}">
+                <a16:creationId xmlns:a16="http://schemas.microsoft.com/office/drawing/2014/main" id="{E0142D9B-528D-4B4E-9310-90DAA83FC995}"/>
+              </a:ext>
+            </a:extLst>
+          </p:cNvPr>
+          <p:cNvPicPr>
+            <a:picLocks noChangeAspect="1"/>
+          </p:cNvPicPr>
+          <p:nvPr/>
+        </p:nvPicPr>
+        <p:blipFill>
+          <a:blip r:embed="rId4"/>
+          <a:stretch>
+            <a:fillRect/>
+          </a:stretch>
+        </p:blipFill>
+        <p:spPr>
+          <a:xfrm>
+            <a:off x="1656892" y="1195289"/>
+            <a:ext cx="4158131" cy="2772087"/>
+          </a:xfrm>
+          <a:prstGeom prst="rect">
+            <a:avLst/>
+          </a:prstGeom>
+        </p:spPr>
+      </p:pic>
+      <p:pic>
+        <p:nvPicPr>
+          <p:cNvPr id="9" name="Picture 8" descr="Chart, scatter chart&#10;&#10;Description automatically generated">
+            <a:extLst>
+              <a:ext uri="{FF2B5EF4-FFF2-40B4-BE49-F238E27FC236}">
+                <a16:creationId xmlns:a16="http://schemas.microsoft.com/office/drawing/2014/main" id="{061638B9-2092-A54C-8A1E-A083607496D1}"/>
+              </a:ext>
+            </a:extLst>
+          </p:cNvPr>
+          <p:cNvPicPr>
+            <a:picLocks noChangeAspect="1"/>
+          </p:cNvPicPr>
+          <p:nvPr/>
+        </p:nvPicPr>
+        <p:blipFill>
+          <a:blip r:embed="rId5"/>
+          <a:stretch>
+            <a:fillRect/>
+          </a:stretch>
+        </p:blipFill>
+        <p:spPr>
+          <a:xfrm>
+            <a:off x="6412465" y="4078482"/>
+            <a:ext cx="4396270" cy="2653904"/>
+          </a:xfrm>
+          <a:prstGeom prst="rect">
+            <a:avLst/>
+          </a:prstGeom>
+        </p:spPr>
+      </p:pic>
+      <p:pic>
+        <p:nvPicPr>
+          <p:cNvPr id="11" name="Picture 10" descr="Chart, scatter chart&#10;&#10;Description automatically generated">
+            <a:extLst>
+              <a:ext uri="{FF2B5EF4-FFF2-40B4-BE49-F238E27FC236}">
+                <a16:creationId xmlns:a16="http://schemas.microsoft.com/office/drawing/2014/main" id="{291E5E7F-D376-3247-986D-6B28BC9F7A64}"/>
+              </a:ext>
+            </a:extLst>
+          </p:cNvPr>
+          <p:cNvPicPr>
+            <a:picLocks noChangeAspect="1"/>
+          </p:cNvPicPr>
+          <p:nvPr/>
+        </p:nvPicPr>
+        <p:blipFill>
+          <a:blip r:embed="rId6"/>
+          <a:stretch>
+            <a:fillRect/>
+          </a:stretch>
+        </p:blipFill>
+        <p:spPr>
+          <a:xfrm>
+            <a:off x="6376979" y="1282209"/>
+            <a:ext cx="4396270" cy="2653904"/>
+          </a:xfrm>
+          <a:prstGeom prst="rect">
+            <a:avLst/>
+          </a:prstGeom>
+        </p:spPr>
+      </p:pic>
+    </p:spTree>
+    <p:extLst>
+      <p:ext uri="{BB962C8B-B14F-4D97-AF65-F5344CB8AC3E}">
+        <p14:creationId xmlns:p14="http://schemas.microsoft.com/office/powerpoint/2010/main" val="721295254"/>
+      </p:ext>
+    </p:extLst>
+  </p:cSld>
+  <p:clrMapOvr>
+    <a:masterClrMapping/>
+  </p:clrMapOvr>
+</p:sld>
+</file>
+
 <file path=ppt/slides/slide3.xml><?xml version="1.0" encoding="utf-8"?>
 <p:sld xmlns:a="http://schemas.openxmlformats.org/drawingml/2006/main" xmlns:r="http://schemas.openxmlformats.org/officeDocument/2006/relationships" xmlns:p="http://schemas.openxmlformats.org/presentationml/2006/main">
   <p:cSld>
@@ -27490,6 +30882,862 @@
     <p:extLst>
       <p:ext uri="{BB962C8B-B14F-4D97-AF65-F5344CB8AC3E}">
         <p14:creationId xmlns:p14="http://schemas.microsoft.com/office/powerpoint/2010/main" val="4281871720"/>
+      </p:ext>
+    </p:extLst>
+  </p:cSld>
+  <p:clrMapOvr>
+    <a:masterClrMapping/>
+  </p:clrMapOvr>
+</p:sld>
+</file>
+
+<file path=ppt/slides/slide30.xml><?xml version="1.0" encoding="utf-8"?>
+<p:sld xmlns:a="http://schemas.openxmlformats.org/drawingml/2006/main" xmlns:r="http://schemas.openxmlformats.org/officeDocument/2006/relationships" xmlns:p="http://schemas.openxmlformats.org/presentationml/2006/main">
+  <p:cSld>
+    <p:spTree>
+      <p:nvGrpSpPr>
+        <p:cNvPr id="1" name=""/>
+        <p:cNvGrpSpPr/>
+        <p:nvPr/>
+      </p:nvGrpSpPr>
+      <p:grpSpPr>
+        <a:xfrm>
+          <a:off x="0" y="0"/>
+          <a:ext cx="0" cy="0"/>
+          <a:chOff x="0" y="0"/>
+          <a:chExt cx="0" cy="0"/>
+        </a:xfrm>
+      </p:grpSpPr>
+      <p:sp>
+        <p:nvSpPr>
+          <p:cNvPr id="48" name="Rectangle 47">
+            <a:extLst>
+              <a:ext uri="{FF2B5EF4-FFF2-40B4-BE49-F238E27FC236}">
+                <a16:creationId xmlns:a16="http://schemas.microsoft.com/office/drawing/2014/main" id="{ED71B86B-BC2D-9047-8277-56342C96644B}"/>
+              </a:ext>
+            </a:extLst>
+          </p:cNvPr>
+          <p:cNvSpPr/>
+          <p:nvPr/>
+        </p:nvSpPr>
+        <p:spPr>
+          <a:xfrm>
+            <a:off x="185770" y="1223118"/>
+            <a:ext cx="11859994" cy="2772087"/>
+          </a:xfrm>
+          <a:prstGeom prst="rect">
+            <a:avLst/>
+          </a:prstGeom>
+          <a:solidFill>
+            <a:schemeClr val="accent2">
+              <a:lumMod val="20000"/>
+              <a:lumOff val="80000"/>
+            </a:schemeClr>
+          </a:solidFill>
+          <a:ln>
+            <a:noFill/>
+          </a:ln>
+        </p:spPr>
+        <p:style>
+          <a:lnRef idx="2">
+            <a:schemeClr val="accent1">
+              <a:shade val="50000"/>
+            </a:schemeClr>
+          </a:lnRef>
+          <a:fillRef idx="1">
+            <a:schemeClr val="accent1"/>
+          </a:fillRef>
+          <a:effectRef idx="0">
+            <a:schemeClr val="accent1"/>
+          </a:effectRef>
+          <a:fontRef idx="minor">
+            <a:schemeClr val="lt1"/>
+          </a:fontRef>
+        </p:style>
+        <p:txBody>
+          <a:bodyPr rtlCol="0" anchor="ctr"/>
+          <a:lstStyle/>
+          <a:p>
+            <a:pPr algn="ctr"/>
+            <a:endParaRPr lang="en-US"/>
+          </a:p>
+        </p:txBody>
+      </p:sp>
+      <p:sp>
+        <p:nvSpPr>
+          <p:cNvPr id="47" name="Rectangle 46">
+            <a:extLst>
+              <a:ext uri="{FF2B5EF4-FFF2-40B4-BE49-F238E27FC236}">
+                <a16:creationId xmlns:a16="http://schemas.microsoft.com/office/drawing/2014/main" id="{D78E196A-10A1-3D45-9865-B2B9D48AAD8B}"/>
+              </a:ext>
+            </a:extLst>
+          </p:cNvPr>
+          <p:cNvSpPr/>
+          <p:nvPr/>
+        </p:nvSpPr>
+        <p:spPr>
+          <a:xfrm>
+            <a:off x="166003" y="4019391"/>
+            <a:ext cx="11859994" cy="2772087"/>
+          </a:xfrm>
+          <a:prstGeom prst="rect">
+            <a:avLst/>
+          </a:prstGeom>
+          <a:solidFill>
+            <a:schemeClr val="accent6">
+              <a:lumMod val="20000"/>
+              <a:lumOff val="80000"/>
+            </a:schemeClr>
+          </a:solidFill>
+          <a:ln>
+            <a:noFill/>
+          </a:ln>
+        </p:spPr>
+        <p:style>
+          <a:lnRef idx="2">
+            <a:schemeClr val="accent1">
+              <a:shade val="50000"/>
+            </a:schemeClr>
+          </a:lnRef>
+          <a:fillRef idx="1">
+            <a:schemeClr val="accent1"/>
+          </a:fillRef>
+          <a:effectRef idx="0">
+            <a:schemeClr val="accent1"/>
+          </a:effectRef>
+          <a:fontRef idx="minor">
+            <a:schemeClr val="lt1"/>
+          </a:fontRef>
+        </p:style>
+        <p:txBody>
+          <a:bodyPr rtlCol="0" anchor="ctr"/>
+          <a:lstStyle/>
+          <a:p>
+            <a:pPr algn="ctr"/>
+            <a:endParaRPr lang="en-US"/>
+          </a:p>
+        </p:txBody>
+      </p:sp>
+      <p:sp>
+        <p:nvSpPr>
+          <p:cNvPr id="4" name="Slide Number Placeholder 3">
+            <a:extLst>
+              <a:ext uri="{FF2B5EF4-FFF2-40B4-BE49-F238E27FC236}">
+                <a16:creationId xmlns:a16="http://schemas.microsoft.com/office/drawing/2014/main" id="{4383861C-DDFF-F94F-B844-7188E07B1951}"/>
+              </a:ext>
+            </a:extLst>
+          </p:cNvPr>
+          <p:cNvSpPr>
+            <a:spLocks noGrp="1"/>
+          </p:cNvSpPr>
+          <p:nvPr>
+            <p:ph type="sldNum" sz="quarter" idx="12"/>
+          </p:nvPr>
+        </p:nvSpPr>
+        <p:spPr/>
+        <p:txBody>
+          <a:bodyPr/>
+          <a:lstStyle/>
+          <a:p>
+            <a:fld id="{1621B6DD-29C1-4FEA-923F-71EA1347694C}" type="slidenum">
+              <a:rPr lang="en-US" smtClean="0"/>
+              <a:t>29</a:t>
+            </a:fld>
+            <a:endParaRPr lang="en-US"/>
+          </a:p>
+        </p:txBody>
+      </p:sp>
+      <p:sp>
+        <p:nvSpPr>
+          <p:cNvPr id="6" name="Title 1">
+            <a:extLst>
+              <a:ext uri="{FF2B5EF4-FFF2-40B4-BE49-F238E27FC236}">
+                <a16:creationId xmlns:a16="http://schemas.microsoft.com/office/drawing/2014/main" id="{8BB2DFB4-E4EC-CC46-BF2B-90B0CB50A619}"/>
+              </a:ext>
+            </a:extLst>
+          </p:cNvPr>
+          <p:cNvSpPr txBox="1">
+            <a:spLocks/>
+          </p:cNvSpPr>
+          <p:nvPr/>
+        </p:nvSpPr>
+        <p:spPr>
+          <a:xfrm>
+            <a:off x="720000" y="619200"/>
+            <a:ext cx="10728322" cy="666675"/>
+          </a:xfrm>
+          <a:prstGeom prst="rect">
+            <a:avLst/>
+          </a:prstGeom>
+        </p:spPr>
+        <p:txBody>
+          <a:bodyPr vert="horz" lIns="91440" tIns="45720" rIns="91440" bIns="45720" rtlCol="0" anchor="ctr">
+            <a:normAutofit fontScale="97500" lnSpcReduction="10000"/>
+          </a:bodyPr>
+          <a:lstStyle>
+            <a:lvl1pPr algn="l" defTabSz="914400" rtl="0" eaLnBrk="1" latinLnBrk="0" hangingPunct="1">
+              <a:lnSpc>
+                <a:spcPct val="90000"/>
+              </a:lnSpc>
+              <a:spcBef>
+                <a:spcPct val="0"/>
+              </a:spcBef>
+              <a:buNone/>
+              <a:defRPr sz="4400" kern="1200">
+                <a:solidFill>
+                  <a:schemeClr val="tx1"/>
+                </a:solidFill>
+                <a:latin typeface="+mj-lt"/>
+                <a:ea typeface="+mj-ea"/>
+                <a:cs typeface="+mj-cs"/>
+              </a:defRPr>
+            </a:lvl1pPr>
+          </a:lstStyle>
+          <a:p>
+            <a:r>
+              <a:rPr lang="en-US" b="1" dirty="0">
+                <a:latin typeface="Times New Roman" panose="02020603050405020304" pitchFamily="18" charset="0"/>
+                <a:cs typeface="Times New Roman" panose="02020603050405020304" pitchFamily="18" charset="0"/>
+              </a:rPr>
+              <a:t>File 101</a:t>
+            </a:r>
+          </a:p>
+        </p:txBody>
+      </p:sp>
+      <p:pic>
+        <p:nvPicPr>
+          <p:cNvPr id="3" name="Picture 2" descr="Chart, bar chart&#10;&#10;Description automatically generated">
+            <a:extLst>
+              <a:ext uri="{FF2B5EF4-FFF2-40B4-BE49-F238E27FC236}">
+                <a16:creationId xmlns:a16="http://schemas.microsoft.com/office/drawing/2014/main" id="{C42CFE0A-BEDF-C946-9D0B-671F37F09CB6}"/>
+              </a:ext>
+            </a:extLst>
+          </p:cNvPr>
+          <p:cNvPicPr>
+            <a:picLocks noChangeAspect="1"/>
+          </p:cNvPicPr>
+          <p:nvPr/>
+        </p:nvPicPr>
+        <p:blipFill>
+          <a:blip r:embed="rId3"/>
+          <a:stretch>
+            <a:fillRect/>
+          </a:stretch>
+        </p:blipFill>
+        <p:spPr>
+          <a:xfrm>
+            <a:off x="400094" y="1378526"/>
+            <a:ext cx="3868829" cy="2579219"/>
+          </a:xfrm>
+          <a:prstGeom prst="rect">
+            <a:avLst/>
+          </a:prstGeom>
+        </p:spPr>
+      </p:pic>
+      <p:pic>
+        <p:nvPicPr>
+          <p:cNvPr id="7" name="Picture 6" descr="Chart, histogram&#10;&#10;Description automatically generated">
+            <a:extLst>
+              <a:ext uri="{FF2B5EF4-FFF2-40B4-BE49-F238E27FC236}">
+                <a16:creationId xmlns:a16="http://schemas.microsoft.com/office/drawing/2014/main" id="{6E598A11-EBD0-C149-A63B-39AFD03D2E9D}"/>
+              </a:ext>
+            </a:extLst>
+          </p:cNvPr>
+          <p:cNvPicPr>
+            <a:picLocks noChangeAspect="1"/>
+          </p:cNvPicPr>
+          <p:nvPr/>
+        </p:nvPicPr>
+        <p:blipFill>
+          <a:blip r:embed="rId4"/>
+          <a:stretch>
+            <a:fillRect/>
+          </a:stretch>
+        </p:blipFill>
+        <p:spPr>
+          <a:xfrm>
+            <a:off x="4166226" y="1310061"/>
+            <a:ext cx="3971527" cy="2647684"/>
+          </a:xfrm>
+          <a:prstGeom prst="rect">
+            <a:avLst/>
+          </a:prstGeom>
+        </p:spPr>
+      </p:pic>
+      <p:pic>
+        <p:nvPicPr>
+          <p:cNvPr id="9" name="Picture 8" descr="Chart, histogram&#10;&#10;Description automatically generated">
+            <a:extLst>
+              <a:ext uri="{FF2B5EF4-FFF2-40B4-BE49-F238E27FC236}">
+                <a16:creationId xmlns:a16="http://schemas.microsoft.com/office/drawing/2014/main" id="{CD529632-C68C-D748-A4A6-F64A1954DDED}"/>
+              </a:ext>
+            </a:extLst>
+          </p:cNvPr>
+          <p:cNvPicPr>
+            <a:picLocks noChangeAspect="1"/>
+          </p:cNvPicPr>
+          <p:nvPr/>
+        </p:nvPicPr>
+        <p:blipFill>
+          <a:blip r:embed="rId5"/>
+          <a:stretch>
+            <a:fillRect/>
+          </a:stretch>
+        </p:blipFill>
+        <p:spPr>
+          <a:xfrm>
+            <a:off x="8047785" y="1310061"/>
+            <a:ext cx="3868830" cy="2579220"/>
+          </a:xfrm>
+          <a:prstGeom prst="rect">
+            <a:avLst/>
+          </a:prstGeom>
+        </p:spPr>
+      </p:pic>
+      <p:pic>
+        <p:nvPicPr>
+          <p:cNvPr id="11" name="Picture 10" descr="Chart, waterfall chart&#10;&#10;Description automatically generated">
+            <a:extLst>
+              <a:ext uri="{FF2B5EF4-FFF2-40B4-BE49-F238E27FC236}">
+                <a16:creationId xmlns:a16="http://schemas.microsoft.com/office/drawing/2014/main" id="{EF9A7ED5-A79A-E04F-98DC-15662C37681E}"/>
+              </a:ext>
+            </a:extLst>
+          </p:cNvPr>
+          <p:cNvPicPr>
+            <a:picLocks noChangeAspect="1"/>
+          </p:cNvPicPr>
+          <p:nvPr/>
+        </p:nvPicPr>
+        <p:blipFill>
+          <a:blip r:embed="rId6"/>
+          <a:stretch>
+            <a:fillRect/>
+          </a:stretch>
+        </p:blipFill>
+        <p:spPr>
+          <a:xfrm>
+            <a:off x="255442" y="4064888"/>
+            <a:ext cx="4158131" cy="2772087"/>
+          </a:xfrm>
+          <a:prstGeom prst="rect">
+            <a:avLst/>
+          </a:prstGeom>
+        </p:spPr>
+      </p:pic>
+      <p:pic>
+        <p:nvPicPr>
+          <p:cNvPr id="13" name="Picture 12" descr="Chart, histogram&#10;&#10;Description automatically generated">
+            <a:extLst>
+              <a:ext uri="{FF2B5EF4-FFF2-40B4-BE49-F238E27FC236}">
+                <a16:creationId xmlns:a16="http://schemas.microsoft.com/office/drawing/2014/main" id="{C4364D33-36C3-A643-A54E-130C2F280561}"/>
+              </a:ext>
+            </a:extLst>
+          </p:cNvPr>
+          <p:cNvPicPr>
+            <a:picLocks noChangeAspect="1"/>
+          </p:cNvPicPr>
+          <p:nvPr/>
+        </p:nvPicPr>
+        <p:blipFill>
+          <a:blip r:embed="rId7"/>
+          <a:stretch>
+            <a:fillRect/>
+          </a:stretch>
+        </p:blipFill>
+        <p:spPr>
+          <a:xfrm>
+            <a:off x="4311875" y="4143793"/>
+            <a:ext cx="3971527" cy="2647685"/>
+          </a:xfrm>
+          <a:prstGeom prst="rect">
+            <a:avLst/>
+          </a:prstGeom>
+        </p:spPr>
+      </p:pic>
+      <p:pic>
+        <p:nvPicPr>
+          <p:cNvPr id="15" name="Picture 14" descr="Chart, histogram&#10;&#10;Description automatically generated">
+            <a:extLst>
+              <a:ext uri="{FF2B5EF4-FFF2-40B4-BE49-F238E27FC236}">
+                <a16:creationId xmlns:a16="http://schemas.microsoft.com/office/drawing/2014/main" id="{7A481926-E41F-A145-9C03-0EEB19CA034B}"/>
+              </a:ext>
+            </a:extLst>
+          </p:cNvPr>
+          <p:cNvPicPr>
+            <a:picLocks noChangeAspect="1"/>
+          </p:cNvPicPr>
+          <p:nvPr/>
+        </p:nvPicPr>
+        <p:blipFill>
+          <a:blip r:embed="rId8"/>
+          <a:stretch>
+            <a:fillRect/>
+          </a:stretch>
+        </p:blipFill>
+        <p:spPr>
+          <a:xfrm>
+            <a:off x="8212630" y="4170772"/>
+            <a:ext cx="3703985" cy="2469323"/>
+          </a:xfrm>
+          <a:prstGeom prst="rect">
+            <a:avLst/>
+          </a:prstGeom>
+        </p:spPr>
+      </p:pic>
+      <p:sp>
+        <p:nvSpPr>
+          <p:cNvPr id="27" name="Rectangle 26">
+            <a:extLst>
+              <a:ext uri="{FF2B5EF4-FFF2-40B4-BE49-F238E27FC236}">
+                <a16:creationId xmlns:a16="http://schemas.microsoft.com/office/drawing/2014/main" id="{DAE92C06-EE9B-0242-889B-0E04AAA0AAC9}"/>
+              </a:ext>
+            </a:extLst>
+          </p:cNvPr>
+          <p:cNvSpPr/>
+          <p:nvPr/>
+        </p:nvSpPr>
+        <p:spPr>
+          <a:xfrm>
+            <a:off x="1960862" y="3662476"/>
+            <a:ext cx="902970" cy="295269"/>
+          </a:xfrm>
+          <a:prstGeom prst="rect">
+            <a:avLst/>
+          </a:prstGeom>
+          <a:noFill/>
+          <a:ln w="57150">
+            <a:solidFill>
+              <a:srgbClr val="C00000"/>
+            </a:solidFill>
+          </a:ln>
+        </p:spPr>
+        <p:style>
+          <a:lnRef idx="2">
+            <a:schemeClr val="accent1">
+              <a:shade val="50000"/>
+            </a:schemeClr>
+          </a:lnRef>
+          <a:fillRef idx="1">
+            <a:schemeClr val="accent1"/>
+          </a:fillRef>
+          <a:effectRef idx="0">
+            <a:schemeClr val="accent1"/>
+          </a:effectRef>
+          <a:fontRef idx="minor">
+            <a:schemeClr val="lt1"/>
+          </a:fontRef>
+        </p:style>
+        <p:txBody>
+          <a:bodyPr rtlCol="0" anchor="ctr"/>
+          <a:lstStyle/>
+          <a:p>
+            <a:pPr algn="ctr"/>
+            <a:endParaRPr lang="en-US"/>
+          </a:p>
+        </p:txBody>
+      </p:sp>
+      <p:sp>
+        <p:nvSpPr>
+          <p:cNvPr id="28" name="Rectangle 27">
+            <a:extLst>
+              <a:ext uri="{FF2B5EF4-FFF2-40B4-BE49-F238E27FC236}">
+                <a16:creationId xmlns:a16="http://schemas.microsoft.com/office/drawing/2014/main" id="{2B9FFC93-6B78-6A4B-8DD1-1335EA7A1020}"/>
+              </a:ext>
+            </a:extLst>
+          </p:cNvPr>
+          <p:cNvSpPr/>
+          <p:nvPr/>
+        </p:nvSpPr>
+        <p:spPr>
+          <a:xfrm>
+            <a:off x="1960862" y="6516129"/>
+            <a:ext cx="902970" cy="275349"/>
+          </a:xfrm>
+          <a:prstGeom prst="rect">
+            <a:avLst/>
+          </a:prstGeom>
+          <a:noFill/>
+          <a:ln w="57150">
+            <a:solidFill>
+              <a:srgbClr val="C00000"/>
+            </a:solidFill>
+          </a:ln>
+        </p:spPr>
+        <p:style>
+          <a:lnRef idx="2">
+            <a:schemeClr val="accent1">
+              <a:shade val="50000"/>
+            </a:schemeClr>
+          </a:lnRef>
+          <a:fillRef idx="1">
+            <a:schemeClr val="accent1"/>
+          </a:fillRef>
+          <a:effectRef idx="0">
+            <a:schemeClr val="accent1"/>
+          </a:effectRef>
+          <a:fontRef idx="minor">
+            <a:schemeClr val="lt1"/>
+          </a:fontRef>
+        </p:style>
+        <p:txBody>
+          <a:bodyPr rtlCol="0" anchor="ctr"/>
+          <a:lstStyle/>
+          <a:p>
+            <a:pPr algn="ctr"/>
+            <a:endParaRPr lang="en-US"/>
+          </a:p>
+        </p:txBody>
+      </p:sp>
+    </p:spTree>
+    <p:extLst>
+      <p:ext uri="{BB962C8B-B14F-4D97-AF65-F5344CB8AC3E}">
+        <p14:creationId xmlns:p14="http://schemas.microsoft.com/office/powerpoint/2010/main" val="3639131346"/>
+      </p:ext>
+    </p:extLst>
+  </p:cSld>
+  <p:clrMapOvr>
+    <a:masterClrMapping/>
+  </p:clrMapOvr>
+</p:sld>
+</file>
+
+<file path=ppt/slides/slide31.xml><?xml version="1.0" encoding="utf-8"?>
+<p:sld xmlns:a="http://schemas.openxmlformats.org/drawingml/2006/main" xmlns:r="http://schemas.openxmlformats.org/officeDocument/2006/relationships" xmlns:p="http://schemas.openxmlformats.org/presentationml/2006/main">
+  <p:cSld>
+    <p:spTree>
+      <p:nvGrpSpPr>
+        <p:cNvPr id="1" name=""/>
+        <p:cNvGrpSpPr/>
+        <p:nvPr/>
+      </p:nvGrpSpPr>
+      <p:grpSpPr>
+        <a:xfrm>
+          <a:off x="0" y="0"/>
+          <a:ext cx="0" cy="0"/>
+          <a:chOff x="0" y="0"/>
+          <a:chExt cx="0" cy="0"/>
+        </a:xfrm>
+      </p:grpSpPr>
+      <p:sp>
+        <p:nvSpPr>
+          <p:cNvPr id="48" name="Rectangle 47">
+            <a:extLst>
+              <a:ext uri="{FF2B5EF4-FFF2-40B4-BE49-F238E27FC236}">
+                <a16:creationId xmlns:a16="http://schemas.microsoft.com/office/drawing/2014/main" id="{ED71B86B-BC2D-9047-8277-56342C96644B}"/>
+              </a:ext>
+            </a:extLst>
+          </p:cNvPr>
+          <p:cNvSpPr/>
+          <p:nvPr/>
+        </p:nvSpPr>
+        <p:spPr>
+          <a:xfrm>
+            <a:off x="185770" y="1223118"/>
+            <a:ext cx="11859994" cy="2772087"/>
+          </a:xfrm>
+          <a:prstGeom prst="rect">
+            <a:avLst/>
+          </a:prstGeom>
+          <a:solidFill>
+            <a:schemeClr val="accent2">
+              <a:lumMod val="20000"/>
+              <a:lumOff val="80000"/>
+            </a:schemeClr>
+          </a:solidFill>
+          <a:ln>
+            <a:noFill/>
+          </a:ln>
+        </p:spPr>
+        <p:style>
+          <a:lnRef idx="2">
+            <a:schemeClr val="accent1">
+              <a:shade val="50000"/>
+            </a:schemeClr>
+          </a:lnRef>
+          <a:fillRef idx="1">
+            <a:schemeClr val="accent1"/>
+          </a:fillRef>
+          <a:effectRef idx="0">
+            <a:schemeClr val="accent1"/>
+          </a:effectRef>
+          <a:fontRef idx="minor">
+            <a:schemeClr val="lt1"/>
+          </a:fontRef>
+        </p:style>
+        <p:txBody>
+          <a:bodyPr rtlCol="0" anchor="ctr"/>
+          <a:lstStyle/>
+          <a:p>
+            <a:pPr algn="ctr"/>
+            <a:endParaRPr lang="en-US"/>
+          </a:p>
+        </p:txBody>
+      </p:sp>
+      <p:sp>
+        <p:nvSpPr>
+          <p:cNvPr id="47" name="Rectangle 46">
+            <a:extLst>
+              <a:ext uri="{FF2B5EF4-FFF2-40B4-BE49-F238E27FC236}">
+                <a16:creationId xmlns:a16="http://schemas.microsoft.com/office/drawing/2014/main" id="{D78E196A-10A1-3D45-9865-B2B9D48AAD8B}"/>
+              </a:ext>
+            </a:extLst>
+          </p:cNvPr>
+          <p:cNvSpPr/>
+          <p:nvPr/>
+        </p:nvSpPr>
+        <p:spPr>
+          <a:xfrm>
+            <a:off x="166003" y="4019391"/>
+            <a:ext cx="11859994" cy="2772087"/>
+          </a:xfrm>
+          <a:prstGeom prst="rect">
+            <a:avLst/>
+          </a:prstGeom>
+          <a:solidFill>
+            <a:schemeClr val="accent6">
+              <a:lumMod val="20000"/>
+              <a:lumOff val="80000"/>
+            </a:schemeClr>
+          </a:solidFill>
+          <a:ln>
+            <a:noFill/>
+          </a:ln>
+        </p:spPr>
+        <p:style>
+          <a:lnRef idx="2">
+            <a:schemeClr val="accent1">
+              <a:shade val="50000"/>
+            </a:schemeClr>
+          </a:lnRef>
+          <a:fillRef idx="1">
+            <a:schemeClr val="accent1"/>
+          </a:fillRef>
+          <a:effectRef idx="0">
+            <a:schemeClr val="accent1"/>
+          </a:effectRef>
+          <a:fontRef idx="minor">
+            <a:schemeClr val="lt1"/>
+          </a:fontRef>
+        </p:style>
+        <p:txBody>
+          <a:bodyPr rtlCol="0" anchor="ctr"/>
+          <a:lstStyle/>
+          <a:p>
+            <a:pPr algn="ctr"/>
+            <a:endParaRPr lang="en-US"/>
+          </a:p>
+        </p:txBody>
+      </p:sp>
+      <p:sp>
+        <p:nvSpPr>
+          <p:cNvPr id="4" name="Slide Number Placeholder 3">
+            <a:extLst>
+              <a:ext uri="{FF2B5EF4-FFF2-40B4-BE49-F238E27FC236}">
+                <a16:creationId xmlns:a16="http://schemas.microsoft.com/office/drawing/2014/main" id="{4383861C-DDFF-F94F-B844-7188E07B1951}"/>
+              </a:ext>
+            </a:extLst>
+          </p:cNvPr>
+          <p:cNvSpPr>
+            <a:spLocks noGrp="1"/>
+          </p:cNvSpPr>
+          <p:nvPr>
+            <p:ph type="sldNum" sz="quarter" idx="12"/>
+          </p:nvPr>
+        </p:nvSpPr>
+        <p:spPr/>
+        <p:txBody>
+          <a:bodyPr/>
+          <a:lstStyle/>
+          <a:p>
+            <a:fld id="{1621B6DD-29C1-4FEA-923F-71EA1347694C}" type="slidenum">
+              <a:rPr lang="en-US" smtClean="0"/>
+              <a:t>30</a:t>
+            </a:fld>
+            <a:endParaRPr lang="en-US"/>
+          </a:p>
+        </p:txBody>
+      </p:sp>
+      <p:sp>
+        <p:nvSpPr>
+          <p:cNvPr id="6" name="Title 1">
+            <a:extLst>
+              <a:ext uri="{FF2B5EF4-FFF2-40B4-BE49-F238E27FC236}">
+                <a16:creationId xmlns:a16="http://schemas.microsoft.com/office/drawing/2014/main" id="{8BB2DFB4-E4EC-CC46-BF2B-90B0CB50A619}"/>
+              </a:ext>
+            </a:extLst>
+          </p:cNvPr>
+          <p:cNvSpPr txBox="1">
+            <a:spLocks/>
+          </p:cNvSpPr>
+          <p:nvPr/>
+        </p:nvSpPr>
+        <p:spPr>
+          <a:xfrm>
+            <a:off x="720000" y="619200"/>
+            <a:ext cx="10728322" cy="666675"/>
+          </a:xfrm>
+          <a:prstGeom prst="rect">
+            <a:avLst/>
+          </a:prstGeom>
+        </p:spPr>
+        <p:txBody>
+          <a:bodyPr vert="horz" lIns="91440" tIns="45720" rIns="91440" bIns="45720" rtlCol="0" anchor="ctr">
+            <a:normAutofit fontScale="97500" lnSpcReduction="10000"/>
+          </a:bodyPr>
+          <a:lstStyle>
+            <a:lvl1pPr algn="l" defTabSz="914400" rtl="0" eaLnBrk="1" latinLnBrk="0" hangingPunct="1">
+              <a:lnSpc>
+                <a:spcPct val="90000"/>
+              </a:lnSpc>
+              <a:spcBef>
+                <a:spcPct val="0"/>
+              </a:spcBef>
+              <a:buNone/>
+              <a:defRPr sz="4400" kern="1200">
+                <a:solidFill>
+                  <a:schemeClr val="tx1"/>
+                </a:solidFill>
+                <a:latin typeface="+mj-lt"/>
+                <a:ea typeface="+mj-ea"/>
+                <a:cs typeface="+mj-cs"/>
+              </a:defRPr>
+            </a:lvl1pPr>
+          </a:lstStyle>
+          <a:p>
+            <a:r>
+              <a:rPr lang="en-US" b="1" dirty="0">
+                <a:latin typeface="Times New Roman" panose="02020603050405020304" pitchFamily="18" charset="0"/>
+                <a:cs typeface="Times New Roman" panose="02020603050405020304" pitchFamily="18" charset="0"/>
+              </a:rPr>
+              <a:t>File 101</a:t>
+            </a:r>
+          </a:p>
+        </p:txBody>
+      </p:sp>
+      <p:pic>
+        <p:nvPicPr>
+          <p:cNvPr id="5" name="Picture 4" descr="Chart, waterfall chart&#10;&#10;Description automatically generated">
+            <a:extLst>
+              <a:ext uri="{FF2B5EF4-FFF2-40B4-BE49-F238E27FC236}">
+                <a16:creationId xmlns:a16="http://schemas.microsoft.com/office/drawing/2014/main" id="{0BB8D6E9-41AC-5740-996C-92651C6A3385}"/>
+              </a:ext>
+            </a:extLst>
+          </p:cNvPr>
+          <p:cNvPicPr>
+            <a:picLocks noChangeAspect="1"/>
+          </p:cNvPicPr>
+          <p:nvPr/>
+        </p:nvPicPr>
+        <p:blipFill>
+          <a:blip r:embed="rId3"/>
+          <a:stretch>
+            <a:fillRect/>
+          </a:stretch>
+        </p:blipFill>
+        <p:spPr>
+          <a:xfrm>
+            <a:off x="2088051" y="1266589"/>
+            <a:ext cx="4027716" cy="2685144"/>
+          </a:xfrm>
+          <a:prstGeom prst="rect">
+            <a:avLst/>
+          </a:prstGeom>
+        </p:spPr>
+      </p:pic>
+      <p:pic>
+        <p:nvPicPr>
+          <p:cNvPr id="10" name="Picture 9" descr="Chart, scatter chart&#10;&#10;Description automatically generated">
+            <a:extLst>
+              <a:ext uri="{FF2B5EF4-FFF2-40B4-BE49-F238E27FC236}">
+                <a16:creationId xmlns:a16="http://schemas.microsoft.com/office/drawing/2014/main" id="{645898AF-DDB0-9B40-B2F5-A9724954A6EA}"/>
+              </a:ext>
+            </a:extLst>
+          </p:cNvPr>
+          <p:cNvPicPr>
+            <a:picLocks noChangeAspect="1"/>
+          </p:cNvPicPr>
+          <p:nvPr/>
+        </p:nvPicPr>
+        <p:blipFill>
+          <a:blip r:embed="rId4"/>
+          <a:stretch>
+            <a:fillRect/>
+          </a:stretch>
+        </p:blipFill>
+        <p:spPr>
+          <a:xfrm>
+            <a:off x="6506642" y="1370440"/>
+            <a:ext cx="4207915" cy="2540200"/>
+          </a:xfrm>
+          <a:prstGeom prst="rect">
+            <a:avLst/>
+          </a:prstGeom>
+        </p:spPr>
+      </p:pic>
+      <p:pic>
+        <p:nvPicPr>
+          <p:cNvPr id="13" name="Picture 12" descr="Chart, waterfall chart&#10;&#10;Description automatically generated">
+            <a:extLst>
+              <a:ext uri="{FF2B5EF4-FFF2-40B4-BE49-F238E27FC236}">
+                <a16:creationId xmlns:a16="http://schemas.microsoft.com/office/drawing/2014/main" id="{8DA4F906-70F7-3243-89EE-A88FE95662CE}"/>
+              </a:ext>
+            </a:extLst>
+          </p:cNvPr>
+          <p:cNvPicPr>
+            <a:picLocks noChangeAspect="1"/>
+          </p:cNvPicPr>
+          <p:nvPr/>
+        </p:nvPicPr>
+        <p:blipFill>
+          <a:blip r:embed="rId5"/>
+          <a:stretch>
+            <a:fillRect/>
+          </a:stretch>
+        </p:blipFill>
+        <p:spPr>
+          <a:xfrm>
+            <a:off x="2135829" y="4094714"/>
+            <a:ext cx="3932159" cy="2621439"/>
+          </a:xfrm>
+          <a:prstGeom prst="rect">
+            <a:avLst/>
+          </a:prstGeom>
+        </p:spPr>
+      </p:pic>
+      <p:pic>
+        <p:nvPicPr>
+          <p:cNvPr id="15" name="Picture 14" descr="Chart, scatter chart&#10;&#10;Description automatically generated">
+            <a:extLst>
+              <a:ext uri="{FF2B5EF4-FFF2-40B4-BE49-F238E27FC236}">
+                <a16:creationId xmlns:a16="http://schemas.microsoft.com/office/drawing/2014/main" id="{B9D1910A-5470-5D4D-9A60-5E0EB5E96A6B}"/>
+              </a:ext>
+            </a:extLst>
+          </p:cNvPr>
+          <p:cNvPicPr>
+            <a:picLocks noChangeAspect="1"/>
+          </p:cNvPicPr>
+          <p:nvPr/>
+        </p:nvPicPr>
+        <p:blipFill>
+          <a:blip r:embed="rId6"/>
+          <a:stretch>
+            <a:fillRect/>
+          </a:stretch>
+        </p:blipFill>
+        <p:spPr>
+          <a:xfrm>
+            <a:off x="6506642" y="4175954"/>
+            <a:ext cx="4207915" cy="2540199"/>
+          </a:xfrm>
+          <a:prstGeom prst="rect">
+            <a:avLst/>
+          </a:prstGeom>
+        </p:spPr>
+      </p:pic>
+    </p:spTree>
+    <p:extLst>
+      <p:ext uri="{BB962C8B-B14F-4D97-AF65-F5344CB8AC3E}">
+        <p14:creationId xmlns:p14="http://schemas.microsoft.com/office/powerpoint/2010/main" val="2886417708"/>
       </p:ext>
     </p:extLst>
   </p:cSld>

</xml_diff>

<commit_message>
fixes before merge into main
</commit_message>
<xml_diff>
--- a/docs/group_meeting_pp_turboid.pptx
+++ b/docs/group_meeting_pp_turboid.pptx
@@ -5,7 +5,7 @@
     <p:sldMasterId id="2147483713" r:id="rId1"/>
   </p:sldMasterIdLst>
   <p:notesMasterIdLst>
-    <p:notesMasterId r:id="rId33"/>
+    <p:notesMasterId r:id="rId26"/>
   </p:notesMasterIdLst>
   <p:sldIdLst>
     <p:sldId id="256" r:id="rId2"/>
@@ -32,13 +32,6 @@
     <p:sldId id="308" r:id="rId23"/>
     <p:sldId id="290" r:id="rId24"/>
     <p:sldId id="289" r:id="rId25"/>
-    <p:sldId id="318" r:id="rId26"/>
-    <p:sldId id="319" r:id="rId27"/>
-    <p:sldId id="321" r:id="rId28"/>
-    <p:sldId id="322" r:id="rId29"/>
-    <p:sldId id="325" r:id="rId30"/>
-    <p:sldId id="324" r:id="rId31"/>
-    <p:sldId id="326" r:id="rId32"/>
   </p:sldIdLst>
   <p:sldSz cx="12192000" cy="6858000"/>
   <p:notesSz cx="6858000" cy="9144000"/>
@@ -4093,7 +4086,7 @@
           <a:p>
             <a:fld id="{5D91BF4D-3201-F745-B932-E7F786B71255}" type="datetimeFigureOut">
               <a:rPr lang="en-US" smtClean="0"/>
-              <a:t>5/11/23</a:t>
+              <a:t>5/12/23</a:t>
             </a:fld>
             <a:endParaRPr lang="en-US"/>
           </a:p>
@@ -6927,510 +6920,6 @@
 </p:notes>
 </file>
 
-<file path=ppt/notesSlides/notesSlide22.xml><?xml version="1.0" encoding="utf-8"?>
-<p:notes xmlns:a="http://schemas.openxmlformats.org/drawingml/2006/main" xmlns:r="http://schemas.openxmlformats.org/officeDocument/2006/relationships" xmlns:p="http://schemas.openxmlformats.org/presentationml/2006/main">
-  <p:cSld>
-    <p:spTree>
-      <p:nvGrpSpPr>
-        <p:cNvPr id="1" name=""/>
-        <p:cNvGrpSpPr/>
-        <p:nvPr/>
-      </p:nvGrpSpPr>
-      <p:grpSpPr>
-        <a:xfrm>
-          <a:off x="0" y="0"/>
-          <a:ext cx="0" cy="0"/>
-          <a:chOff x="0" y="0"/>
-          <a:chExt cx="0" cy="0"/>
-        </a:xfrm>
-      </p:grpSpPr>
-      <p:sp>
-        <p:nvSpPr>
-          <p:cNvPr id="2" name="Slide Image Placeholder 1"/>
-          <p:cNvSpPr>
-            <a:spLocks noGrp="1" noRot="1" noChangeAspect="1"/>
-          </p:cNvSpPr>
-          <p:nvPr>
-            <p:ph type="sldImg"/>
-          </p:nvPr>
-        </p:nvSpPr>
-        <p:spPr/>
-      </p:sp>
-      <p:sp>
-        <p:nvSpPr>
-          <p:cNvPr id="3" name="Notes Placeholder 2"/>
-          <p:cNvSpPr>
-            <a:spLocks noGrp="1"/>
-          </p:cNvSpPr>
-          <p:nvPr>
-            <p:ph type="body" idx="1"/>
-          </p:nvPr>
-        </p:nvSpPr>
-        <p:spPr/>
-        <p:txBody>
-          <a:bodyPr/>
-          <a:lstStyle/>
-          <a:p>
-            <a:endParaRPr lang="en-US" dirty="0"/>
-          </a:p>
-        </p:txBody>
-      </p:sp>
-      <p:sp>
-        <p:nvSpPr>
-          <p:cNvPr id="4" name="Slide Number Placeholder 3"/>
-          <p:cNvSpPr>
-            <a:spLocks noGrp="1"/>
-          </p:cNvSpPr>
-          <p:nvPr>
-            <p:ph type="sldNum" sz="quarter" idx="5"/>
-          </p:nvPr>
-        </p:nvSpPr>
-        <p:spPr/>
-        <p:txBody>
-          <a:bodyPr/>
-          <a:lstStyle/>
-          <a:p>
-            <a:fld id="{5E3C3097-339F-D341-9AE2-47DB3DE0E34B}" type="slidenum">
-              <a:rPr lang="en-US" smtClean="0"/>
-              <a:t>25</a:t>
-            </a:fld>
-            <a:endParaRPr lang="en-US"/>
-          </a:p>
-        </p:txBody>
-      </p:sp>
-    </p:spTree>
-    <p:extLst>
-      <p:ext uri="{BB962C8B-B14F-4D97-AF65-F5344CB8AC3E}">
-        <p14:creationId xmlns:p14="http://schemas.microsoft.com/office/powerpoint/2010/main" val="3585033310"/>
-      </p:ext>
-    </p:extLst>
-  </p:cSld>
-  <p:clrMapOvr>
-    <a:masterClrMapping/>
-  </p:clrMapOvr>
-</p:notes>
-</file>
-
-<file path=ppt/notesSlides/notesSlide23.xml><?xml version="1.0" encoding="utf-8"?>
-<p:notes xmlns:a="http://schemas.openxmlformats.org/drawingml/2006/main" xmlns:r="http://schemas.openxmlformats.org/officeDocument/2006/relationships" xmlns:p="http://schemas.openxmlformats.org/presentationml/2006/main">
-  <p:cSld>
-    <p:spTree>
-      <p:nvGrpSpPr>
-        <p:cNvPr id="1" name=""/>
-        <p:cNvGrpSpPr/>
-        <p:nvPr/>
-      </p:nvGrpSpPr>
-      <p:grpSpPr>
-        <a:xfrm>
-          <a:off x="0" y="0"/>
-          <a:ext cx="0" cy="0"/>
-          <a:chOff x="0" y="0"/>
-          <a:chExt cx="0" cy="0"/>
-        </a:xfrm>
-      </p:grpSpPr>
-      <p:sp>
-        <p:nvSpPr>
-          <p:cNvPr id="2" name="Slide Image Placeholder 1"/>
-          <p:cNvSpPr>
-            <a:spLocks noGrp="1" noRot="1" noChangeAspect="1"/>
-          </p:cNvSpPr>
-          <p:nvPr>
-            <p:ph type="sldImg"/>
-          </p:nvPr>
-        </p:nvSpPr>
-        <p:spPr/>
-      </p:sp>
-      <p:sp>
-        <p:nvSpPr>
-          <p:cNvPr id="3" name="Notes Placeholder 2"/>
-          <p:cNvSpPr>
-            <a:spLocks noGrp="1"/>
-          </p:cNvSpPr>
-          <p:nvPr>
-            <p:ph type="body" idx="1"/>
-          </p:nvPr>
-        </p:nvSpPr>
-        <p:spPr/>
-        <p:txBody>
-          <a:bodyPr/>
-          <a:lstStyle/>
-          <a:p>
-            <a:endParaRPr lang="en-US" dirty="0"/>
-          </a:p>
-        </p:txBody>
-      </p:sp>
-      <p:sp>
-        <p:nvSpPr>
-          <p:cNvPr id="4" name="Slide Number Placeholder 3"/>
-          <p:cNvSpPr>
-            <a:spLocks noGrp="1"/>
-          </p:cNvSpPr>
-          <p:nvPr>
-            <p:ph type="sldNum" sz="quarter" idx="5"/>
-          </p:nvPr>
-        </p:nvSpPr>
-        <p:spPr/>
-        <p:txBody>
-          <a:bodyPr/>
-          <a:lstStyle/>
-          <a:p>
-            <a:fld id="{5E3C3097-339F-D341-9AE2-47DB3DE0E34B}" type="slidenum">
-              <a:rPr lang="en-US" smtClean="0"/>
-              <a:t>26</a:t>
-            </a:fld>
-            <a:endParaRPr lang="en-US"/>
-          </a:p>
-        </p:txBody>
-      </p:sp>
-    </p:spTree>
-    <p:extLst>
-      <p:ext uri="{BB962C8B-B14F-4D97-AF65-F5344CB8AC3E}">
-        <p14:creationId xmlns:p14="http://schemas.microsoft.com/office/powerpoint/2010/main" val="2766349677"/>
-      </p:ext>
-    </p:extLst>
-  </p:cSld>
-  <p:clrMapOvr>
-    <a:masterClrMapping/>
-  </p:clrMapOvr>
-</p:notes>
-</file>
-
-<file path=ppt/notesSlides/notesSlide24.xml><?xml version="1.0" encoding="utf-8"?>
-<p:notes xmlns:a="http://schemas.openxmlformats.org/drawingml/2006/main" xmlns:r="http://schemas.openxmlformats.org/officeDocument/2006/relationships" xmlns:p="http://schemas.openxmlformats.org/presentationml/2006/main">
-  <p:cSld>
-    <p:spTree>
-      <p:nvGrpSpPr>
-        <p:cNvPr id="1" name=""/>
-        <p:cNvGrpSpPr/>
-        <p:nvPr/>
-      </p:nvGrpSpPr>
-      <p:grpSpPr>
-        <a:xfrm>
-          <a:off x="0" y="0"/>
-          <a:ext cx="0" cy="0"/>
-          <a:chOff x="0" y="0"/>
-          <a:chExt cx="0" cy="0"/>
-        </a:xfrm>
-      </p:grpSpPr>
-      <p:sp>
-        <p:nvSpPr>
-          <p:cNvPr id="2" name="Slide Image Placeholder 1"/>
-          <p:cNvSpPr>
-            <a:spLocks noGrp="1" noRot="1" noChangeAspect="1"/>
-          </p:cNvSpPr>
-          <p:nvPr>
-            <p:ph type="sldImg"/>
-          </p:nvPr>
-        </p:nvSpPr>
-        <p:spPr/>
-      </p:sp>
-      <p:sp>
-        <p:nvSpPr>
-          <p:cNvPr id="3" name="Notes Placeholder 2"/>
-          <p:cNvSpPr>
-            <a:spLocks noGrp="1"/>
-          </p:cNvSpPr>
-          <p:nvPr>
-            <p:ph type="body" idx="1"/>
-          </p:nvPr>
-        </p:nvSpPr>
-        <p:spPr/>
-        <p:txBody>
-          <a:bodyPr/>
-          <a:lstStyle/>
-          <a:p>
-            <a:endParaRPr lang="en-US" dirty="0"/>
-          </a:p>
-        </p:txBody>
-      </p:sp>
-      <p:sp>
-        <p:nvSpPr>
-          <p:cNvPr id="4" name="Slide Number Placeholder 3"/>
-          <p:cNvSpPr>
-            <a:spLocks noGrp="1"/>
-          </p:cNvSpPr>
-          <p:nvPr>
-            <p:ph type="sldNum" sz="quarter" idx="5"/>
-          </p:nvPr>
-        </p:nvSpPr>
-        <p:spPr/>
-        <p:txBody>
-          <a:bodyPr/>
-          <a:lstStyle/>
-          <a:p>
-            <a:fld id="{5E3C3097-339F-D341-9AE2-47DB3DE0E34B}" type="slidenum">
-              <a:rPr lang="en-US" smtClean="0"/>
-              <a:t>27</a:t>
-            </a:fld>
-            <a:endParaRPr lang="en-US"/>
-          </a:p>
-        </p:txBody>
-      </p:sp>
-    </p:spTree>
-    <p:extLst>
-      <p:ext uri="{BB962C8B-B14F-4D97-AF65-F5344CB8AC3E}">
-        <p14:creationId xmlns:p14="http://schemas.microsoft.com/office/powerpoint/2010/main" val="724225446"/>
-      </p:ext>
-    </p:extLst>
-  </p:cSld>
-  <p:clrMapOvr>
-    <a:masterClrMapping/>
-  </p:clrMapOvr>
-</p:notes>
-</file>
-
-<file path=ppt/notesSlides/notesSlide25.xml><?xml version="1.0" encoding="utf-8"?>
-<p:notes xmlns:a="http://schemas.openxmlformats.org/drawingml/2006/main" xmlns:r="http://schemas.openxmlformats.org/officeDocument/2006/relationships" xmlns:p="http://schemas.openxmlformats.org/presentationml/2006/main">
-  <p:cSld>
-    <p:spTree>
-      <p:nvGrpSpPr>
-        <p:cNvPr id="1" name=""/>
-        <p:cNvGrpSpPr/>
-        <p:nvPr/>
-      </p:nvGrpSpPr>
-      <p:grpSpPr>
-        <a:xfrm>
-          <a:off x="0" y="0"/>
-          <a:ext cx="0" cy="0"/>
-          <a:chOff x="0" y="0"/>
-          <a:chExt cx="0" cy="0"/>
-        </a:xfrm>
-      </p:grpSpPr>
-      <p:sp>
-        <p:nvSpPr>
-          <p:cNvPr id="2" name="Slide Image Placeholder 1"/>
-          <p:cNvSpPr>
-            <a:spLocks noGrp="1" noRot="1" noChangeAspect="1"/>
-          </p:cNvSpPr>
-          <p:nvPr>
-            <p:ph type="sldImg"/>
-          </p:nvPr>
-        </p:nvSpPr>
-        <p:spPr/>
-      </p:sp>
-      <p:sp>
-        <p:nvSpPr>
-          <p:cNvPr id="3" name="Notes Placeholder 2"/>
-          <p:cNvSpPr>
-            <a:spLocks noGrp="1"/>
-          </p:cNvSpPr>
-          <p:nvPr>
-            <p:ph type="body" idx="1"/>
-          </p:nvPr>
-        </p:nvSpPr>
-        <p:spPr/>
-        <p:txBody>
-          <a:bodyPr/>
-          <a:lstStyle/>
-          <a:p>
-            <a:endParaRPr lang="en-US" dirty="0"/>
-          </a:p>
-        </p:txBody>
-      </p:sp>
-      <p:sp>
-        <p:nvSpPr>
-          <p:cNvPr id="4" name="Slide Number Placeholder 3"/>
-          <p:cNvSpPr>
-            <a:spLocks noGrp="1"/>
-          </p:cNvSpPr>
-          <p:nvPr>
-            <p:ph type="sldNum" sz="quarter" idx="5"/>
-          </p:nvPr>
-        </p:nvSpPr>
-        <p:spPr/>
-        <p:txBody>
-          <a:bodyPr/>
-          <a:lstStyle/>
-          <a:p>
-            <a:fld id="{5E3C3097-339F-D341-9AE2-47DB3DE0E34B}" type="slidenum">
-              <a:rPr lang="en-US" smtClean="0"/>
-              <a:t>28</a:t>
-            </a:fld>
-            <a:endParaRPr lang="en-US"/>
-          </a:p>
-        </p:txBody>
-      </p:sp>
-    </p:spTree>
-    <p:extLst>
-      <p:ext uri="{BB962C8B-B14F-4D97-AF65-F5344CB8AC3E}">
-        <p14:creationId xmlns:p14="http://schemas.microsoft.com/office/powerpoint/2010/main" val="538711350"/>
-      </p:ext>
-    </p:extLst>
-  </p:cSld>
-  <p:clrMapOvr>
-    <a:masterClrMapping/>
-  </p:clrMapOvr>
-</p:notes>
-</file>
-
-<file path=ppt/notesSlides/notesSlide26.xml><?xml version="1.0" encoding="utf-8"?>
-<p:notes xmlns:a="http://schemas.openxmlformats.org/drawingml/2006/main" xmlns:r="http://schemas.openxmlformats.org/officeDocument/2006/relationships" xmlns:p="http://schemas.openxmlformats.org/presentationml/2006/main">
-  <p:cSld>
-    <p:spTree>
-      <p:nvGrpSpPr>
-        <p:cNvPr id="1" name=""/>
-        <p:cNvGrpSpPr/>
-        <p:nvPr/>
-      </p:nvGrpSpPr>
-      <p:grpSpPr>
-        <a:xfrm>
-          <a:off x="0" y="0"/>
-          <a:ext cx="0" cy="0"/>
-          <a:chOff x="0" y="0"/>
-          <a:chExt cx="0" cy="0"/>
-        </a:xfrm>
-      </p:grpSpPr>
-      <p:sp>
-        <p:nvSpPr>
-          <p:cNvPr id="2" name="Slide Image Placeholder 1"/>
-          <p:cNvSpPr>
-            <a:spLocks noGrp="1" noRot="1" noChangeAspect="1"/>
-          </p:cNvSpPr>
-          <p:nvPr>
-            <p:ph type="sldImg"/>
-          </p:nvPr>
-        </p:nvSpPr>
-        <p:spPr/>
-      </p:sp>
-      <p:sp>
-        <p:nvSpPr>
-          <p:cNvPr id="3" name="Notes Placeholder 2"/>
-          <p:cNvSpPr>
-            <a:spLocks noGrp="1"/>
-          </p:cNvSpPr>
-          <p:nvPr>
-            <p:ph type="body" idx="1"/>
-          </p:nvPr>
-        </p:nvSpPr>
-        <p:spPr/>
-        <p:txBody>
-          <a:bodyPr/>
-          <a:lstStyle/>
-          <a:p>
-            <a:endParaRPr lang="en-US" dirty="0"/>
-          </a:p>
-        </p:txBody>
-      </p:sp>
-      <p:sp>
-        <p:nvSpPr>
-          <p:cNvPr id="4" name="Slide Number Placeholder 3"/>
-          <p:cNvSpPr>
-            <a:spLocks noGrp="1"/>
-          </p:cNvSpPr>
-          <p:nvPr>
-            <p:ph type="sldNum" sz="quarter" idx="5"/>
-          </p:nvPr>
-        </p:nvSpPr>
-        <p:spPr/>
-        <p:txBody>
-          <a:bodyPr/>
-          <a:lstStyle/>
-          <a:p>
-            <a:fld id="{5E3C3097-339F-D341-9AE2-47DB3DE0E34B}" type="slidenum">
-              <a:rPr lang="en-US" smtClean="0"/>
-              <a:t>29</a:t>
-            </a:fld>
-            <a:endParaRPr lang="en-US"/>
-          </a:p>
-        </p:txBody>
-      </p:sp>
-    </p:spTree>
-    <p:extLst>
-      <p:ext uri="{BB962C8B-B14F-4D97-AF65-F5344CB8AC3E}">
-        <p14:creationId xmlns:p14="http://schemas.microsoft.com/office/powerpoint/2010/main" val="1946830940"/>
-      </p:ext>
-    </p:extLst>
-  </p:cSld>
-  <p:clrMapOvr>
-    <a:masterClrMapping/>
-  </p:clrMapOvr>
-</p:notes>
-</file>
-
-<file path=ppt/notesSlides/notesSlide27.xml><?xml version="1.0" encoding="utf-8"?>
-<p:notes xmlns:a="http://schemas.openxmlformats.org/drawingml/2006/main" xmlns:r="http://schemas.openxmlformats.org/officeDocument/2006/relationships" xmlns:p="http://schemas.openxmlformats.org/presentationml/2006/main">
-  <p:cSld>
-    <p:spTree>
-      <p:nvGrpSpPr>
-        <p:cNvPr id="1" name=""/>
-        <p:cNvGrpSpPr/>
-        <p:nvPr/>
-      </p:nvGrpSpPr>
-      <p:grpSpPr>
-        <a:xfrm>
-          <a:off x="0" y="0"/>
-          <a:ext cx="0" cy="0"/>
-          <a:chOff x="0" y="0"/>
-          <a:chExt cx="0" cy="0"/>
-        </a:xfrm>
-      </p:grpSpPr>
-      <p:sp>
-        <p:nvSpPr>
-          <p:cNvPr id="2" name="Slide Image Placeholder 1"/>
-          <p:cNvSpPr>
-            <a:spLocks noGrp="1" noRot="1" noChangeAspect="1"/>
-          </p:cNvSpPr>
-          <p:nvPr>
-            <p:ph type="sldImg"/>
-          </p:nvPr>
-        </p:nvSpPr>
-        <p:spPr/>
-      </p:sp>
-      <p:sp>
-        <p:nvSpPr>
-          <p:cNvPr id="3" name="Notes Placeholder 2"/>
-          <p:cNvSpPr>
-            <a:spLocks noGrp="1"/>
-          </p:cNvSpPr>
-          <p:nvPr>
-            <p:ph type="body" idx="1"/>
-          </p:nvPr>
-        </p:nvSpPr>
-        <p:spPr/>
-        <p:txBody>
-          <a:bodyPr/>
-          <a:lstStyle/>
-          <a:p>
-            <a:endParaRPr lang="en-US" dirty="0"/>
-          </a:p>
-        </p:txBody>
-      </p:sp>
-      <p:sp>
-        <p:nvSpPr>
-          <p:cNvPr id="4" name="Slide Number Placeholder 3"/>
-          <p:cNvSpPr>
-            <a:spLocks noGrp="1"/>
-          </p:cNvSpPr>
-          <p:nvPr>
-            <p:ph type="sldNum" sz="quarter" idx="5"/>
-          </p:nvPr>
-        </p:nvSpPr>
-        <p:spPr/>
-        <p:txBody>
-          <a:bodyPr/>
-          <a:lstStyle/>
-          <a:p>
-            <a:fld id="{5E3C3097-339F-D341-9AE2-47DB3DE0E34B}" type="slidenum">
-              <a:rPr lang="en-US" smtClean="0"/>
-              <a:t>30</a:t>
-            </a:fld>
-            <a:endParaRPr lang="en-US"/>
-          </a:p>
-        </p:txBody>
-      </p:sp>
-    </p:spTree>
-    <p:extLst>
-      <p:ext uri="{BB962C8B-B14F-4D97-AF65-F5344CB8AC3E}">
-        <p14:creationId xmlns:p14="http://schemas.microsoft.com/office/powerpoint/2010/main" val="415904847"/>
-      </p:ext>
-    </p:extLst>
-  </p:cSld>
-  <p:clrMapOvr>
-    <a:masterClrMapping/>
-  </p:clrMapOvr>
-</p:notes>
-</file>
-
 <file path=ppt/notesSlides/notesSlide3.xml><?xml version="1.0" encoding="utf-8"?>
 <p:notes xmlns:a="http://schemas.openxmlformats.org/drawingml/2006/main" xmlns:r="http://schemas.openxmlformats.org/officeDocument/2006/relationships" xmlns:p="http://schemas.openxmlformats.org/presentationml/2006/main">
   <p:cSld>
@@ -8420,7 +7909,7 @@
           <a:p>
             <a:fld id="{4D82D62B-C5BC-9A48-B649-B612C2626DF0}" type="datetime2">
               <a:rPr lang="en-US" smtClean="0"/>
-              <a:t>Thursday, May 11, 2023</a:t>
+              <a:t>Friday, May 12, 2023</a:t>
             </a:fld>
             <a:endParaRPr lang="en-US" dirty="0"/>
           </a:p>
@@ -8623,7 +8112,7 @@
           <a:p>
             <a:fld id="{8C7BF22D-4351-7443-9203-BE328953BFC7}" type="datetime2">
               <a:rPr lang="en-US" smtClean="0"/>
-              <a:t>Thursday, May 11, 2023</a:t>
+              <a:t>Friday, May 12, 2023</a:t>
             </a:fld>
             <a:endParaRPr lang="en-US"/>
           </a:p>
@@ -8834,7 +8323,7 @@
           <a:p>
             <a:fld id="{9FDF6349-9520-004C-B410-2193F9372E49}" type="datetime2">
               <a:rPr lang="en-US" smtClean="0"/>
-              <a:t>Thursday, May 11, 2023</a:t>
+              <a:t>Friday, May 12, 2023</a:t>
             </a:fld>
             <a:endParaRPr lang="en-US"/>
           </a:p>
@@ -9035,7 +8524,7 @@
           <a:p>
             <a:fld id="{E9A10DC3-F6B5-014A-A9AD-0D47C6506BAB}" type="datetime2">
               <a:rPr lang="en-US" smtClean="0"/>
-              <a:t>Thursday, May 11, 2023</a:t>
+              <a:t>Friday, May 12, 2023</a:t>
             </a:fld>
             <a:endParaRPr lang="en-US" dirty="0"/>
           </a:p>
@@ -9315,7 +8804,7 @@
           <a:p>
             <a:fld id="{A049C287-8CF4-DC48-88B8-6E35669697EC}" type="datetime2">
               <a:rPr lang="en-US" smtClean="0"/>
-              <a:t>Thursday, May 11, 2023</a:t>
+              <a:t>Friday, May 12, 2023</a:t>
             </a:fld>
             <a:endParaRPr lang="en-US"/>
           </a:p>
@@ -9585,7 +9074,7 @@
           <a:p>
             <a:fld id="{ADEB5C39-7764-3744-BF89-1BA0C95D9B94}" type="datetime2">
               <a:rPr lang="en-US" smtClean="0"/>
-              <a:t>Thursday, May 11, 2023</a:t>
+              <a:t>Friday, May 12, 2023</a:t>
             </a:fld>
             <a:endParaRPr lang="en-US"/>
           </a:p>
@@ -10000,7 +9489,7 @@
           <a:p>
             <a:fld id="{4BAB7099-C23E-1745-AF03-0B0C40F6AA6C}" type="datetime2">
               <a:rPr lang="en-US" smtClean="0"/>
-              <a:t>Thursday, May 11, 2023</a:t>
+              <a:t>Friday, May 12, 2023</a:t>
             </a:fld>
             <a:endParaRPr lang="en-US"/>
           </a:p>
@@ -10144,7 +9633,7 @@
           <a:p>
             <a:fld id="{52B883A0-F701-0F49-9D67-42F97F0F4C65}" type="datetime2">
               <a:rPr lang="en-US" smtClean="0"/>
-              <a:t>Thursday, May 11, 2023</a:t>
+              <a:t>Friday, May 12, 2023</a:t>
             </a:fld>
             <a:endParaRPr lang="en-US"/>
           </a:p>
@@ -10260,7 +9749,7 @@
           <a:p>
             <a:fld id="{E6923127-F9F8-8B4E-9CEB-95BF7FFEA85F}" type="datetime2">
               <a:rPr lang="en-US" smtClean="0"/>
-              <a:t>Thursday, May 11, 2023</a:t>
+              <a:t>Friday, May 12, 2023</a:t>
             </a:fld>
             <a:endParaRPr lang="en-US"/>
           </a:p>
@@ -10574,7 +10063,7 @@
           <a:p>
             <a:fld id="{24AFEB34-53E9-8F42-9ED2-04274EE70207}" type="datetime2">
               <a:rPr lang="en-US" smtClean="0"/>
-              <a:t>Thursday, May 11, 2023</a:t>
+              <a:t>Friday, May 12, 2023</a:t>
             </a:fld>
             <a:endParaRPr lang="en-US"/>
           </a:p>
@@ -10865,7 +10354,7 @@
           <a:p>
             <a:fld id="{78864A2C-3282-224A-8A3B-B1B48911DC1D}" type="datetime2">
               <a:rPr lang="en-US" smtClean="0"/>
-              <a:t>Thursday, May 11, 2023</a:t>
+              <a:t>Friday, May 12, 2023</a:t>
             </a:fld>
             <a:endParaRPr lang="en-US"/>
           </a:p>
@@ -11109,7 +10598,7 @@
           <a:p>
             <a:fld id="{6A398F71-50EE-C442-9A03-D3A19758747B}" type="datetime2">
               <a:rPr lang="en-US" smtClean="0"/>
-              <a:t>Thursday, May 11, 2023</a:t>
+              <a:t>Friday, May 12, 2023</a:t>
             </a:fld>
             <a:endParaRPr lang="en-US" dirty="0"/>
           </a:p>
@@ -27759,2887 +27248,6 @@
 </p:sld>
 </file>
 
-<file path=ppt/slides/slide25.xml><?xml version="1.0" encoding="utf-8"?>
-<p:sld xmlns:a="http://schemas.openxmlformats.org/drawingml/2006/main" xmlns:r="http://schemas.openxmlformats.org/officeDocument/2006/relationships" xmlns:p="http://schemas.openxmlformats.org/presentationml/2006/main">
-  <p:cSld>
-    <p:spTree>
-      <p:nvGrpSpPr>
-        <p:cNvPr id="1" name=""/>
-        <p:cNvGrpSpPr/>
-        <p:nvPr/>
-      </p:nvGrpSpPr>
-      <p:grpSpPr>
-        <a:xfrm>
-          <a:off x="0" y="0"/>
-          <a:ext cx="0" cy="0"/>
-          <a:chOff x="0" y="0"/>
-          <a:chExt cx="0" cy="0"/>
-        </a:xfrm>
-      </p:grpSpPr>
-      <p:sp>
-        <p:nvSpPr>
-          <p:cNvPr id="4" name="Slide Number Placeholder 3">
-            <a:extLst>
-              <a:ext uri="{FF2B5EF4-FFF2-40B4-BE49-F238E27FC236}">
-                <a16:creationId xmlns:a16="http://schemas.microsoft.com/office/drawing/2014/main" id="{4383861C-DDFF-F94F-B844-7188E07B1951}"/>
-              </a:ext>
-            </a:extLst>
-          </p:cNvPr>
-          <p:cNvSpPr>
-            <a:spLocks noGrp="1"/>
-          </p:cNvSpPr>
-          <p:nvPr>
-            <p:ph type="sldNum" sz="quarter" idx="12"/>
-          </p:nvPr>
-        </p:nvSpPr>
-        <p:spPr/>
-        <p:txBody>
-          <a:bodyPr/>
-          <a:lstStyle/>
-          <a:p>
-            <a:fld id="{1621B6DD-29C1-4FEA-923F-71EA1347694C}" type="slidenum">
-              <a:rPr lang="en-US" smtClean="0"/>
-              <a:t>24</a:t>
-            </a:fld>
-            <a:endParaRPr lang="en-US"/>
-          </a:p>
-        </p:txBody>
-      </p:sp>
-      <p:sp>
-        <p:nvSpPr>
-          <p:cNvPr id="6" name="Title 1">
-            <a:extLst>
-              <a:ext uri="{FF2B5EF4-FFF2-40B4-BE49-F238E27FC236}">
-                <a16:creationId xmlns:a16="http://schemas.microsoft.com/office/drawing/2014/main" id="{8BB2DFB4-E4EC-CC46-BF2B-90B0CB50A619}"/>
-              </a:ext>
-            </a:extLst>
-          </p:cNvPr>
-          <p:cNvSpPr txBox="1">
-            <a:spLocks/>
-          </p:cNvSpPr>
-          <p:nvPr/>
-        </p:nvSpPr>
-        <p:spPr>
-          <a:xfrm>
-            <a:off x="720000" y="619200"/>
-            <a:ext cx="10728322" cy="666675"/>
-          </a:xfrm>
-          <a:prstGeom prst="rect">
-            <a:avLst/>
-          </a:prstGeom>
-        </p:spPr>
-        <p:txBody>
-          <a:bodyPr vert="horz" lIns="91440" tIns="45720" rIns="91440" bIns="45720" rtlCol="0" anchor="ctr">
-            <a:normAutofit fontScale="97500" lnSpcReduction="10000"/>
-          </a:bodyPr>
-          <a:lstStyle>
-            <a:lvl1pPr algn="l" defTabSz="914400" rtl="0" eaLnBrk="1" latinLnBrk="0" hangingPunct="1">
-              <a:lnSpc>
-                <a:spcPct val="90000"/>
-              </a:lnSpc>
-              <a:spcBef>
-                <a:spcPct val="0"/>
-              </a:spcBef>
-              <a:buNone/>
-              <a:defRPr sz="4400" kern="1200">
-                <a:solidFill>
-                  <a:schemeClr val="tx1"/>
-                </a:solidFill>
-                <a:latin typeface="+mj-lt"/>
-                <a:ea typeface="+mj-ea"/>
-                <a:cs typeface="+mj-cs"/>
-              </a:defRPr>
-            </a:lvl1pPr>
-          </a:lstStyle>
-          <a:p>
-            <a:r>
-              <a:rPr lang="en-US" sz="4400" b="1" dirty="0">
-                <a:latin typeface="Times New Roman" panose="02020603050405020304" pitchFamily="18" charset="0"/>
-                <a:cs typeface="Times New Roman" panose="02020603050405020304" pitchFamily="18" charset="0"/>
-              </a:rPr>
-              <a:t>Updates 04/12</a:t>
-            </a:r>
-            <a:endParaRPr lang="en-US" b="1" dirty="0">
-              <a:latin typeface="Times New Roman" panose="02020603050405020304" pitchFamily="18" charset="0"/>
-              <a:cs typeface="Times New Roman" panose="02020603050405020304" pitchFamily="18" charset="0"/>
-            </a:endParaRPr>
-          </a:p>
-        </p:txBody>
-      </p:sp>
-    </p:spTree>
-    <p:extLst>
-      <p:ext uri="{BB962C8B-B14F-4D97-AF65-F5344CB8AC3E}">
-        <p14:creationId xmlns:p14="http://schemas.microsoft.com/office/powerpoint/2010/main" val="2813102204"/>
-      </p:ext>
-    </p:extLst>
-  </p:cSld>
-  <p:clrMapOvr>
-    <a:masterClrMapping/>
-  </p:clrMapOvr>
-</p:sld>
-</file>
-
-<file path=ppt/slides/slide26.xml><?xml version="1.0" encoding="utf-8"?>
-<p:sld xmlns:a="http://schemas.openxmlformats.org/drawingml/2006/main" xmlns:r="http://schemas.openxmlformats.org/officeDocument/2006/relationships" xmlns:p="http://schemas.openxmlformats.org/presentationml/2006/main">
-  <p:cSld>
-    <p:spTree>
-      <p:nvGrpSpPr>
-        <p:cNvPr id="1" name=""/>
-        <p:cNvGrpSpPr/>
-        <p:nvPr/>
-      </p:nvGrpSpPr>
-      <p:grpSpPr>
-        <a:xfrm>
-          <a:off x="0" y="0"/>
-          <a:ext cx="0" cy="0"/>
-          <a:chOff x="0" y="0"/>
-          <a:chExt cx="0" cy="0"/>
-        </a:xfrm>
-      </p:grpSpPr>
-      <p:sp>
-        <p:nvSpPr>
-          <p:cNvPr id="4" name="Slide Number Placeholder 3">
-            <a:extLst>
-              <a:ext uri="{FF2B5EF4-FFF2-40B4-BE49-F238E27FC236}">
-                <a16:creationId xmlns:a16="http://schemas.microsoft.com/office/drawing/2014/main" id="{4383861C-DDFF-F94F-B844-7188E07B1951}"/>
-              </a:ext>
-            </a:extLst>
-          </p:cNvPr>
-          <p:cNvSpPr>
-            <a:spLocks noGrp="1"/>
-          </p:cNvSpPr>
-          <p:nvPr>
-            <p:ph type="sldNum" sz="quarter" idx="12"/>
-          </p:nvPr>
-        </p:nvSpPr>
-        <p:spPr/>
-        <p:txBody>
-          <a:bodyPr/>
-          <a:lstStyle/>
-          <a:p>
-            <a:fld id="{1621B6DD-29C1-4FEA-923F-71EA1347694C}" type="slidenum">
-              <a:rPr lang="en-US" smtClean="0"/>
-              <a:t>25</a:t>
-            </a:fld>
-            <a:endParaRPr lang="en-US"/>
-          </a:p>
-        </p:txBody>
-      </p:sp>
-      <p:sp>
-        <p:nvSpPr>
-          <p:cNvPr id="6" name="Title 1">
-            <a:extLst>
-              <a:ext uri="{FF2B5EF4-FFF2-40B4-BE49-F238E27FC236}">
-                <a16:creationId xmlns:a16="http://schemas.microsoft.com/office/drawing/2014/main" id="{8BB2DFB4-E4EC-CC46-BF2B-90B0CB50A619}"/>
-              </a:ext>
-            </a:extLst>
-          </p:cNvPr>
-          <p:cNvSpPr txBox="1">
-            <a:spLocks/>
-          </p:cNvSpPr>
-          <p:nvPr/>
-        </p:nvSpPr>
-        <p:spPr>
-          <a:xfrm>
-            <a:off x="720000" y="619200"/>
-            <a:ext cx="10728322" cy="666675"/>
-          </a:xfrm>
-          <a:prstGeom prst="rect">
-            <a:avLst/>
-          </a:prstGeom>
-        </p:spPr>
-        <p:txBody>
-          <a:bodyPr vert="horz" lIns="91440" tIns="45720" rIns="91440" bIns="45720" rtlCol="0" anchor="ctr">
-            <a:normAutofit fontScale="97500" lnSpcReduction="10000"/>
-          </a:bodyPr>
-          <a:lstStyle>
-            <a:lvl1pPr algn="l" defTabSz="914400" rtl="0" eaLnBrk="1" latinLnBrk="0" hangingPunct="1">
-              <a:lnSpc>
-                <a:spcPct val="90000"/>
-              </a:lnSpc>
-              <a:spcBef>
-                <a:spcPct val="0"/>
-              </a:spcBef>
-              <a:buNone/>
-              <a:defRPr sz="4400" kern="1200">
-                <a:solidFill>
-                  <a:schemeClr val="tx1"/>
-                </a:solidFill>
-                <a:latin typeface="+mj-lt"/>
-                <a:ea typeface="+mj-ea"/>
-                <a:cs typeface="+mj-cs"/>
-              </a:defRPr>
-            </a:lvl1pPr>
-          </a:lstStyle>
-          <a:p>
-            <a:r>
-              <a:rPr lang="en-US" sz="4400" b="1" dirty="0">
-                <a:latin typeface="Times New Roman" panose="02020603050405020304" pitchFamily="18" charset="0"/>
-                <a:cs typeface="Times New Roman" panose="02020603050405020304" pitchFamily="18" charset="0"/>
-              </a:rPr>
-              <a:t>Including </a:t>
-            </a:r>
-            <a:r>
-              <a:rPr lang="en-US" sz="4400" b="1" dirty="0" err="1">
-                <a:latin typeface="Times New Roman" panose="02020603050405020304" pitchFamily="18" charset="0"/>
-                <a:cs typeface="Times New Roman" panose="02020603050405020304" pitchFamily="18" charset="0"/>
-              </a:rPr>
-              <a:t>SignalP</a:t>
-            </a:r>
-            <a:r>
-              <a:rPr lang="en-US" sz="4400" b="1" dirty="0">
-                <a:latin typeface="Times New Roman" panose="02020603050405020304" pitchFamily="18" charset="0"/>
-                <a:cs typeface="Times New Roman" panose="02020603050405020304" pitchFamily="18" charset="0"/>
-              </a:rPr>
-              <a:t> prediction into TP list</a:t>
-            </a:r>
-            <a:endParaRPr lang="en-US" b="1" dirty="0">
-              <a:latin typeface="Times New Roman" panose="02020603050405020304" pitchFamily="18" charset="0"/>
-              <a:cs typeface="Times New Roman" panose="02020603050405020304" pitchFamily="18" charset="0"/>
-            </a:endParaRPr>
-          </a:p>
-        </p:txBody>
-      </p:sp>
-      <p:sp>
-        <p:nvSpPr>
-          <p:cNvPr id="5" name="Content Placeholder 2">
-            <a:extLst>
-              <a:ext uri="{FF2B5EF4-FFF2-40B4-BE49-F238E27FC236}">
-                <a16:creationId xmlns:a16="http://schemas.microsoft.com/office/drawing/2014/main" id="{D334BA8F-7D11-7C46-92B4-623B02C91ADB}"/>
-              </a:ext>
-            </a:extLst>
-          </p:cNvPr>
-          <p:cNvSpPr>
-            <a:spLocks noGrp="1"/>
-          </p:cNvSpPr>
-          <p:nvPr>
-            <p:ph idx="1"/>
-          </p:nvPr>
-        </p:nvSpPr>
-        <p:spPr>
-          <a:xfrm>
-            <a:off x="1106545" y="1764307"/>
-            <a:ext cx="9978909" cy="3864074"/>
-          </a:xfrm>
-        </p:spPr>
-        <p:txBody>
-          <a:bodyPr>
-            <a:normAutofit/>
-          </a:bodyPr>
-          <a:lstStyle/>
-          <a:p>
-            <a:pPr>
-              <a:lnSpc>
-                <a:spcPct val="120000"/>
-              </a:lnSpc>
-              <a:buClr>
-                <a:schemeClr val="tx1"/>
-              </a:buClr>
-              <a:defRPr/>
-            </a:pPr>
-            <a:r>
-              <a:rPr lang="en-US" sz="2000" i="0" spc="20" dirty="0">
-                <a:solidFill>
-                  <a:srgbClr val="000000"/>
-                </a:solidFill>
-                <a:latin typeface="Segoe UI" panose="020B0502040204020203" pitchFamily="34" charset="0"/>
-                <a:cs typeface="Segoe UI" panose="020B0502040204020203" pitchFamily="34" charset="0"/>
-              </a:rPr>
-              <a:t>Corey shared </a:t>
-            </a:r>
-            <a:r>
-              <a:rPr lang="en-US" sz="2000" spc="20" dirty="0" err="1">
-                <a:solidFill>
-                  <a:srgbClr val="000000"/>
-                </a:solidFill>
-                <a:latin typeface="Segoe UI" panose="020B0502040204020203" pitchFamily="34" charset="0"/>
-                <a:cs typeface="Segoe UI" panose="020B0502040204020203" pitchFamily="34" charset="0"/>
-              </a:rPr>
-              <a:t>SignalP</a:t>
-            </a:r>
-            <a:r>
-              <a:rPr lang="en-US" sz="2000" spc="20" dirty="0">
-                <a:solidFill>
-                  <a:srgbClr val="000000"/>
-                </a:solidFill>
-                <a:latin typeface="Segoe UI" panose="020B0502040204020203" pitchFamily="34" charset="0"/>
-                <a:cs typeface="Segoe UI" panose="020B0502040204020203" pitchFamily="34" charset="0"/>
-              </a:rPr>
-              <a:t> prediction list: </a:t>
-            </a:r>
-            <a:r>
-              <a:rPr lang="en-US" sz="2000" b="1" spc="20" dirty="0" err="1">
-                <a:solidFill>
-                  <a:srgbClr val="000000"/>
-                </a:solidFill>
-                <a:latin typeface="Segoe UI" panose="020B0502040204020203" pitchFamily="34" charset="0"/>
-                <a:cs typeface="Segoe UI" panose="020B0502040204020203" pitchFamily="34" charset="0"/>
-              </a:rPr>
-              <a:t>Secretion_Prediction_Resource.csv</a:t>
-            </a:r>
-            <a:endParaRPr lang="en-US" sz="2000" b="1" spc="20" dirty="0">
-              <a:solidFill>
-                <a:srgbClr val="000000"/>
-              </a:solidFill>
-              <a:latin typeface="Segoe UI" panose="020B0502040204020203" pitchFamily="34" charset="0"/>
-              <a:cs typeface="Segoe UI" panose="020B0502040204020203" pitchFamily="34" charset="0"/>
-            </a:endParaRPr>
-          </a:p>
-          <a:p>
-            <a:pPr marL="0" marR="0" algn="l">
-              <a:spcBef>
-                <a:spcPts val="0"/>
-              </a:spcBef>
-              <a:spcAft>
-                <a:spcPts val="0"/>
-              </a:spcAft>
-            </a:pPr>
-            <a:r>
-              <a:rPr lang="en-US" sz="2000" b="0" i="0" u="none" strike="noStrike" dirty="0">
-                <a:solidFill>
-                  <a:srgbClr val="000000"/>
-                </a:solidFill>
-                <a:effectLst/>
-                <a:latin typeface="Segoe UI" panose="020B0502040204020203" pitchFamily="34" charset="0"/>
-                <a:cs typeface="Segoe UI" panose="020B0502040204020203" pitchFamily="34" charset="0"/>
-              </a:rPr>
-              <a:t>For each </a:t>
-            </a:r>
-            <a:r>
-              <a:rPr lang="en-US" sz="2000" b="0" i="0" u="none" strike="noStrike" dirty="0" err="1">
-                <a:solidFill>
-                  <a:srgbClr val="000000"/>
-                </a:solidFill>
-                <a:effectLst/>
-                <a:latin typeface="Segoe UI" panose="020B0502040204020203" pitchFamily="34" charset="0"/>
-                <a:cs typeface="Segoe UI" panose="020B0502040204020203" pitchFamily="34" charset="0"/>
-              </a:rPr>
-              <a:t>uniprot</a:t>
-            </a:r>
-            <a:r>
-              <a:rPr lang="en-US" sz="2000" b="0" i="0" u="none" strike="noStrike" dirty="0">
-                <a:solidFill>
-                  <a:srgbClr val="000000"/>
-                </a:solidFill>
-                <a:effectLst/>
-                <a:latin typeface="Segoe UI" panose="020B0502040204020203" pitchFamily="34" charset="0"/>
-                <a:cs typeface="Segoe UI" panose="020B0502040204020203" pitchFamily="34" charset="0"/>
-              </a:rPr>
-              <a:t> id we check if the Subcellular location has any of these terms: </a:t>
-            </a:r>
-          </a:p>
-          <a:p>
-            <a:pPr marL="457200" lvl="1">
-              <a:spcBef>
-                <a:spcPts val="0"/>
-              </a:spcBef>
-            </a:pPr>
-            <a:r>
-              <a:rPr lang="en-US" sz="2000" b="0" i="0" u="none" strike="noStrike" dirty="0">
-                <a:solidFill>
-                  <a:srgbClr val="000000"/>
-                </a:solidFill>
-                <a:effectLst/>
-                <a:latin typeface="Segoe UI" panose="020B0502040204020203" pitchFamily="34" charset="0"/>
-                <a:cs typeface="Segoe UI" panose="020B0502040204020203" pitchFamily="34" charset="0"/>
-              </a:rPr>
-              <a:t>"Endoplasmic Reticulum", </a:t>
-            </a:r>
-          </a:p>
-          <a:p>
-            <a:pPr marL="457200" lvl="1">
-              <a:spcBef>
-                <a:spcPts val="0"/>
-              </a:spcBef>
-            </a:pPr>
-            <a:r>
-              <a:rPr lang="en-US" sz="2000" b="0" i="0" u="none" strike="noStrike" dirty="0">
-                <a:solidFill>
-                  <a:srgbClr val="000000"/>
-                </a:solidFill>
-                <a:effectLst/>
-                <a:latin typeface="Segoe UI" panose="020B0502040204020203" pitchFamily="34" charset="0"/>
-                <a:cs typeface="Segoe UI" panose="020B0502040204020203" pitchFamily="34" charset="0"/>
-              </a:rPr>
-              <a:t>"Rough endoplasmic reticulum", </a:t>
-            </a:r>
-          </a:p>
-          <a:p>
-            <a:pPr marL="457200" lvl="1">
-              <a:spcBef>
-                <a:spcPts val="0"/>
-              </a:spcBef>
-            </a:pPr>
-            <a:endParaRPr lang="en-US" sz="2000" b="0" i="0" u="none" strike="noStrike" dirty="0">
-              <a:solidFill>
-                <a:srgbClr val="000000"/>
-              </a:solidFill>
-              <a:effectLst/>
-              <a:latin typeface="Segoe UI" panose="020B0502040204020203" pitchFamily="34" charset="0"/>
-              <a:cs typeface="Segoe UI" panose="020B0502040204020203" pitchFamily="34" charset="0"/>
-            </a:endParaRPr>
-          </a:p>
-          <a:p>
-            <a:pPr marL="0" marR="0" algn="l">
-              <a:spcBef>
-                <a:spcPts val="0"/>
-              </a:spcBef>
-              <a:spcAft>
-                <a:spcPts val="0"/>
-              </a:spcAft>
-            </a:pPr>
-            <a:r>
-              <a:rPr lang="en-US" sz="2000" b="0" i="0" u="none" strike="noStrike" dirty="0">
-                <a:solidFill>
-                  <a:srgbClr val="000000"/>
-                </a:solidFill>
-                <a:effectLst/>
-                <a:latin typeface="Segoe UI" panose="020B0502040204020203" pitchFamily="34" charset="0"/>
-                <a:cs typeface="Segoe UI" panose="020B0502040204020203" pitchFamily="34" charset="0"/>
-              </a:rPr>
-              <a:t>If yes, then check if the </a:t>
-            </a:r>
-            <a:r>
-              <a:rPr lang="en-US" sz="2000" b="1" i="0" u="none" strike="noStrike" dirty="0">
-                <a:solidFill>
-                  <a:srgbClr val="000000"/>
-                </a:solidFill>
-                <a:effectLst/>
-                <a:latin typeface="Segoe UI" panose="020B0502040204020203" pitchFamily="34" charset="0"/>
-                <a:cs typeface="Segoe UI" panose="020B0502040204020203" pitchFamily="34" charset="0"/>
-              </a:rPr>
-              <a:t>score column </a:t>
-            </a:r>
-            <a:r>
-              <a:rPr lang="en-US" sz="2000" b="0" i="0" u="none" strike="noStrike" dirty="0">
-                <a:solidFill>
-                  <a:srgbClr val="000000"/>
-                </a:solidFill>
-                <a:effectLst/>
-                <a:latin typeface="Segoe UI" panose="020B0502040204020203" pitchFamily="34" charset="0"/>
-                <a:cs typeface="Segoe UI" panose="020B0502040204020203" pitchFamily="34" charset="0"/>
-              </a:rPr>
-              <a:t>has a value &gt;= 0.7 but the </a:t>
-            </a:r>
-            <a:r>
-              <a:rPr lang="en-US" sz="2000" b="1" i="0" u="none" strike="noStrike" dirty="0" err="1">
-                <a:solidFill>
-                  <a:srgbClr val="000000"/>
-                </a:solidFill>
-                <a:effectLst/>
-                <a:latin typeface="Segoe UI" panose="020B0502040204020203" pitchFamily="34" charset="0"/>
-                <a:cs typeface="Segoe UI" panose="020B0502040204020203" pitchFamily="34" charset="0"/>
-              </a:rPr>
-              <a:t>UPS_score</a:t>
-            </a:r>
-            <a:r>
-              <a:rPr lang="en-US" sz="2000" b="1" i="0" u="none" strike="noStrike" dirty="0">
-                <a:solidFill>
-                  <a:srgbClr val="000000"/>
-                </a:solidFill>
-                <a:effectLst/>
-                <a:latin typeface="Segoe UI" panose="020B0502040204020203" pitchFamily="34" charset="0"/>
-                <a:cs typeface="Segoe UI" panose="020B0502040204020203" pitchFamily="34" charset="0"/>
-              </a:rPr>
-              <a:t> </a:t>
-            </a:r>
-            <a:r>
-              <a:rPr lang="en-US" sz="2000" b="0" i="0" u="none" strike="noStrike" dirty="0">
-                <a:solidFill>
-                  <a:srgbClr val="000000"/>
-                </a:solidFill>
-                <a:effectLst/>
-                <a:latin typeface="Segoe UI" panose="020B0502040204020203" pitchFamily="34" charset="0"/>
-                <a:cs typeface="Segoe UI" panose="020B0502040204020203" pitchFamily="34" charset="0"/>
-              </a:rPr>
-              <a:t>column value is 0</a:t>
-            </a:r>
-          </a:p>
-          <a:p>
-            <a:pPr marL="0" marR="0" indent="0" algn="l">
-              <a:spcBef>
-                <a:spcPts val="0"/>
-              </a:spcBef>
-              <a:spcAft>
-                <a:spcPts val="0"/>
-              </a:spcAft>
-              <a:buNone/>
-            </a:pPr>
-            <a:endParaRPr lang="en-US" sz="2000" dirty="0">
-              <a:solidFill>
-                <a:srgbClr val="000000"/>
-              </a:solidFill>
-              <a:latin typeface="Segoe UI" panose="020B0502040204020203" pitchFamily="34" charset="0"/>
-              <a:cs typeface="Segoe UI" panose="020B0502040204020203" pitchFamily="34" charset="0"/>
-            </a:endParaRPr>
-          </a:p>
-          <a:p>
-            <a:pPr marL="0" marR="0" indent="0" algn="l">
-              <a:spcBef>
-                <a:spcPts val="0"/>
-              </a:spcBef>
-              <a:spcAft>
-                <a:spcPts val="0"/>
-              </a:spcAft>
-              <a:buNone/>
-            </a:pPr>
-            <a:r>
-              <a:rPr lang="en-US" sz="1400" b="0" u="none" strike="noStrike" dirty="0">
-                <a:solidFill>
-                  <a:srgbClr val="000000"/>
-                </a:solidFill>
-                <a:effectLst/>
-                <a:latin typeface="Calibri" panose="020F0502020204030204" pitchFamily="34" charset="0"/>
-              </a:rPr>
-              <a:t>Note from Corey: </a:t>
-            </a:r>
-            <a:r>
-              <a:rPr lang="en-US" sz="1400" b="0" i="1" u="none" strike="noStrike" dirty="0">
-                <a:solidFill>
-                  <a:srgbClr val="000000"/>
-                </a:solidFill>
-                <a:effectLst/>
-                <a:latin typeface="Calibri" panose="020F0502020204030204" pitchFamily="34" charset="0"/>
-              </a:rPr>
-              <a:t>The “score” column represents the likelihood of classical secretion, while the “</a:t>
-            </a:r>
-            <a:r>
-              <a:rPr lang="en-US" sz="1400" b="0" i="1" u="none" strike="noStrike" dirty="0" err="1">
-                <a:solidFill>
-                  <a:srgbClr val="000000"/>
-                </a:solidFill>
-                <a:effectLst/>
-                <a:latin typeface="Calibri" panose="020F0502020204030204" pitchFamily="34" charset="0"/>
-              </a:rPr>
-              <a:t>UPS_score</a:t>
-            </a:r>
-            <a:r>
-              <a:rPr lang="en-US" sz="1400" b="0" i="1" u="none" strike="noStrike" dirty="0">
-                <a:solidFill>
-                  <a:srgbClr val="000000"/>
-                </a:solidFill>
-                <a:effectLst/>
-                <a:latin typeface="Calibri" panose="020F0502020204030204" pitchFamily="34" charset="0"/>
-              </a:rPr>
-              <a:t>” is the likelihood of unclassical secretion. Because we expect to be tagging classically secreted proteins, I would actually </a:t>
-            </a:r>
-            <a:r>
-              <a:rPr lang="en-US" sz="1400" b="1" i="1" u="none" strike="noStrike" dirty="0">
-                <a:solidFill>
-                  <a:srgbClr val="000000"/>
-                </a:solidFill>
-                <a:effectLst/>
-                <a:latin typeface="Calibri" panose="020F0502020204030204" pitchFamily="34" charset="0"/>
-              </a:rPr>
-              <a:t>exclude</a:t>
-            </a:r>
-            <a:r>
-              <a:rPr lang="en-US" sz="1400" b="0" i="1" u="none" strike="noStrike" dirty="0">
-                <a:solidFill>
-                  <a:srgbClr val="000000"/>
-                </a:solidFill>
-                <a:effectLst/>
-                <a:latin typeface="Calibri" panose="020F0502020204030204" pitchFamily="34" charset="0"/>
-              </a:rPr>
-              <a:t> those proteins from the TP list that have a high </a:t>
-            </a:r>
-            <a:r>
-              <a:rPr lang="en-US" sz="1400" b="0" i="1" u="none" strike="noStrike" dirty="0" err="1">
-                <a:solidFill>
-                  <a:srgbClr val="000000"/>
-                </a:solidFill>
-                <a:effectLst/>
-                <a:latin typeface="Calibri" panose="020F0502020204030204" pitchFamily="34" charset="0"/>
-              </a:rPr>
-              <a:t>UPS_score</a:t>
-            </a:r>
-            <a:r>
-              <a:rPr lang="en-US" sz="1400" b="0" i="1" u="none" strike="noStrike" dirty="0">
-                <a:solidFill>
-                  <a:srgbClr val="000000"/>
-                </a:solidFill>
-                <a:effectLst/>
-                <a:latin typeface="Calibri" panose="020F0502020204030204" pitchFamily="34" charset="0"/>
-              </a:rPr>
-              <a:t>, as they may not be trafficked through the ER for secretion.</a:t>
-            </a:r>
-            <a:endParaRPr lang="en-US" sz="2000" b="0" i="1" u="none" strike="noStrike" dirty="0">
-              <a:solidFill>
-                <a:srgbClr val="000000"/>
-              </a:solidFill>
-              <a:effectLst/>
-              <a:latin typeface="Segoe UI" panose="020B0502040204020203" pitchFamily="34" charset="0"/>
-              <a:cs typeface="Segoe UI" panose="020B0502040204020203" pitchFamily="34" charset="0"/>
-            </a:endParaRPr>
-          </a:p>
-          <a:p>
-            <a:pPr marL="0" marR="0" indent="0" algn="l">
-              <a:spcBef>
-                <a:spcPts val="0"/>
-              </a:spcBef>
-              <a:spcAft>
-                <a:spcPts val="0"/>
-              </a:spcAft>
-              <a:buNone/>
-            </a:pPr>
-            <a:endParaRPr lang="en-US" sz="2000" b="0" i="0" u="none" strike="noStrike" dirty="0">
-              <a:solidFill>
-                <a:srgbClr val="000000"/>
-              </a:solidFill>
-              <a:effectLst/>
-              <a:latin typeface="Segoe UI" panose="020B0502040204020203" pitchFamily="34" charset="0"/>
-              <a:cs typeface="Segoe UI" panose="020B0502040204020203" pitchFamily="34" charset="0"/>
-            </a:endParaRPr>
-          </a:p>
-          <a:p>
-            <a:pPr marL="0" marR="0" algn="l">
-              <a:spcBef>
-                <a:spcPts val="0"/>
-              </a:spcBef>
-              <a:spcAft>
-                <a:spcPts val="0"/>
-              </a:spcAft>
-            </a:pPr>
-            <a:r>
-              <a:rPr lang="en-US" sz="2000" b="0" i="0" u="none" strike="noStrike" dirty="0">
-                <a:solidFill>
-                  <a:srgbClr val="000000"/>
-                </a:solidFill>
-                <a:effectLst/>
-                <a:latin typeface="Segoe UI" panose="020B0502040204020203" pitchFamily="34" charset="0"/>
-                <a:cs typeface="Segoe UI" panose="020B0502040204020203" pitchFamily="34" charset="0"/>
-              </a:rPr>
-              <a:t>Then for the FP lists use the </a:t>
-            </a:r>
-            <a:r>
-              <a:rPr lang="en-US" sz="2000" b="0" i="0" u="none" strike="noStrike" dirty="0" err="1">
-                <a:solidFill>
-                  <a:srgbClr val="000000"/>
-                </a:solidFill>
-                <a:effectLst/>
-                <a:latin typeface="Segoe UI" panose="020B0502040204020203" pitchFamily="34" charset="0"/>
-                <a:cs typeface="Segoe UI" panose="020B0502040204020203" pitchFamily="34" charset="0"/>
-              </a:rPr>
-              <a:t>mitomatrix</a:t>
-            </a:r>
-            <a:r>
-              <a:rPr lang="en-US" sz="2000" b="0" i="0" u="none" strike="noStrike" dirty="0">
-                <a:solidFill>
-                  <a:srgbClr val="000000"/>
-                </a:solidFill>
-                <a:effectLst/>
-                <a:latin typeface="Segoe UI" panose="020B0502040204020203" pitchFamily="34" charset="0"/>
-                <a:cs typeface="Segoe UI" panose="020B0502040204020203" pitchFamily="34" charset="0"/>
-              </a:rPr>
-              <a:t> list – but exclude the proteins with </a:t>
-            </a:r>
-            <a:r>
-              <a:rPr lang="en-US" sz="2000" b="1" i="0" u="none" strike="noStrike" dirty="0">
-                <a:solidFill>
-                  <a:srgbClr val="000000"/>
-                </a:solidFill>
-                <a:effectLst/>
-                <a:latin typeface="Segoe UI" panose="020B0502040204020203" pitchFamily="34" charset="0"/>
-                <a:cs typeface="Segoe UI" panose="020B0502040204020203" pitchFamily="34" charset="0"/>
-              </a:rPr>
-              <a:t>score column </a:t>
-            </a:r>
-            <a:r>
-              <a:rPr lang="en-US" sz="2000" b="0" i="0" u="none" strike="noStrike" dirty="0">
-                <a:solidFill>
-                  <a:srgbClr val="000000"/>
-                </a:solidFill>
-                <a:effectLst/>
-                <a:latin typeface="Segoe UI" panose="020B0502040204020203" pitchFamily="34" charset="0"/>
-                <a:cs typeface="Segoe UI" panose="020B0502040204020203" pitchFamily="34" charset="0"/>
-              </a:rPr>
-              <a:t>&gt;= 0.7 and </a:t>
-            </a:r>
-            <a:r>
-              <a:rPr lang="en-US" sz="2000" b="1" i="0" u="none" strike="noStrike" dirty="0" err="1">
-                <a:solidFill>
-                  <a:srgbClr val="000000"/>
-                </a:solidFill>
-                <a:effectLst/>
-                <a:latin typeface="Segoe UI" panose="020B0502040204020203" pitchFamily="34" charset="0"/>
-                <a:cs typeface="Segoe UI" panose="020B0502040204020203" pitchFamily="34" charset="0"/>
-              </a:rPr>
-              <a:t>UPS_score</a:t>
-            </a:r>
-            <a:r>
-              <a:rPr lang="en-US" sz="2000" b="1" i="0" u="none" strike="noStrike" dirty="0">
-                <a:solidFill>
-                  <a:srgbClr val="000000"/>
-                </a:solidFill>
-                <a:effectLst/>
-                <a:latin typeface="Segoe UI" panose="020B0502040204020203" pitchFamily="34" charset="0"/>
-                <a:cs typeface="Segoe UI" panose="020B0502040204020203" pitchFamily="34" charset="0"/>
-              </a:rPr>
-              <a:t> </a:t>
-            </a:r>
-            <a:r>
-              <a:rPr lang="en-US" sz="2000" b="0" i="0" u="none" strike="noStrike" dirty="0">
-                <a:solidFill>
-                  <a:srgbClr val="000000"/>
-                </a:solidFill>
-                <a:effectLst/>
-                <a:latin typeface="Segoe UI" panose="020B0502040204020203" pitchFamily="34" charset="0"/>
-                <a:cs typeface="Segoe UI" panose="020B0502040204020203" pitchFamily="34" charset="0"/>
-              </a:rPr>
-              <a:t>column value is 0</a:t>
-            </a:r>
-          </a:p>
-          <a:p>
-            <a:pPr marL="0" marR="0" indent="0" algn="l">
-              <a:spcBef>
-                <a:spcPts val="0"/>
-              </a:spcBef>
-              <a:spcAft>
-                <a:spcPts val="0"/>
-              </a:spcAft>
-              <a:buNone/>
-            </a:pPr>
-            <a:endParaRPr kumimoji="0" lang="en-US" sz="2000" b="0" i="0" u="none" strike="noStrike" kern="1200" cap="none" spc="20" normalizeH="0" baseline="0" noProof="0" dirty="0">
-              <a:ln>
-                <a:noFill/>
-              </a:ln>
-              <a:solidFill>
-                <a:srgbClr val="000000"/>
-              </a:solidFill>
-              <a:effectLst/>
-              <a:uLnTx/>
-              <a:uFillTx/>
-              <a:latin typeface="Avenir Next LT Pro"/>
-              <a:ea typeface="+mn-ea"/>
-              <a:cs typeface="+mn-cs"/>
-            </a:endParaRPr>
-          </a:p>
-          <a:p>
-            <a:pPr>
-              <a:buClr>
-                <a:srgbClr val="7BAF34"/>
-              </a:buClr>
-              <a:defRPr/>
-            </a:pPr>
-            <a:endParaRPr kumimoji="0" lang="en-US" sz="2000" b="0" i="0" u="none" strike="noStrike" kern="1200" cap="none" spc="20" normalizeH="0" baseline="0" noProof="0" dirty="0">
-              <a:ln>
-                <a:noFill/>
-              </a:ln>
-              <a:solidFill>
-                <a:srgbClr val="000000"/>
-              </a:solidFill>
-              <a:effectLst/>
-              <a:uLnTx/>
-              <a:uFillTx/>
-              <a:latin typeface="Avenir Next LT Pro"/>
-              <a:ea typeface="+mn-ea"/>
-              <a:cs typeface="+mn-cs"/>
-            </a:endParaRPr>
-          </a:p>
-          <a:p>
-            <a:pPr marL="0" marR="0" lvl="0" indent="0" algn="l" defTabSz="914400" rtl="0" eaLnBrk="1" fontAlgn="auto" latinLnBrk="0" hangingPunct="1">
-              <a:lnSpc>
-                <a:spcPct val="120000"/>
-              </a:lnSpc>
-              <a:spcBef>
-                <a:spcPts val="1000"/>
-              </a:spcBef>
-              <a:spcAft>
-                <a:spcPts val="0"/>
-              </a:spcAft>
-              <a:buClr>
-                <a:srgbClr val="7BAF34"/>
-              </a:buClr>
-              <a:buSzTx/>
-              <a:buNone/>
-              <a:tabLst/>
-              <a:defRPr/>
-            </a:pPr>
-            <a:endParaRPr kumimoji="0" lang="en-US" sz="2000" b="1" i="0" u="none" strike="noStrike" kern="1200" cap="none" spc="20" normalizeH="0" baseline="0" noProof="0" dirty="0">
-              <a:ln>
-                <a:noFill/>
-              </a:ln>
-              <a:solidFill>
-                <a:srgbClr val="000000"/>
-              </a:solidFill>
-              <a:effectLst/>
-              <a:uLnTx/>
-              <a:uFillTx/>
-              <a:latin typeface="Avenir Next LT Pro"/>
-              <a:ea typeface="+mn-ea"/>
-              <a:cs typeface="+mn-cs"/>
-            </a:endParaRPr>
-          </a:p>
-          <a:p>
-            <a:pPr marL="0" marR="0" lvl="0" indent="0" algn="l" defTabSz="914400" rtl="0" eaLnBrk="1" fontAlgn="auto" latinLnBrk="0" hangingPunct="1">
-              <a:lnSpc>
-                <a:spcPct val="120000"/>
-              </a:lnSpc>
-              <a:spcBef>
-                <a:spcPts val="1000"/>
-              </a:spcBef>
-              <a:spcAft>
-                <a:spcPts val="0"/>
-              </a:spcAft>
-              <a:buClr>
-                <a:srgbClr val="7BAF34"/>
-              </a:buClr>
-              <a:buSzTx/>
-              <a:buNone/>
-              <a:tabLst/>
-              <a:defRPr/>
-            </a:pPr>
-            <a:endParaRPr kumimoji="0" lang="en-US" sz="2000" b="0" i="0" u="none" strike="noStrike" kern="1200" cap="none" spc="20" normalizeH="0" baseline="0" noProof="0" dirty="0">
-              <a:ln>
-                <a:noFill/>
-              </a:ln>
-              <a:solidFill>
-                <a:srgbClr val="000000"/>
-              </a:solidFill>
-              <a:effectLst/>
-              <a:uLnTx/>
-              <a:uFillTx/>
-              <a:latin typeface="Avenir Next LT Pro"/>
-              <a:ea typeface="+mn-ea"/>
-              <a:cs typeface="+mn-cs"/>
-            </a:endParaRPr>
-          </a:p>
-          <a:p>
-            <a:pPr lvl="1">
-              <a:spcBef>
-                <a:spcPts val="1000"/>
-              </a:spcBef>
-              <a:buClr>
-                <a:srgbClr val="7BAF34"/>
-              </a:buClr>
-              <a:defRPr/>
-            </a:pPr>
-            <a:endParaRPr kumimoji="0" lang="en-US" b="0" i="0" u="none" strike="noStrike" kern="1200" cap="none" spc="20" normalizeH="0" baseline="0" noProof="0" dirty="0">
-              <a:ln>
-                <a:noFill/>
-              </a:ln>
-              <a:solidFill>
-                <a:srgbClr val="000000"/>
-              </a:solidFill>
-              <a:effectLst/>
-              <a:uLnTx/>
-              <a:uFillTx/>
-              <a:latin typeface="Avenir Next LT Pro"/>
-              <a:ea typeface="+mn-ea"/>
-              <a:cs typeface="+mn-cs"/>
-            </a:endParaRPr>
-          </a:p>
-          <a:p>
-            <a:pPr marL="228600" marR="0" lvl="0" indent="-228600" algn="l" defTabSz="914400" rtl="0" eaLnBrk="1" fontAlgn="auto" latinLnBrk="0" hangingPunct="1">
-              <a:lnSpc>
-                <a:spcPct val="120000"/>
-              </a:lnSpc>
-              <a:spcBef>
-                <a:spcPts val="1000"/>
-              </a:spcBef>
-              <a:spcAft>
-                <a:spcPts val="0"/>
-              </a:spcAft>
-              <a:buClr>
-                <a:srgbClr val="7BAF34"/>
-              </a:buClr>
-              <a:buSzTx/>
-              <a:buFont typeface="The Hand Extrablack" panose="03070A02030502020204" pitchFamily="66" charset="0"/>
-              <a:buChar char="•"/>
-              <a:tabLst/>
-              <a:defRPr/>
-            </a:pPr>
-            <a:endParaRPr lang="en-US" dirty="0">
-              <a:solidFill>
-                <a:srgbClr val="000000"/>
-              </a:solidFill>
-              <a:latin typeface="Avenir Next LT Pro"/>
-            </a:endParaRPr>
-          </a:p>
-          <a:p>
-            <a:pPr marL="0" marR="0" lvl="0" indent="0" algn="l" defTabSz="914400" rtl="0" eaLnBrk="1" fontAlgn="auto" latinLnBrk="0" hangingPunct="1">
-              <a:lnSpc>
-                <a:spcPct val="120000"/>
-              </a:lnSpc>
-              <a:spcBef>
-                <a:spcPts val="1000"/>
-              </a:spcBef>
-              <a:spcAft>
-                <a:spcPts val="0"/>
-              </a:spcAft>
-              <a:buClr>
-                <a:srgbClr val="7BAF34"/>
-              </a:buClr>
-              <a:buSzTx/>
-              <a:buNone/>
-              <a:tabLst/>
-              <a:defRPr/>
-            </a:pPr>
-            <a:endParaRPr kumimoji="0" lang="en-US" sz="2000" b="0" i="0" u="none" strike="noStrike" kern="1200" cap="none" spc="20" normalizeH="0" baseline="0" noProof="0" dirty="0">
-              <a:ln>
-                <a:noFill/>
-              </a:ln>
-              <a:solidFill>
-                <a:srgbClr val="000000"/>
-              </a:solidFill>
-              <a:effectLst/>
-              <a:uLnTx/>
-              <a:uFillTx/>
-              <a:latin typeface="Avenir Next LT Pro"/>
-              <a:ea typeface="+mn-ea"/>
-              <a:cs typeface="+mn-cs"/>
-            </a:endParaRPr>
-          </a:p>
-          <a:p>
-            <a:pPr marL="228600" marR="0" lvl="0" indent="-228600" algn="l" defTabSz="914400" rtl="0" eaLnBrk="1" fontAlgn="auto" latinLnBrk="0" hangingPunct="1">
-              <a:lnSpc>
-                <a:spcPct val="120000"/>
-              </a:lnSpc>
-              <a:spcBef>
-                <a:spcPts val="1000"/>
-              </a:spcBef>
-              <a:spcAft>
-                <a:spcPts val="0"/>
-              </a:spcAft>
-              <a:buClr>
-                <a:srgbClr val="7BAF34"/>
-              </a:buClr>
-              <a:buSzTx/>
-              <a:buFont typeface="The Hand Extrablack" panose="03070A02030502020204" pitchFamily="66" charset="0"/>
-              <a:buChar char="•"/>
-              <a:tabLst/>
-              <a:defRPr/>
-            </a:pPr>
-            <a:endParaRPr kumimoji="0" lang="en-US" sz="2000" b="0" i="0" u="none" strike="noStrike" kern="1200" cap="none" spc="20" normalizeH="0" baseline="0" noProof="0" dirty="0">
-              <a:ln>
-                <a:noFill/>
-              </a:ln>
-              <a:solidFill>
-                <a:srgbClr val="000000"/>
-              </a:solidFill>
-              <a:effectLst/>
-              <a:uLnTx/>
-              <a:uFillTx/>
-              <a:latin typeface="Avenir Next LT Pro"/>
-              <a:ea typeface="+mn-ea"/>
-              <a:cs typeface="+mn-cs"/>
-            </a:endParaRPr>
-          </a:p>
-        </p:txBody>
-      </p:sp>
-    </p:spTree>
-    <p:extLst>
-      <p:ext uri="{BB962C8B-B14F-4D97-AF65-F5344CB8AC3E}">
-        <p14:creationId xmlns:p14="http://schemas.microsoft.com/office/powerpoint/2010/main" val="787388046"/>
-      </p:ext>
-    </p:extLst>
-  </p:cSld>
-  <p:clrMapOvr>
-    <a:masterClrMapping/>
-  </p:clrMapOvr>
-</p:sld>
-</file>
-
-<file path=ppt/slides/slide27.xml><?xml version="1.0" encoding="utf-8"?>
-<p:sld xmlns:a="http://schemas.openxmlformats.org/drawingml/2006/main" xmlns:r="http://schemas.openxmlformats.org/officeDocument/2006/relationships" xmlns:p="http://schemas.openxmlformats.org/presentationml/2006/main">
-  <p:cSld>
-    <p:spTree>
-      <p:nvGrpSpPr>
-        <p:cNvPr id="1" name=""/>
-        <p:cNvGrpSpPr/>
-        <p:nvPr/>
-      </p:nvGrpSpPr>
-      <p:grpSpPr>
-        <a:xfrm>
-          <a:off x="0" y="0"/>
-          <a:ext cx="0" cy="0"/>
-          <a:chOff x="0" y="0"/>
-          <a:chExt cx="0" cy="0"/>
-        </a:xfrm>
-      </p:grpSpPr>
-      <p:sp>
-        <p:nvSpPr>
-          <p:cNvPr id="11" name="Rectangle 10">
-            <a:extLst>
-              <a:ext uri="{FF2B5EF4-FFF2-40B4-BE49-F238E27FC236}">
-                <a16:creationId xmlns:a16="http://schemas.microsoft.com/office/drawing/2014/main" id="{79FB9493-3B31-7442-A8F3-792E4A8E4E18}"/>
-              </a:ext>
-            </a:extLst>
-          </p:cNvPr>
-          <p:cNvSpPr/>
-          <p:nvPr/>
-        </p:nvSpPr>
-        <p:spPr>
-          <a:xfrm>
-            <a:off x="720000" y="3648545"/>
-            <a:ext cx="10881450" cy="1897380"/>
-          </a:xfrm>
-          <a:prstGeom prst="rect">
-            <a:avLst/>
-          </a:prstGeom>
-          <a:solidFill>
-            <a:schemeClr val="accent6">
-              <a:lumMod val="20000"/>
-              <a:lumOff val="80000"/>
-            </a:schemeClr>
-          </a:solidFill>
-          <a:ln>
-            <a:noFill/>
-          </a:ln>
-        </p:spPr>
-        <p:style>
-          <a:lnRef idx="2">
-            <a:schemeClr val="accent1">
-              <a:shade val="50000"/>
-            </a:schemeClr>
-          </a:lnRef>
-          <a:fillRef idx="1">
-            <a:schemeClr val="accent1"/>
-          </a:fillRef>
-          <a:effectRef idx="0">
-            <a:schemeClr val="accent1"/>
-          </a:effectRef>
-          <a:fontRef idx="minor">
-            <a:schemeClr val="lt1"/>
-          </a:fontRef>
-        </p:style>
-        <p:txBody>
-          <a:bodyPr rtlCol="0" anchor="ctr"/>
-          <a:lstStyle/>
-          <a:p>
-            <a:pPr algn="ctr"/>
-            <a:endParaRPr lang="en-US"/>
-          </a:p>
-        </p:txBody>
-      </p:sp>
-      <p:sp>
-        <p:nvSpPr>
-          <p:cNvPr id="2" name="Rectangle 1">
-            <a:extLst>
-              <a:ext uri="{FF2B5EF4-FFF2-40B4-BE49-F238E27FC236}">
-                <a16:creationId xmlns:a16="http://schemas.microsoft.com/office/drawing/2014/main" id="{0FDC7938-1D84-FF4D-83EF-7F7E750E52EB}"/>
-              </a:ext>
-            </a:extLst>
-          </p:cNvPr>
-          <p:cNvSpPr/>
-          <p:nvPr/>
-        </p:nvSpPr>
-        <p:spPr>
-          <a:xfrm>
-            <a:off x="720000" y="1611630"/>
-            <a:ext cx="10881450" cy="1897380"/>
-          </a:xfrm>
-          <a:prstGeom prst="rect">
-            <a:avLst/>
-          </a:prstGeom>
-          <a:solidFill>
-            <a:schemeClr val="accent2">
-              <a:lumMod val="20000"/>
-              <a:lumOff val="80000"/>
-            </a:schemeClr>
-          </a:solidFill>
-          <a:ln>
-            <a:noFill/>
-          </a:ln>
-        </p:spPr>
-        <p:style>
-          <a:lnRef idx="2">
-            <a:schemeClr val="accent1">
-              <a:shade val="50000"/>
-            </a:schemeClr>
-          </a:lnRef>
-          <a:fillRef idx="1">
-            <a:schemeClr val="accent1"/>
-          </a:fillRef>
-          <a:effectRef idx="0">
-            <a:schemeClr val="accent1"/>
-          </a:effectRef>
-          <a:fontRef idx="minor">
-            <a:schemeClr val="lt1"/>
-          </a:fontRef>
-        </p:style>
-        <p:txBody>
-          <a:bodyPr rtlCol="0" anchor="ctr"/>
-          <a:lstStyle/>
-          <a:p>
-            <a:pPr algn="ctr"/>
-            <a:endParaRPr lang="en-US"/>
-          </a:p>
-        </p:txBody>
-      </p:sp>
-      <p:sp>
-        <p:nvSpPr>
-          <p:cNvPr id="4" name="Slide Number Placeholder 3">
-            <a:extLst>
-              <a:ext uri="{FF2B5EF4-FFF2-40B4-BE49-F238E27FC236}">
-                <a16:creationId xmlns:a16="http://schemas.microsoft.com/office/drawing/2014/main" id="{4383861C-DDFF-F94F-B844-7188E07B1951}"/>
-              </a:ext>
-            </a:extLst>
-          </p:cNvPr>
-          <p:cNvSpPr>
-            <a:spLocks noGrp="1"/>
-          </p:cNvSpPr>
-          <p:nvPr>
-            <p:ph type="sldNum" sz="quarter" idx="12"/>
-          </p:nvPr>
-        </p:nvSpPr>
-        <p:spPr/>
-        <p:txBody>
-          <a:bodyPr/>
-          <a:lstStyle/>
-          <a:p>
-            <a:fld id="{1621B6DD-29C1-4FEA-923F-71EA1347694C}" type="slidenum">
-              <a:rPr lang="en-US" smtClean="0"/>
-              <a:t>26</a:t>
-            </a:fld>
-            <a:endParaRPr lang="en-US"/>
-          </a:p>
-        </p:txBody>
-      </p:sp>
-      <p:sp>
-        <p:nvSpPr>
-          <p:cNvPr id="6" name="Title 1">
-            <a:extLst>
-              <a:ext uri="{FF2B5EF4-FFF2-40B4-BE49-F238E27FC236}">
-                <a16:creationId xmlns:a16="http://schemas.microsoft.com/office/drawing/2014/main" id="{8BB2DFB4-E4EC-CC46-BF2B-90B0CB50A619}"/>
-              </a:ext>
-            </a:extLst>
-          </p:cNvPr>
-          <p:cNvSpPr txBox="1">
-            <a:spLocks/>
-          </p:cNvSpPr>
-          <p:nvPr/>
-        </p:nvSpPr>
-        <p:spPr>
-          <a:xfrm>
-            <a:off x="720000" y="619200"/>
-            <a:ext cx="10728322" cy="666675"/>
-          </a:xfrm>
-          <a:prstGeom prst="rect">
-            <a:avLst/>
-          </a:prstGeom>
-        </p:spPr>
-        <p:txBody>
-          <a:bodyPr vert="horz" lIns="91440" tIns="45720" rIns="91440" bIns="45720" rtlCol="0" anchor="ctr">
-            <a:normAutofit fontScale="97500" lnSpcReduction="10000"/>
-          </a:bodyPr>
-          <a:lstStyle>
-            <a:lvl1pPr algn="l" defTabSz="914400" rtl="0" eaLnBrk="1" latinLnBrk="0" hangingPunct="1">
-              <a:lnSpc>
-                <a:spcPct val="90000"/>
-              </a:lnSpc>
-              <a:spcBef>
-                <a:spcPct val="0"/>
-              </a:spcBef>
-              <a:buNone/>
-              <a:defRPr sz="4400" kern="1200">
-                <a:solidFill>
-                  <a:schemeClr val="tx1"/>
-                </a:solidFill>
-                <a:latin typeface="+mj-lt"/>
-                <a:ea typeface="+mj-ea"/>
-                <a:cs typeface="+mj-cs"/>
-              </a:defRPr>
-            </a:lvl1pPr>
-          </a:lstStyle>
-          <a:p>
-            <a:r>
-              <a:rPr lang="en-US" b="1" dirty="0">
-                <a:latin typeface="Times New Roman" panose="02020603050405020304" pitchFamily="18" charset="0"/>
-                <a:cs typeface="Times New Roman" panose="02020603050405020304" pitchFamily="18" charset="0"/>
-              </a:rPr>
-              <a:t>Total number of proteins in list </a:t>
-            </a:r>
-          </a:p>
-        </p:txBody>
-      </p:sp>
-      <p:sp>
-        <p:nvSpPr>
-          <p:cNvPr id="5" name="Content Placeholder 2">
-            <a:extLst>
-              <a:ext uri="{FF2B5EF4-FFF2-40B4-BE49-F238E27FC236}">
-                <a16:creationId xmlns:a16="http://schemas.microsoft.com/office/drawing/2014/main" id="{D334BA8F-7D11-7C46-92B4-623B02C91ADB}"/>
-              </a:ext>
-            </a:extLst>
-          </p:cNvPr>
-          <p:cNvSpPr>
-            <a:spLocks noGrp="1"/>
-          </p:cNvSpPr>
-          <p:nvPr>
-            <p:ph idx="1"/>
-          </p:nvPr>
-        </p:nvSpPr>
-        <p:spPr>
-          <a:xfrm>
-            <a:off x="1106545" y="1764307"/>
-            <a:ext cx="9978909" cy="3864074"/>
-          </a:xfrm>
-        </p:spPr>
-        <p:txBody>
-          <a:bodyPr>
-            <a:normAutofit/>
-          </a:bodyPr>
-          <a:lstStyle/>
-          <a:p>
-            <a:pPr marL="0" indent="0">
-              <a:lnSpc>
-                <a:spcPct val="120000"/>
-              </a:lnSpc>
-              <a:buClr>
-                <a:schemeClr val="tx1"/>
-              </a:buClr>
-              <a:buNone/>
-              <a:defRPr/>
-            </a:pPr>
-            <a:r>
-              <a:rPr lang="en-US" sz="2000" i="0" spc="20" dirty="0">
-                <a:solidFill>
-                  <a:srgbClr val="000000"/>
-                </a:solidFill>
-                <a:latin typeface="Segoe UI" panose="020B0502040204020203" pitchFamily="34" charset="0"/>
-                <a:cs typeface="Segoe UI" panose="020B0502040204020203" pitchFamily="34" charset="0"/>
-              </a:rPr>
-              <a:t>Old lists </a:t>
-            </a:r>
-            <a:endParaRPr lang="en-US" sz="2000" b="1" spc="20" dirty="0">
-              <a:solidFill>
-                <a:srgbClr val="000000"/>
-              </a:solidFill>
-              <a:latin typeface="Segoe UI" panose="020B0502040204020203" pitchFamily="34" charset="0"/>
-              <a:cs typeface="Segoe UI" panose="020B0502040204020203" pitchFamily="34" charset="0"/>
-            </a:endParaRPr>
-          </a:p>
-          <a:p>
-            <a:pPr>
-              <a:buClr>
-                <a:srgbClr val="7BAF34"/>
-              </a:buClr>
-              <a:defRPr/>
-            </a:pPr>
-            <a:endParaRPr kumimoji="0" lang="en-US" sz="2000" b="0" i="0" u="none" strike="noStrike" kern="1200" cap="none" spc="20" normalizeH="0" baseline="0" noProof="0" dirty="0">
-              <a:ln>
-                <a:noFill/>
-              </a:ln>
-              <a:solidFill>
-                <a:srgbClr val="000000"/>
-              </a:solidFill>
-              <a:effectLst/>
-              <a:uLnTx/>
-              <a:uFillTx/>
-              <a:latin typeface="Avenir Next LT Pro"/>
-              <a:ea typeface="+mn-ea"/>
-              <a:cs typeface="+mn-cs"/>
-            </a:endParaRPr>
-          </a:p>
-          <a:p>
-            <a:pPr marL="0" marR="0" lvl="0" indent="0" algn="l" defTabSz="914400" rtl="0" eaLnBrk="1" fontAlgn="auto" latinLnBrk="0" hangingPunct="1">
-              <a:lnSpc>
-                <a:spcPct val="120000"/>
-              </a:lnSpc>
-              <a:spcBef>
-                <a:spcPts val="1000"/>
-              </a:spcBef>
-              <a:spcAft>
-                <a:spcPts val="0"/>
-              </a:spcAft>
-              <a:buClr>
-                <a:srgbClr val="7BAF34"/>
-              </a:buClr>
-              <a:buSzTx/>
-              <a:buNone/>
-              <a:tabLst/>
-              <a:defRPr/>
-            </a:pPr>
-            <a:endParaRPr kumimoji="0" lang="en-US" sz="2000" b="1" i="0" u="none" strike="noStrike" kern="1200" cap="none" spc="20" normalizeH="0" baseline="0" noProof="0" dirty="0">
-              <a:ln>
-                <a:noFill/>
-              </a:ln>
-              <a:solidFill>
-                <a:srgbClr val="000000"/>
-              </a:solidFill>
-              <a:effectLst/>
-              <a:uLnTx/>
-              <a:uFillTx/>
-              <a:latin typeface="Avenir Next LT Pro"/>
-              <a:ea typeface="+mn-ea"/>
-              <a:cs typeface="+mn-cs"/>
-            </a:endParaRPr>
-          </a:p>
-          <a:p>
-            <a:pPr marL="0" marR="0" lvl="0" indent="0" algn="l" defTabSz="914400" rtl="0" eaLnBrk="1" fontAlgn="auto" latinLnBrk="0" hangingPunct="1">
-              <a:lnSpc>
-                <a:spcPct val="120000"/>
-              </a:lnSpc>
-              <a:spcBef>
-                <a:spcPts val="1000"/>
-              </a:spcBef>
-              <a:spcAft>
-                <a:spcPts val="0"/>
-              </a:spcAft>
-              <a:buClr>
-                <a:srgbClr val="7BAF34"/>
-              </a:buClr>
-              <a:buSzTx/>
-              <a:buNone/>
-              <a:tabLst/>
-              <a:defRPr/>
-            </a:pPr>
-            <a:endParaRPr kumimoji="0" lang="en-US" sz="2000" b="0" i="0" u="none" strike="noStrike" kern="1200" cap="none" spc="20" normalizeH="0" baseline="0" noProof="0" dirty="0">
-              <a:ln>
-                <a:noFill/>
-              </a:ln>
-              <a:solidFill>
-                <a:srgbClr val="000000"/>
-              </a:solidFill>
-              <a:effectLst/>
-              <a:uLnTx/>
-              <a:uFillTx/>
-              <a:latin typeface="Avenir Next LT Pro"/>
-              <a:ea typeface="+mn-ea"/>
-              <a:cs typeface="+mn-cs"/>
-            </a:endParaRPr>
-          </a:p>
-          <a:p>
-            <a:pPr marL="0" indent="0">
-              <a:lnSpc>
-                <a:spcPct val="120000"/>
-              </a:lnSpc>
-              <a:buClr>
-                <a:srgbClr val="7BAF34"/>
-              </a:buClr>
-              <a:buNone/>
-              <a:defRPr/>
-            </a:pPr>
-            <a:r>
-              <a:rPr lang="en-US" sz="2000" i="0" spc="20" dirty="0">
-                <a:solidFill>
-                  <a:srgbClr val="000000"/>
-                </a:solidFill>
-                <a:latin typeface="Segoe UI" panose="020B0502040204020203" pitchFamily="34" charset="0"/>
-                <a:cs typeface="Segoe UI" panose="020B0502040204020203" pitchFamily="34" charset="0"/>
-              </a:rPr>
-              <a:t>New lists (with </a:t>
-            </a:r>
-            <a:r>
-              <a:rPr lang="en-US" sz="2000" i="0" spc="20" dirty="0" err="1">
-                <a:solidFill>
-                  <a:srgbClr val="000000"/>
-                </a:solidFill>
-                <a:latin typeface="Segoe UI" panose="020B0502040204020203" pitchFamily="34" charset="0"/>
-                <a:cs typeface="Segoe UI" panose="020B0502040204020203" pitchFamily="34" charset="0"/>
-              </a:rPr>
-              <a:t>SignalP</a:t>
-            </a:r>
-            <a:r>
-              <a:rPr lang="en-US" sz="2000" spc="20" dirty="0">
-                <a:solidFill>
-                  <a:srgbClr val="000000"/>
-                </a:solidFill>
-                <a:latin typeface="Segoe UI" panose="020B0502040204020203" pitchFamily="34" charset="0"/>
-                <a:cs typeface="Segoe UI" panose="020B0502040204020203" pitchFamily="34" charset="0"/>
-              </a:rPr>
-              <a:t>)</a:t>
-            </a:r>
-            <a:endParaRPr lang="en-US" sz="2000" b="1" spc="20" dirty="0">
-              <a:solidFill>
-                <a:srgbClr val="000000"/>
-              </a:solidFill>
-              <a:latin typeface="Segoe UI" panose="020B0502040204020203" pitchFamily="34" charset="0"/>
-              <a:cs typeface="Segoe UI" panose="020B0502040204020203" pitchFamily="34" charset="0"/>
-            </a:endParaRPr>
-          </a:p>
-          <a:p>
-            <a:pPr marL="0" marR="0" lvl="0" indent="0" algn="l" defTabSz="914400" rtl="0" eaLnBrk="1" fontAlgn="auto" latinLnBrk="0" hangingPunct="1">
-              <a:lnSpc>
-                <a:spcPct val="120000"/>
-              </a:lnSpc>
-              <a:spcBef>
-                <a:spcPts val="1000"/>
-              </a:spcBef>
-              <a:spcAft>
-                <a:spcPts val="0"/>
-              </a:spcAft>
-              <a:buClr>
-                <a:srgbClr val="7BAF34"/>
-              </a:buClr>
-              <a:buSzTx/>
-              <a:buNone/>
-              <a:tabLst/>
-              <a:defRPr/>
-            </a:pPr>
-            <a:endParaRPr kumimoji="0" lang="en-US" sz="2000" b="0" i="0" u="none" strike="noStrike" kern="1200" cap="none" spc="20" normalizeH="0" baseline="0" noProof="0" dirty="0">
-              <a:ln>
-                <a:noFill/>
-              </a:ln>
-              <a:solidFill>
-                <a:srgbClr val="000000"/>
-              </a:solidFill>
-              <a:effectLst/>
-              <a:uLnTx/>
-              <a:uFillTx/>
-              <a:latin typeface="Avenir Next LT Pro"/>
-              <a:ea typeface="+mn-ea"/>
-              <a:cs typeface="+mn-cs"/>
-            </a:endParaRPr>
-          </a:p>
-          <a:p>
-            <a:pPr lvl="1">
-              <a:spcBef>
-                <a:spcPts val="1000"/>
-              </a:spcBef>
-              <a:buClr>
-                <a:srgbClr val="7BAF34"/>
-              </a:buClr>
-              <a:defRPr/>
-            </a:pPr>
-            <a:endParaRPr kumimoji="0" lang="en-US" b="0" i="0" u="none" strike="noStrike" kern="1200" cap="none" spc="20" normalizeH="0" baseline="0" noProof="0" dirty="0">
-              <a:ln>
-                <a:noFill/>
-              </a:ln>
-              <a:solidFill>
-                <a:srgbClr val="000000"/>
-              </a:solidFill>
-              <a:effectLst/>
-              <a:uLnTx/>
-              <a:uFillTx/>
-              <a:latin typeface="Avenir Next LT Pro"/>
-              <a:ea typeface="+mn-ea"/>
-              <a:cs typeface="+mn-cs"/>
-            </a:endParaRPr>
-          </a:p>
-          <a:p>
-            <a:pPr marL="228600" marR="0" lvl="0" indent="-228600" algn="l" defTabSz="914400" rtl="0" eaLnBrk="1" fontAlgn="auto" latinLnBrk="0" hangingPunct="1">
-              <a:lnSpc>
-                <a:spcPct val="120000"/>
-              </a:lnSpc>
-              <a:spcBef>
-                <a:spcPts val="1000"/>
-              </a:spcBef>
-              <a:spcAft>
-                <a:spcPts val="0"/>
-              </a:spcAft>
-              <a:buClr>
-                <a:srgbClr val="7BAF34"/>
-              </a:buClr>
-              <a:buSzTx/>
-              <a:buFont typeface="The Hand Extrablack" panose="03070A02030502020204" pitchFamily="66" charset="0"/>
-              <a:buChar char="•"/>
-              <a:tabLst/>
-              <a:defRPr/>
-            </a:pPr>
-            <a:endParaRPr lang="en-US" dirty="0">
-              <a:solidFill>
-                <a:srgbClr val="000000"/>
-              </a:solidFill>
-              <a:latin typeface="Avenir Next LT Pro"/>
-            </a:endParaRPr>
-          </a:p>
-          <a:p>
-            <a:pPr marL="0" marR="0" lvl="0" indent="0" algn="l" defTabSz="914400" rtl="0" eaLnBrk="1" fontAlgn="auto" latinLnBrk="0" hangingPunct="1">
-              <a:lnSpc>
-                <a:spcPct val="120000"/>
-              </a:lnSpc>
-              <a:spcBef>
-                <a:spcPts val="1000"/>
-              </a:spcBef>
-              <a:spcAft>
-                <a:spcPts val="0"/>
-              </a:spcAft>
-              <a:buClr>
-                <a:srgbClr val="7BAF34"/>
-              </a:buClr>
-              <a:buSzTx/>
-              <a:buNone/>
-              <a:tabLst/>
-              <a:defRPr/>
-            </a:pPr>
-            <a:endParaRPr kumimoji="0" lang="en-US" sz="2000" b="0" i="0" u="none" strike="noStrike" kern="1200" cap="none" spc="20" normalizeH="0" baseline="0" noProof="0" dirty="0">
-              <a:ln>
-                <a:noFill/>
-              </a:ln>
-              <a:solidFill>
-                <a:srgbClr val="000000"/>
-              </a:solidFill>
-              <a:effectLst/>
-              <a:uLnTx/>
-              <a:uFillTx/>
-              <a:latin typeface="Avenir Next LT Pro"/>
-              <a:ea typeface="+mn-ea"/>
-              <a:cs typeface="+mn-cs"/>
-            </a:endParaRPr>
-          </a:p>
-          <a:p>
-            <a:pPr marL="228600" marR="0" lvl="0" indent="-228600" algn="l" defTabSz="914400" rtl="0" eaLnBrk="1" fontAlgn="auto" latinLnBrk="0" hangingPunct="1">
-              <a:lnSpc>
-                <a:spcPct val="120000"/>
-              </a:lnSpc>
-              <a:spcBef>
-                <a:spcPts val="1000"/>
-              </a:spcBef>
-              <a:spcAft>
-                <a:spcPts val="0"/>
-              </a:spcAft>
-              <a:buClr>
-                <a:srgbClr val="7BAF34"/>
-              </a:buClr>
-              <a:buSzTx/>
-              <a:buFont typeface="The Hand Extrablack" panose="03070A02030502020204" pitchFamily="66" charset="0"/>
-              <a:buChar char="•"/>
-              <a:tabLst/>
-              <a:defRPr/>
-            </a:pPr>
-            <a:endParaRPr kumimoji="0" lang="en-US" sz="2000" b="0" i="0" u="none" strike="noStrike" kern="1200" cap="none" spc="20" normalizeH="0" baseline="0" noProof="0" dirty="0">
-              <a:ln>
-                <a:noFill/>
-              </a:ln>
-              <a:solidFill>
-                <a:srgbClr val="000000"/>
-              </a:solidFill>
-              <a:effectLst/>
-              <a:uLnTx/>
-              <a:uFillTx/>
-              <a:latin typeface="Avenir Next LT Pro"/>
-              <a:ea typeface="+mn-ea"/>
-              <a:cs typeface="+mn-cs"/>
-            </a:endParaRPr>
-          </a:p>
-        </p:txBody>
-      </p:sp>
-      <p:sp>
-        <p:nvSpPr>
-          <p:cNvPr id="7" name="Rectangle 6">
-            <a:extLst>
-              <a:ext uri="{FF2B5EF4-FFF2-40B4-BE49-F238E27FC236}">
-                <a16:creationId xmlns:a16="http://schemas.microsoft.com/office/drawing/2014/main" id="{03292042-6149-A447-BDAE-2B25DDEF63C4}"/>
-              </a:ext>
-            </a:extLst>
-          </p:cNvPr>
-          <p:cNvSpPr/>
-          <p:nvPr/>
-        </p:nvSpPr>
-        <p:spPr>
-          <a:xfrm>
-            <a:off x="2859766" y="2546812"/>
-            <a:ext cx="2738535" cy="406937"/>
-          </a:xfrm>
-          <a:prstGeom prst="rect">
-            <a:avLst/>
-          </a:prstGeom>
-          <a:solidFill>
-            <a:srgbClr val="008A00"/>
-          </a:solidFill>
-        </p:spPr>
-        <p:style>
-          <a:lnRef idx="1">
-            <a:schemeClr val="accent6"/>
-          </a:lnRef>
-          <a:fillRef idx="2">
-            <a:schemeClr val="accent6"/>
-          </a:fillRef>
-          <a:effectRef idx="1">
-            <a:schemeClr val="accent6"/>
-          </a:effectRef>
-          <a:fontRef idx="minor">
-            <a:schemeClr val="dk1"/>
-          </a:fontRef>
-        </p:style>
-        <p:txBody>
-          <a:bodyPr rtlCol="0" anchor="ctr"/>
-          <a:lstStyle/>
-          <a:p>
-            <a:pPr algn="ctr"/>
-            <a:r>
-              <a:rPr lang="en-US" dirty="0">
-                <a:solidFill>
-                  <a:schemeClr val="bg1"/>
-                </a:solidFill>
-              </a:rPr>
-              <a:t>TP list: </a:t>
-            </a:r>
-            <a:r>
-              <a:rPr lang="en-US" b="1" dirty="0">
-                <a:solidFill>
-                  <a:schemeClr val="bg1"/>
-                </a:solidFill>
-              </a:rPr>
-              <a:t>2806</a:t>
-            </a:r>
-            <a:r>
-              <a:rPr lang="en-US" dirty="0">
-                <a:solidFill>
-                  <a:schemeClr val="bg1"/>
-                </a:solidFill>
-              </a:rPr>
-              <a:t> Proteins</a:t>
-            </a:r>
-          </a:p>
-        </p:txBody>
-      </p:sp>
-      <p:sp>
-        <p:nvSpPr>
-          <p:cNvPr id="8" name="Rectangle 7">
-            <a:extLst>
-              <a:ext uri="{FF2B5EF4-FFF2-40B4-BE49-F238E27FC236}">
-                <a16:creationId xmlns:a16="http://schemas.microsoft.com/office/drawing/2014/main" id="{054423E0-2779-0145-99D5-394704B4A2D3}"/>
-              </a:ext>
-            </a:extLst>
-          </p:cNvPr>
-          <p:cNvSpPr/>
-          <p:nvPr/>
-        </p:nvSpPr>
-        <p:spPr>
-          <a:xfrm>
-            <a:off x="5872065" y="2546811"/>
-            <a:ext cx="2738535" cy="406937"/>
-          </a:xfrm>
-          <a:prstGeom prst="rect">
-            <a:avLst/>
-          </a:prstGeom>
-          <a:solidFill>
-            <a:srgbClr val="C00000"/>
-          </a:solidFill>
-          <a:ln>
-            <a:noFill/>
-          </a:ln>
-        </p:spPr>
-        <p:style>
-          <a:lnRef idx="1">
-            <a:schemeClr val="accent6"/>
-          </a:lnRef>
-          <a:fillRef idx="2">
-            <a:schemeClr val="accent6"/>
-          </a:fillRef>
-          <a:effectRef idx="1">
-            <a:schemeClr val="accent6"/>
-          </a:effectRef>
-          <a:fontRef idx="minor">
-            <a:schemeClr val="dk1"/>
-          </a:fontRef>
-        </p:style>
-        <p:txBody>
-          <a:bodyPr rtlCol="0" anchor="ctr"/>
-          <a:lstStyle/>
-          <a:p>
-            <a:pPr algn="ctr"/>
-            <a:r>
-              <a:rPr lang="en-US" dirty="0">
-                <a:solidFill>
-                  <a:schemeClr val="bg1"/>
-                </a:solidFill>
-              </a:rPr>
-              <a:t>FP list: </a:t>
-            </a:r>
-            <a:r>
-              <a:rPr lang="en-US" b="1" dirty="0">
-                <a:solidFill>
-                  <a:schemeClr val="bg1"/>
-                </a:solidFill>
-              </a:rPr>
-              <a:t>435</a:t>
-            </a:r>
-            <a:r>
-              <a:rPr lang="en-US" dirty="0">
-                <a:solidFill>
-                  <a:schemeClr val="bg1"/>
-                </a:solidFill>
-              </a:rPr>
-              <a:t> Proteins</a:t>
-            </a:r>
-          </a:p>
-        </p:txBody>
-      </p:sp>
-      <p:sp>
-        <p:nvSpPr>
-          <p:cNvPr id="9" name="Rectangle 8">
-            <a:extLst>
-              <a:ext uri="{FF2B5EF4-FFF2-40B4-BE49-F238E27FC236}">
-                <a16:creationId xmlns:a16="http://schemas.microsoft.com/office/drawing/2014/main" id="{69C8880B-A639-0D4A-BAE4-CDC36D688C9C}"/>
-              </a:ext>
-            </a:extLst>
-          </p:cNvPr>
-          <p:cNvSpPr/>
-          <p:nvPr/>
-        </p:nvSpPr>
-        <p:spPr>
-          <a:xfrm>
-            <a:off x="2859766" y="4690244"/>
-            <a:ext cx="2738535" cy="406937"/>
-          </a:xfrm>
-          <a:prstGeom prst="rect">
-            <a:avLst/>
-          </a:prstGeom>
-          <a:solidFill>
-            <a:srgbClr val="008A00"/>
-          </a:solidFill>
-        </p:spPr>
-        <p:style>
-          <a:lnRef idx="1">
-            <a:schemeClr val="accent6"/>
-          </a:lnRef>
-          <a:fillRef idx="2">
-            <a:schemeClr val="accent6"/>
-          </a:fillRef>
-          <a:effectRef idx="1">
-            <a:schemeClr val="accent6"/>
-          </a:effectRef>
-          <a:fontRef idx="minor">
-            <a:schemeClr val="dk1"/>
-          </a:fontRef>
-        </p:style>
-        <p:txBody>
-          <a:bodyPr rtlCol="0" anchor="ctr"/>
-          <a:lstStyle/>
-          <a:p>
-            <a:pPr algn="ctr"/>
-            <a:r>
-              <a:rPr lang="en-US" dirty="0">
-                <a:solidFill>
-                  <a:schemeClr val="bg1"/>
-                </a:solidFill>
-              </a:rPr>
-              <a:t>TP list: </a:t>
-            </a:r>
-            <a:r>
-              <a:rPr lang="en-US" b="1" dirty="0">
-                <a:solidFill>
-                  <a:schemeClr val="bg1"/>
-                </a:solidFill>
-              </a:rPr>
-              <a:t>348</a:t>
-            </a:r>
-            <a:r>
-              <a:rPr lang="en-US" dirty="0">
-                <a:solidFill>
-                  <a:schemeClr val="bg1"/>
-                </a:solidFill>
-              </a:rPr>
-              <a:t> Proteins</a:t>
-            </a:r>
-          </a:p>
-        </p:txBody>
-      </p:sp>
-      <p:sp>
-        <p:nvSpPr>
-          <p:cNvPr id="10" name="Rectangle 9">
-            <a:extLst>
-              <a:ext uri="{FF2B5EF4-FFF2-40B4-BE49-F238E27FC236}">
-                <a16:creationId xmlns:a16="http://schemas.microsoft.com/office/drawing/2014/main" id="{41E29D01-8C5D-2345-86EB-6062B1DFA413}"/>
-              </a:ext>
-            </a:extLst>
-          </p:cNvPr>
-          <p:cNvSpPr/>
-          <p:nvPr/>
-        </p:nvSpPr>
-        <p:spPr>
-          <a:xfrm>
-            <a:off x="5872065" y="4690243"/>
-            <a:ext cx="2738535" cy="406937"/>
-          </a:xfrm>
-          <a:prstGeom prst="rect">
-            <a:avLst/>
-          </a:prstGeom>
-          <a:solidFill>
-            <a:srgbClr val="C00000"/>
-          </a:solidFill>
-          <a:ln>
-            <a:noFill/>
-          </a:ln>
-        </p:spPr>
-        <p:style>
-          <a:lnRef idx="1">
-            <a:schemeClr val="accent6"/>
-          </a:lnRef>
-          <a:fillRef idx="2">
-            <a:schemeClr val="accent6"/>
-          </a:fillRef>
-          <a:effectRef idx="1">
-            <a:schemeClr val="accent6"/>
-          </a:effectRef>
-          <a:fontRef idx="minor">
-            <a:schemeClr val="dk1"/>
-          </a:fontRef>
-        </p:style>
-        <p:txBody>
-          <a:bodyPr rtlCol="0" anchor="ctr"/>
-          <a:lstStyle/>
-          <a:p>
-            <a:pPr algn="ctr"/>
-            <a:r>
-              <a:rPr lang="en-US" dirty="0">
-                <a:solidFill>
-                  <a:schemeClr val="bg1"/>
-                </a:solidFill>
-              </a:rPr>
-              <a:t>FP list: </a:t>
-            </a:r>
-            <a:r>
-              <a:rPr lang="en-US" b="1" dirty="0">
-                <a:solidFill>
-                  <a:schemeClr val="bg1"/>
-                </a:solidFill>
-              </a:rPr>
-              <a:t>393</a:t>
-            </a:r>
-            <a:r>
-              <a:rPr lang="en-US" dirty="0">
-                <a:solidFill>
-                  <a:schemeClr val="bg1"/>
-                </a:solidFill>
-              </a:rPr>
-              <a:t> Proteins</a:t>
-            </a:r>
-          </a:p>
-        </p:txBody>
-      </p:sp>
-    </p:spTree>
-    <p:extLst>
-      <p:ext uri="{BB962C8B-B14F-4D97-AF65-F5344CB8AC3E}">
-        <p14:creationId xmlns:p14="http://schemas.microsoft.com/office/powerpoint/2010/main" val="1874436980"/>
-      </p:ext>
-    </p:extLst>
-  </p:cSld>
-  <p:clrMapOvr>
-    <a:masterClrMapping/>
-  </p:clrMapOvr>
-  <p:timing>
-    <p:tnLst>
-      <p:par>
-        <p:cTn id="1" dur="indefinite" restart="never" nodeType="tmRoot">
-          <p:childTnLst>
-            <p:seq concurrent="1" nextAc="seek">
-              <p:cTn id="2" dur="indefinite" nodeType="mainSeq">
-                <p:childTnLst>
-                  <p:par>
-                    <p:cTn id="3" fill="hold">
-                      <p:stCondLst>
-                        <p:cond delay="indefinite"/>
-                      </p:stCondLst>
-                      <p:childTnLst>
-                        <p:par>
-                          <p:cTn id="4" fill="hold">
-                            <p:stCondLst>
-                              <p:cond delay="0"/>
-                            </p:stCondLst>
-                            <p:childTnLst>
-                              <p:par>
-                                <p:cTn id="5" presetID="1" presetClass="entr" presetSubtype="0" fill="hold" grpId="0" nodeType="clickEffect">
-                                  <p:stCondLst>
-                                    <p:cond delay="0"/>
-                                  </p:stCondLst>
-                                  <p:childTnLst>
-                                    <p:set>
-                                      <p:cBhvr>
-                                        <p:cTn id="6" dur="1" fill="hold">
-                                          <p:stCondLst>
-                                            <p:cond delay="0"/>
-                                          </p:stCondLst>
-                                        </p:cTn>
-                                        <p:tgtEl>
-                                          <p:spTgt spid="7"/>
-                                        </p:tgtEl>
-                                        <p:attrNameLst>
-                                          <p:attrName>style.visibility</p:attrName>
-                                        </p:attrNameLst>
-                                      </p:cBhvr>
-                                      <p:to>
-                                        <p:strVal val="visible"/>
-                                      </p:to>
-                                    </p:set>
-                                  </p:childTnLst>
-                                </p:cTn>
-                              </p:par>
-                              <p:par>
-                                <p:cTn id="7" presetID="1" presetClass="entr" presetSubtype="0" fill="hold" grpId="0" nodeType="withEffect">
-                                  <p:stCondLst>
-                                    <p:cond delay="0"/>
-                                  </p:stCondLst>
-                                  <p:childTnLst>
-                                    <p:set>
-                                      <p:cBhvr>
-                                        <p:cTn id="8" dur="1" fill="hold">
-                                          <p:stCondLst>
-                                            <p:cond delay="0"/>
-                                          </p:stCondLst>
-                                        </p:cTn>
-                                        <p:tgtEl>
-                                          <p:spTgt spid="8"/>
-                                        </p:tgtEl>
-                                        <p:attrNameLst>
-                                          <p:attrName>style.visibility</p:attrName>
-                                        </p:attrNameLst>
-                                      </p:cBhvr>
-                                      <p:to>
-                                        <p:strVal val="visible"/>
-                                      </p:to>
-                                    </p:set>
-                                  </p:childTnLst>
-                                </p:cTn>
-                              </p:par>
-                            </p:childTnLst>
-                          </p:cTn>
-                        </p:par>
-                      </p:childTnLst>
-                    </p:cTn>
-                  </p:par>
-                  <p:par>
-                    <p:cTn id="9" fill="hold">
-                      <p:stCondLst>
-                        <p:cond delay="indefinite"/>
-                      </p:stCondLst>
-                      <p:childTnLst>
-                        <p:par>
-                          <p:cTn id="10" fill="hold">
-                            <p:stCondLst>
-                              <p:cond delay="0"/>
-                            </p:stCondLst>
-                            <p:childTnLst>
-                              <p:par>
-                                <p:cTn id="11" presetID="1" presetClass="entr" presetSubtype="0" fill="hold" grpId="0" nodeType="clickEffect">
-                                  <p:stCondLst>
-                                    <p:cond delay="0"/>
-                                  </p:stCondLst>
-                                  <p:childTnLst>
-                                    <p:set>
-                                      <p:cBhvr>
-                                        <p:cTn id="12" dur="1" fill="hold">
-                                          <p:stCondLst>
-                                            <p:cond delay="0"/>
-                                          </p:stCondLst>
-                                        </p:cTn>
-                                        <p:tgtEl>
-                                          <p:spTgt spid="9"/>
-                                        </p:tgtEl>
-                                        <p:attrNameLst>
-                                          <p:attrName>style.visibility</p:attrName>
-                                        </p:attrNameLst>
-                                      </p:cBhvr>
-                                      <p:to>
-                                        <p:strVal val="visible"/>
-                                      </p:to>
-                                    </p:set>
-                                  </p:childTnLst>
-                                </p:cTn>
-                              </p:par>
-                              <p:par>
-                                <p:cTn id="13" presetID="1" presetClass="entr" presetSubtype="0" fill="hold" grpId="0" nodeType="withEffect">
-                                  <p:stCondLst>
-                                    <p:cond delay="0"/>
-                                  </p:stCondLst>
-                                  <p:childTnLst>
-                                    <p:set>
-                                      <p:cBhvr>
-                                        <p:cTn id="14" dur="1" fill="hold">
-                                          <p:stCondLst>
-                                            <p:cond delay="0"/>
-                                          </p:stCondLst>
-                                        </p:cTn>
-                                        <p:tgtEl>
-                                          <p:spTgt spid="10"/>
-                                        </p:tgtEl>
-                                        <p:attrNameLst>
-                                          <p:attrName>style.visibility</p:attrName>
-                                        </p:attrNameLst>
-                                      </p:cBhvr>
-                                      <p:to>
-                                        <p:strVal val="visible"/>
-                                      </p:to>
-                                    </p:set>
-                                  </p:childTnLst>
-                                </p:cTn>
-                              </p:par>
-                            </p:childTnLst>
-                          </p:cTn>
-                        </p:par>
-                      </p:childTnLst>
-                    </p:cTn>
-                  </p:par>
-                </p:childTnLst>
-              </p:cTn>
-              <p:prevCondLst>
-                <p:cond evt="onPrev" delay="0">
-                  <p:tgtEl>
-                    <p:sldTgt/>
-                  </p:tgtEl>
-                </p:cond>
-              </p:prevCondLst>
-              <p:nextCondLst>
-                <p:cond evt="onNext" delay="0">
-                  <p:tgtEl>
-                    <p:sldTgt/>
-                  </p:tgtEl>
-                </p:cond>
-              </p:nextCondLst>
-            </p:seq>
-          </p:childTnLst>
-        </p:cTn>
-      </p:par>
-    </p:tnLst>
-    <p:bldLst>
-      <p:bldP spid="7" grpId="0" animBg="1"/>
-      <p:bldP spid="8" grpId="0" animBg="1"/>
-      <p:bldP spid="9" grpId="0" animBg="1"/>
-      <p:bldP spid="10" grpId="0" animBg="1"/>
-    </p:bldLst>
-  </p:timing>
-</p:sld>
-</file>
-
-<file path=ppt/slides/slide28.xml><?xml version="1.0" encoding="utf-8"?>
-<p:sld xmlns:a="http://schemas.openxmlformats.org/drawingml/2006/main" xmlns:r="http://schemas.openxmlformats.org/officeDocument/2006/relationships" xmlns:p="http://schemas.openxmlformats.org/presentationml/2006/main">
-  <p:cSld>
-    <p:spTree>
-      <p:nvGrpSpPr>
-        <p:cNvPr id="1" name=""/>
-        <p:cNvGrpSpPr/>
-        <p:nvPr/>
-      </p:nvGrpSpPr>
-      <p:grpSpPr>
-        <a:xfrm>
-          <a:off x="0" y="0"/>
-          <a:ext cx="0" cy="0"/>
-          <a:chOff x="0" y="0"/>
-          <a:chExt cx="0" cy="0"/>
-        </a:xfrm>
-      </p:grpSpPr>
-      <p:sp>
-        <p:nvSpPr>
-          <p:cNvPr id="48" name="Rectangle 47">
-            <a:extLst>
-              <a:ext uri="{FF2B5EF4-FFF2-40B4-BE49-F238E27FC236}">
-                <a16:creationId xmlns:a16="http://schemas.microsoft.com/office/drawing/2014/main" id="{ED71B86B-BC2D-9047-8277-56342C96644B}"/>
-              </a:ext>
-            </a:extLst>
-          </p:cNvPr>
-          <p:cNvSpPr/>
-          <p:nvPr/>
-        </p:nvSpPr>
-        <p:spPr>
-          <a:xfrm>
-            <a:off x="185770" y="1223118"/>
-            <a:ext cx="11859994" cy="2772087"/>
-          </a:xfrm>
-          <a:prstGeom prst="rect">
-            <a:avLst/>
-          </a:prstGeom>
-          <a:solidFill>
-            <a:schemeClr val="accent2">
-              <a:lumMod val="20000"/>
-              <a:lumOff val="80000"/>
-            </a:schemeClr>
-          </a:solidFill>
-          <a:ln>
-            <a:noFill/>
-          </a:ln>
-        </p:spPr>
-        <p:style>
-          <a:lnRef idx="2">
-            <a:schemeClr val="accent1">
-              <a:shade val="50000"/>
-            </a:schemeClr>
-          </a:lnRef>
-          <a:fillRef idx="1">
-            <a:schemeClr val="accent1"/>
-          </a:fillRef>
-          <a:effectRef idx="0">
-            <a:schemeClr val="accent1"/>
-          </a:effectRef>
-          <a:fontRef idx="minor">
-            <a:schemeClr val="lt1"/>
-          </a:fontRef>
-        </p:style>
-        <p:txBody>
-          <a:bodyPr rtlCol="0" anchor="ctr"/>
-          <a:lstStyle/>
-          <a:p>
-            <a:pPr algn="ctr"/>
-            <a:endParaRPr lang="en-US"/>
-          </a:p>
-        </p:txBody>
-      </p:sp>
-      <p:sp>
-        <p:nvSpPr>
-          <p:cNvPr id="47" name="Rectangle 46">
-            <a:extLst>
-              <a:ext uri="{FF2B5EF4-FFF2-40B4-BE49-F238E27FC236}">
-                <a16:creationId xmlns:a16="http://schemas.microsoft.com/office/drawing/2014/main" id="{D78E196A-10A1-3D45-9865-B2B9D48AAD8B}"/>
-              </a:ext>
-            </a:extLst>
-          </p:cNvPr>
-          <p:cNvSpPr/>
-          <p:nvPr/>
-        </p:nvSpPr>
-        <p:spPr>
-          <a:xfrm>
-            <a:off x="166003" y="4019391"/>
-            <a:ext cx="11859994" cy="2772087"/>
-          </a:xfrm>
-          <a:prstGeom prst="rect">
-            <a:avLst/>
-          </a:prstGeom>
-          <a:solidFill>
-            <a:schemeClr val="accent6">
-              <a:lumMod val="20000"/>
-              <a:lumOff val="80000"/>
-            </a:schemeClr>
-          </a:solidFill>
-          <a:ln>
-            <a:noFill/>
-          </a:ln>
-        </p:spPr>
-        <p:style>
-          <a:lnRef idx="2">
-            <a:schemeClr val="accent1">
-              <a:shade val="50000"/>
-            </a:schemeClr>
-          </a:lnRef>
-          <a:fillRef idx="1">
-            <a:schemeClr val="accent1"/>
-          </a:fillRef>
-          <a:effectRef idx="0">
-            <a:schemeClr val="accent1"/>
-          </a:effectRef>
-          <a:fontRef idx="minor">
-            <a:schemeClr val="lt1"/>
-          </a:fontRef>
-        </p:style>
-        <p:txBody>
-          <a:bodyPr rtlCol="0" anchor="ctr"/>
-          <a:lstStyle/>
-          <a:p>
-            <a:pPr algn="ctr"/>
-            <a:endParaRPr lang="en-US"/>
-          </a:p>
-        </p:txBody>
-      </p:sp>
-      <p:sp>
-        <p:nvSpPr>
-          <p:cNvPr id="4" name="Slide Number Placeholder 3">
-            <a:extLst>
-              <a:ext uri="{FF2B5EF4-FFF2-40B4-BE49-F238E27FC236}">
-                <a16:creationId xmlns:a16="http://schemas.microsoft.com/office/drawing/2014/main" id="{4383861C-DDFF-F94F-B844-7188E07B1951}"/>
-              </a:ext>
-            </a:extLst>
-          </p:cNvPr>
-          <p:cNvSpPr>
-            <a:spLocks noGrp="1"/>
-          </p:cNvSpPr>
-          <p:nvPr>
-            <p:ph type="sldNum" sz="quarter" idx="12"/>
-          </p:nvPr>
-        </p:nvSpPr>
-        <p:spPr/>
-        <p:txBody>
-          <a:bodyPr/>
-          <a:lstStyle/>
-          <a:p>
-            <a:fld id="{1621B6DD-29C1-4FEA-923F-71EA1347694C}" type="slidenum">
-              <a:rPr lang="en-US" smtClean="0"/>
-              <a:t>27</a:t>
-            </a:fld>
-            <a:endParaRPr lang="en-US"/>
-          </a:p>
-        </p:txBody>
-      </p:sp>
-      <p:sp>
-        <p:nvSpPr>
-          <p:cNvPr id="6" name="Title 1">
-            <a:extLst>
-              <a:ext uri="{FF2B5EF4-FFF2-40B4-BE49-F238E27FC236}">
-                <a16:creationId xmlns:a16="http://schemas.microsoft.com/office/drawing/2014/main" id="{8BB2DFB4-E4EC-CC46-BF2B-90B0CB50A619}"/>
-              </a:ext>
-            </a:extLst>
-          </p:cNvPr>
-          <p:cNvSpPr txBox="1">
-            <a:spLocks/>
-          </p:cNvSpPr>
-          <p:nvPr/>
-        </p:nvSpPr>
-        <p:spPr>
-          <a:xfrm>
-            <a:off x="720000" y="619200"/>
-            <a:ext cx="10728322" cy="666675"/>
-          </a:xfrm>
-          <a:prstGeom prst="rect">
-            <a:avLst/>
-          </a:prstGeom>
-        </p:spPr>
-        <p:txBody>
-          <a:bodyPr vert="horz" lIns="91440" tIns="45720" rIns="91440" bIns="45720" rtlCol="0" anchor="ctr">
-            <a:normAutofit fontScale="97500" lnSpcReduction="10000"/>
-          </a:bodyPr>
-          <a:lstStyle>
-            <a:lvl1pPr algn="l" defTabSz="914400" rtl="0" eaLnBrk="1" latinLnBrk="0" hangingPunct="1">
-              <a:lnSpc>
-                <a:spcPct val="90000"/>
-              </a:lnSpc>
-              <a:spcBef>
-                <a:spcPct val="0"/>
-              </a:spcBef>
-              <a:buNone/>
-              <a:defRPr sz="4400" kern="1200">
-                <a:solidFill>
-                  <a:schemeClr val="tx1"/>
-                </a:solidFill>
-                <a:latin typeface="+mj-lt"/>
-                <a:ea typeface="+mj-ea"/>
-                <a:cs typeface="+mj-cs"/>
-              </a:defRPr>
-            </a:lvl1pPr>
-          </a:lstStyle>
-          <a:p>
-            <a:r>
-              <a:rPr lang="en-US" b="1" dirty="0">
-                <a:latin typeface="Times New Roman" panose="02020603050405020304" pitchFamily="18" charset="0"/>
-                <a:cs typeface="Times New Roman" panose="02020603050405020304" pitchFamily="18" charset="0"/>
-              </a:rPr>
-              <a:t>File 100A</a:t>
-            </a:r>
-          </a:p>
-        </p:txBody>
-      </p:sp>
-      <p:pic>
-        <p:nvPicPr>
-          <p:cNvPr id="18" name="Picture 17" descr="Chart, histogram&#10;&#10;Description automatically generated">
-            <a:extLst>
-              <a:ext uri="{FF2B5EF4-FFF2-40B4-BE49-F238E27FC236}">
-                <a16:creationId xmlns:a16="http://schemas.microsoft.com/office/drawing/2014/main" id="{95489256-47F2-BF44-BDFC-FA7090669E9D}"/>
-              </a:ext>
-            </a:extLst>
-          </p:cNvPr>
-          <p:cNvPicPr>
-            <a:picLocks noChangeAspect="1"/>
-          </p:cNvPicPr>
-          <p:nvPr/>
-        </p:nvPicPr>
-        <p:blipFill>
-          <a:blip r:embed="rId3"/>
-          <a:stretch>
-            <a:fillRect/>
-          </a:stretch>
-        </p:blipFill>
-        <p:spPr>
-          <a:xfrm>
-            <a:off x="4115264" y="4106331"/>
-            <a:ext cx="4027722" cy="2685148"/>
-          </a:xfrm>
-          <a:prstGeom prst="rect">
-            <a:avLst/>
-          </a:prstGeom>
-        </p:spPr>
-      </p:pic>
-      <p:pic>
-        <p:nvPicPr>
-          <p:cNvPr id="22" name="Picture 21" descr="Chart, histogram&#10;&#10;Description automatically generated">
-            <a:extLst>
-              <a:ext uri="{FF2B5EF4-FFF2-40B4-BE49-F238E27FC236}">
-                <a16:creationId xmlns:a16="http://schemas.microsoft.com/office/drawing/2014/main" id="{BEA2181E-EAEC-F347-80D6-7751373F5E5C}"/>
-              </a:ext>
-            </a:extLst>
-          </p:cNvPr>
-          <p:cNvPicPr>
-            <a:picLocks noChangeAspect="1"/>
-          </p:cNvPicPr>
-          <p:nvPr/>
-        </p:nvPicPr>
-        <p:blipFill>
-          <a:blip r:embed="rId4"/>
-          <a:stretch>
-            <a:fillRect/>
-          </a:stretch>
-        </p:blipFill>
-        <p:spPr>
-          <a:xfrm>
-            <a:off x="7998275" y="4110098"/>
-            <a:ext cx="4027722" cy="2685148"/>
-          </a:xfrm>
-          <a:prstGeom prst="rect">
-            <a:avLst/>
-          </a:prstGeom>
-        </p:spPr>
-      </p:pic>
-      <p:pic>
-        <p:nvPicPr>
-          <p:cNvPr id="26" name="Picture 25" descr="Chart&#10;&#10;Description automatically generated">
-            <a:extLst>
-              <a:ext uri="{FF2B5EF4-FFF2-40B4-BE49-F238E27FC236}">
-                <a16:creationId xmlns:a16="http://schemas.microsoft.com/office/drawing/2014/main" id="{827C3A6E-C342-AD4E-A8D7-5A8373465A5B}"/>
-              </a:ext>
-            </a:extLst>
-          </p:cNvPr>
-          <p:cNvPicPr>
-            <a:picLocks noChangeAspect="1"/>
-          </p:cNvPicPr>
-          <p:nvPr/>
-        </p:nvPicPr>
-        <p:blipFill>
-          <a:blip r:embed="rId5"/>
-          <a:stretch>
-            <a:fillRect/>
-          </a:stretch>
-        </p:blipFill>
-        <p:spPr>
-          <a:xfrm>
-            <a:off x="185770" y="4067763"/>
-            <a:ext cx="4185356" cy="2790237"/>
-          </a:xfrm>
-          <a:prstGeom prst="rect">
-            <a:avLst/>
-          </a:prstGeom>
-        </p:spPr>
-      </p:pic>
-      <p:pic>
-        <p:nvPicPr>
-          <p:cNvPr id="36" name="Picture 35" descr="Chart, bar chart&#10;&#10;Description automatically generated">
-            <a:extLst>
-              <a:ext uri="{FF2B5EF4-FFF2-40B4-BE49-F238E27FC236}">
-                <a16:creationId xmlns:a16="http://schemas.microsoft.com/office/drawing/2014/main" id="{EBF3E255-2A18-3143-9C31-70D177F0733F}"/>
-              </a:ext>
-            </a:extLst>
-          </p:cNvPr>
-          <p:cNvPicPr>
-            <a:picLocks noChangeAspect="1"/>
-          </p:cNvPicPr>
-          <p:nvPr/>
-        </p:nvPicPr>
-        <p:blipFill>
-          <a:blip r:embed="rId6"/>
-          <a:stretch>
-            <a:fillRect/>
-          </a:stretch>
-        </p:blipFill>
-        <p:spPr>
-          <a:xfrm>
-            <a:off x="185770" y="1244730"/>
-            <a:ext cx="4104141" cy="2736094"/>
-          </a:xfrm>
-          <a:prstGeom prst="rect">
-            <a:avLst/>
-          </a:prstGeom>
-        </p:spPr>
-      </p:pic>
-      <p:pic>
-        <p:nvPicPr>
-          <p:cNvPr id="38" name="Picture 37" descr="Chart, histogram&#10;&#10;Description automatically generated">
-            <a:extLst>
-              <a:ext uri="{FF2B5EF4-FFF2-40B4-BE49-F238E27FC236}">
-                <a16:creationId xmlns:a16="http://schemas.microsoft.com/office/drawing/2014/main" id="{E2229430-C6AC-FB4E-8AE2-51FAA7C72206}"/>
-              </a:ext>
-            </a:extLst>
-          </p:cNvPr>
-          <p:cNvPicPr>
-            <a:picLocks noChangeAspect="1"/>
-          </p:cNvPicPr>
-          <p:nvPr/>
-        </p:nvPicPr>
-        <p:blipFill>
-          <a:blip r:embed="rId7"/>
-          <a:stretch>
-            <a:fillRect/>
-          </a:stretch>
-        </p:blipFill>
-        <p:spPr>
-          <a:xfrm>
-            <a:off x="4140716" y="1329611"/>
-            <a:ext cx="3976819" cy="2651213"/>
-          </a:xfrm>
-          <a:prstGeom prst="rect">
-            <a:avLst/>
-          </a:prstGeom>
-        </p:spPr>
-      </p:pic>
-      <p:pic>
-        <p:nvPicPr>
-          <p:cNvPr id="46" name="Picture 45" descr="Chart, histogram&#10;&#10;Description automatically generated">
-            <a:extLst>
-              <a:ext uri="{FF2B5EF4-FFF2-40B4-BE49-F238E27FC236}">
-                <a16:creationId xmlns:a16="http://schemas.microsoft.com/office/drawing/2014/main" id="{EB35A27A-2051-1543-B964-8D1CD44D2D88}"/>
-              </a:ext>
-            </a:extLst>
-          </p:cNvPr>
-          <p:cNvPicPr>
-            <a:picLocks noChangeAspect="1"/>
-          </p:cNvPicPr>
-          <p:nvPr/>
-        </p:nvPicPr>
-        <p:blipFill>
-          <a:blip r:embed="rId8"/>
-          <a:stretch>
-            <a:fillRect/>
-          </a:stretch>
-        </p:blipFill>
-        <p:spPr>
-          <a:xfrm>
-            <a:off x="7968339" y="1334244"/>
-            <a:ext cx="4027722" cy="2685148"/>
-          </a:xfrm>
-          <a:prstGeom prst="rect">
-            <a:avLst/>
-          </a:prstGeom>
-        </p:spPr>
-      </p:pic>
-      <p:sp>
-        <p:nvSpPr>
-          <p:cNvPr id="49" name="Rectangle 48">
-            <a:extLst>
-              <a:ext uri="{FF2B5EF4-FFF2-40B4-BE49-F238E27FC236}">
-                <a16:creationId xmlns:a16="http://schemas.microsoft.com/office/drawing/2014/main" id="{88278AAC-7449-884D-A336-F515E54EDFFF}"/>
-              </a:ext>
-            </a:extLst>
-          </p:cNvPr>
-          <p:cNvSpPr/>
-          <p:nvPr/>
-        </p:nvSpPr>
-        <p:spPr>
-          <a:xfrm>
-            <a:off x="1851660" y="3657600"/>
-            <a:ext cx="902970" cy="295269"/>
-          </a:xfrm>
-          <a:prstGeom prst="rect">
-            <a:avLst/>
-          </a:prstGeom>
-          <a:noFill/>
-          <a:ln w="57150">
-            <a:solidFill>
-              <a:srgbClr val="C00000"/>
-            </a:solidFill>
-          </a:ln>
-        </p:spPr>
-        <p:style>
-          <a:lnRef idx="2">
-            <a:schemeClr val="accent1">
-              <a:shade val="50000"/>
-            </a:schemeClr>
-          </a:lnRef>
-          <a:fillRef idx="1">
-            <a:schemeClr val="accent1"/>
-          </a:fillRef>
-          <a:effectRef idx="0">
-            <a:schemeClr val="accent1"/>
-          </a:effectRef>
-          <a:fontRef idx="minor">
-            <a:schemeClr val="lt1"/>
-          </a:fontRef>
-        </p:style>
-        <p:txBody>
-          <a:bodyPr rtlCol="0" anchor="ctr"/>
-          <a:lstStyle/>
-          <a:p>
-            <a:pPr algn="ctr"/>
-            <a:endParaRPr lang="en-US"/>
-          </a:p>
-        </p:txBody>
-      </p:sp>
-      <p:sp>
-        <p:nvSpPr>
-          <p:cNvPr id="50" name="Rectangle 49">
-            <a:extLst>
-              <a:ext uri="{FF2B5EF4-FFF2-40B4-BE49-F238E27FC236}">
-                <a16:creationId xmlns:a16="http://schemas.microsoft.com/office/drawing/2014/main" id="{CF6BB9CF-2C8D-F64B-8901-04A6ECA672DA}"/>
-              </a:ext>
-            </a:extLst>
-          </p:cNvPr>
-          <p:cNvSpPr/>
-          <p:nvPr/>
-        </p:nvSpPr>
-        <p:spPr>
-          <a:xfrm>
-            <a:off x="1908810" y="6549390"/>
-            <a:ext cx="902970" cy="275349"/>
-          </a:xfrm>
-          <a:prstGeom prst="rect">
-            <a:avLst/>
-          </a:prstGeom>
-          <a:noFill/>
-          <a:ln w="57150">
-            <a:solidFill>
-              <a:srgbClr val="C00000"/>
-            </a:solidFill>
-          </a:ln>
-        </p:spPr>
-        <p:style>
-          <a:lnRef idx="2">
-            <a:schemeClr val="accent1">
-              <a:shade val="50000"/>
-            </a:schemeClr>
-          </a:lnRef>
-          <a:fillRef idx="1">
-            <a:schemeClr val="accent1"/>
-          </a:fillRef>
-          <a:effectRef idx="0">
-            <a:schemeClr val="accent1"/>
-          </a:effectRef>
-          <a:fontRef idx="minor">
-            <a:schemeClr val="lt1"/>
-          </a:fontRef>
-        </p:style>
-        <p:txBody>
-          <a:bodyPr rtlCol="0" anchor="ctr"/>
-          <a:lstStyle/>
-          <a:p>
-            <a:pPr algn="ctr"/>
-            <a:endParaRPr lang="en-US"/>
-          </a:p>
-        </p:txBody>
-      </p:sp>
-    </p:spTree>
-    <p:extLst>
-      <p:ext uri="{BB962C8B-B14F-4D97-AF65-F5344CB8AC3E}">
-        <p14:creationId xmlns:p14="http://schemas.microsoft.com/office/powerpoint/2010/main" val="2372763720"/>
-      </p:ext>
-    </p:extLst>
-  </p:cSld>
-  <p:clrMapOvr>
-    <a:masterClrMapping/>
-  </p:clrMapOvr>
-</p:sld>
-</file>
-
-<file path=ppt/slides/slide29.xml><?xml version="1.0" encoding="utf-8"?>
-<p:sld xmlns:a="http://schemas.openxmlformats.org/drawingml/2006/main" xmlns:r="http://schemas.openxmlformats.org/officeDocument/2006/relationships" xmlns:p="http://schemas.openxmlformats.org/presentationml/2006/main">
-  <p:cSld>
-    <p:spTree>
-      <p:nvGrpSpPr>
-        <p:cNvPr id="1" name=""/>
-        <p:cNvGrpSpPr/>
-        <p:nvPr/>
-      </p:nvGrpSpPr>
-      <p:grpSpPr>
-        <a:xfrm>
-          <a:off x="0" y="0"/>
-          <a:ext cx="0" cy="0"/>
-          <a:chOff x="0" y="0"/>
-          <a:chExt cx="0" cy="0"/>
-        </a:xfrm>
-      </p:grpSpPr>
-      <p:sp>
-        <p:nvSpPr>
-          <p:cNvPr id="48" name="Rectangle 47">
-            <a:extLst>
-              <a:ext uri="{FF2B5EF4-FFF2-40B4-BE49-F238E27FC236}">
-                <a16:creationId xmlns:a16="http://schemas.microsoft.com/office/drawing/2014/main" id="{ED71B86B-BC2D-9047-8277-56342C96644B}"/>
-              </a:ext>
-            </a:extLst>
-          </p:cNvPr>
-          <p:cNvSpPr/>
-          <p:nvPr/>
-        </p:nvSpPr>
-        <p:spPr>
-          <a:xfrm>
-            <a:off x="185770" y="1223118"/>
-            <a:ext cx="11859994" cy="2772087"/>
-          </a:xfrm>
-          <a:prstGeom prst="rect">
-            <a:avLst/>
-          </a:prstGeom>
-          <a:solidFill>
-            <a:schemeClr val="accent2">
-              <a:lumMod val="20000"/>
-              <a:lumOff val="80000"/>
-            </a:schemeClr>
-          </a:solidFill>
-          <a:ln>
-            <a:noFill/>
-          </a:ln>
-        </p:spPr>
-        <p:style>
-          <a:lnRef idx="2">
-            <a:schemeClr val="accent1">
-              <a:shade val="50000"/>
-            </a:schemeClr>
-          </a:lnRef>
-          <a:fillRef idx="1">
-            <a:schemeClr val="accent1"/>
-          </a:fillRef>
-          <a:effectRef idx="0">
-            <a:schemeClr val="accent1"/>
-          </a:effectRef>
-          <a:fontRef idx="minor">
-            <a:schemeClr val="lt1"/>
-          </a:fontRef>
-        </p:style>
-        <p:txBody>
-          <a:bodyPr rtlCol="0" anchor="ctr"/>
-          <a:lstStyle/>
-          <a:p>
-            <a:pPr algn="ctr"/>
-            <a:endParaRPr lang="en-US"/>
-          </a:p>
-        </p:txBody>
-      </p:sp>
-      <p:sp>
-        <p:nvSpPr>
-          <p:cNvPr id="47" name="Rectangle 46">
-            <a:extLst>
-              <a:ext uri="{FF2B5EF4-FFF2-40B4-BE49-F238E27FC236}">
-                <a16:creationId xmlns:a16="http://schemas.microsoft.com/office/drawing/2014/main" id="{D78E196A-10A1-3D45-9865-B2B9D48AAD8B}"/>
-              </a:ext>
-            </a:extLst>
-          </p:cNvPr>
-          <p:cNvSpPr/>
-          <p:nvPr/>
-        </p:nvSpPr>
-        <p:spPr>
-          <a:xfrm>
-            <a:off x="166003" y="4019391"/>
-            <a:ext cx="11859994" cy="2772087"/>
-          </a:xfrm>
-          <a:prstGeom prst="rect">
-            <a:avLst/>
-          </a:prstGeom>
-          <a:solidFill>
-            <a:schemeClr val="accent6">
-              <a:lumMod val="20000"/>
-              <a:lumOff val="80000"/>
-            </a:schemeClr>
-          </a:solidFill>
-          <a:ln>
-            <a:noFill/>
-          </a:ln>
-        </p:spPr>
-        <p:style>
-          <a:lnRef idx="2">
-            <a:schemeClr val="accent1">
-              <a:shade val="50000"/>
-            </a:schemeClr>
-          </a:lnRef>
-          <a:fillRef idx="1">
-            <a:schemeClr val="accent1"/>
-          </a:fillRef>
-          <a:effectRef idx="0">
-            <a:schemeClr val="accent1"/>
-          </a:effectRef>
-          <a:fontRef idx="minor">
-            <a:schemeClr val="lt1"/>
-          </a:fontRef>
-        </p:style>
-        <p:txBody>
-          <a:bodyPr rtlCol="0" anchor="ctr"/>
-          <a:lstStyle/>
-          <a:p>
-            <a:pPr algn="ctr"/>
-            <a:endParaRPr lang="en-US"/>
-          </a:p>
-        </p:txBody>
-      </p:sp>
-      <p:sp>
-        <p:nvSpPr>
-          <p:cNvPr id="4" name="Slide Number Placeholder 3">
-            <a:extLst>
-              <a:ext uri="{FF2B5EF4-FFF2-40B4-BE49-F238E27FC236}">
-                <a16:creationId xmlns:a16="http://schemas.microsoft.com/office/drawing/2014/main" id="{4383861C-DDFF-F94F-B844-7188E07B1951}"/>
-              </a:ext>
-            </a:extLst>
-          </p:cNvPr>
-          <p:cNvSpPr>
-            <a:spLocks noGrp="1"/>
-          </p:cNvSpPr>
-          <p:nvPr>
-            <p:ph type="sldNum" sz="quarter" idx="12"/>
-          </p:nvPr>
-        </p:nvSpPr>
-        <p:spPr/>
-        <p:txBody>
-          <a:bodyPr/>
-          <a:lstStyle/>
-          <a:p>
-            <a:fld id="{1621B6DD-29C1-4FEA-923F-71EA1347694C}" type="slidenum">
-              <a:rPr lang="en-US" smtClean="0"/>
-              <a:t>28</a:t>
-            </a:fld>
-            <a:endParaRPr lang="en-US"/>
-          </a:p>
-        </p:txBody>
-      </p:sp>
-      <p:sp>
-        <p:nvSpPr>
-          <p:cNvPr id="6" name="Title 1">
-            <a:extLst>
-              <a:ext uri="{FF2B5EF4-FFF2-40B4-BE49-F238E27FC236}">
-                <a16:creationId xmlns:a16="http://schemas.microsoft.com/office/drawing/2014/main" id="{8BB2DFB4-E4EC-CC46-BF2B-90B0CB50A619}"/>
-              </a:ext>
-            </a:extLst>
-          </p:cNvPr>
-          <p:cNvSpPr txBox="1">
-            <a:spLocks/>
-          </p:cNvSpPr>
-          <p:nvPr/>
-        </p:nvSpPr>
-        <p:spPr>
-          <a:xfrm>
-            <a:off x="720000" y="619200"/>
-            <a:ext cx="10728322" cy="666675"/>
-          </a:xfrm>
-          <a:prstGeom prst="rect">
-            <a:avLst/>
-          </a:prstGeom>
-        </p:spPr>
-        <p:txBody>
-          <a:bodyPr vert="horz" lIns="91440" tIns="45720" rIns="91440" bIns="45720" rtlCol="0" anchor="ctr">
-            <a:normAutofit fontScale="97500" lnSpcReduction="10000"/>
-          </a:bodyPr>
-          <a:lstStyle>
-            <a:lvl1pPr algn="l" defTabSz="914400" rtl="0" eaLnBrk="1" latinLnBrk="0" hangingPunct="1">
-              <a:lnSpc>
-                <a:spcPct val="90000"/>
-              </a:lnSpc>
-              <a:spcBef>
-                <a:spcPct val="0"/>
-              </a:spcBef>
-              <a:buNone/>
-              <a:defRPr sz="4400" kern="1200">
-                <a:solidFill>
-                  <a:schemeClr val="tx1"/>
-                </a:solidFill>
-                <a:latin typeface="+mj-lt"/>
-                <a:ea typeface="+mj-ea"/>
-                <a:cs typeface="+mj-cs"/>
-              </a:defRPr>
-            </a:lvl1pPr>
-          </a:lstStyle>
-          <a:p>
-            <a:r>
-              <a:rPr lang="en-US" b="1" dirty="0">
-                <a:latin typeface="Times New Roman" panose="02020603050405020304" pitchFamily="18" charset="0"/>
-                <a:cs typeface="Times New Roman" panose="02020603050405020304" pitchFamily="18" charset="0"/>
-              </a:rPr>
-              <a:t>File 100A</a:t>
-            </a:r>
-          </a:p>
-        </p:txBody>
-      </p:sp>
-      <p:pic>
-        <p:nvPicPr>
-          <p:cNvPr id="3" name="Picture 2" descr="Chart, waterfall chart&#10;&#10;Description automatically generated">
-            <a:extLst>
-              <a:ext uri="{FF2B5EF4-FFF2-40B4-BE49-F238E27FC236}">
-                <a16:creationId xmlns:a16="http://schemas.microsoft.com/office/drawing/2014/main" id="{F39FC88D-A1B8-3744-8F86-CFD0967311EC}"/>
-              </a:ext>
-            </a:extLst>
-          </p:cNvPr>
-          <p:cNvPicPr>
-            <a:picLocks noChangeAspect="1"/>
-          </p:cNvPicPr>
-          <p:nvPr/>
-        </p:nvPicPr>
-        <p:blipFill>
-          <a:blip r:embed="rId3"/>
-          <a:stretch>
-            <a:fillRect/>
-          </a:stretch>
-        </p:blipFill>
-        <p:spPr>
-          <a:xfrm>
-            <a:off x="1775359" y="4028366"/>
-            <a:ext cx="4039664" cy="2693109"/>
-          </a:xfrm>
-          <a:prstGeom prst="rect">
-            <a:avLst/>
-          </a:prstGeom>
-        </p:spPr>
-      </p:pic>
-      <p:pic>
-        <p:nvPicPr>
-          <p:cNvPr id="7" name="Picture 6" descr="Chart&#10;&#10;Description automatically generated">
-            <a:extLst>
-              <a:ext uri="{FF2B5EF4-FFF2-40B4-BE49-F238E27FC236}">
-                <a16:creationId xmlns:a16="http://schemas.microsoft.com/office/drawing/2014/main" id="{E0142D9B-528D-4B4E-9310-90DAA83FC995}"/>
-              </a:ext>
-            </a:extLst>
-          </p:cNvPr>
-          <p:cNvPicPr>
-            <a:picLocks noChangeAspect="1"/>
-          </p:cNvPicPr>
-          <p:nvPr/>
-        </p:nvPicPr>
-        <p:blipFill>
-          <a:blip r:embed="rId4"/>
-          <a:stretch>
-            <a:fillRect/>
-          </a:stretch>
-        </p:blipFill>
-        <p:spPr>
-          <a:xfrm>
-            <a:off x="1656892" y="1195289"/>
-            <a:ext cx="4158131" cy="2772087"/>
-          </a:xfrm>
-          <a:prstGeom prst="rect">
-            <a:avLst/>
-          </a:prstGeom>
-        </p:spPr>
-      </p:pic>
-      <p:pic>
-        <p:nvPicPr>
-          <p:cNvPr id="9" name="Picture 8" descr="Chart, scatter chart&#10;&#10;Description automatically generated">
-            <a:extLst>
-              <a:ext uri="{FF2B5EF4-FFF2-40B4-BE49-F238E27FC236}">
-                <a16:creationId xmlns:a16="http://schemas.microsoft.com/office/drawing/2014/main" id="{061638B9-2092-A54C-8A1E-A083607496D1}"/>
-              </a:ext>
-            </a:extLst>
-          </p:cNvPr>
-          <p:cNvPicPr>
-            <a:picLocks noChangeAspect="1"/>
-          </p:cNvPicPr>
-          <p:nvPr/>
-        </p:nvPicPr>
-        <p:blipFill>
-          <a:blip r:embed="rId5"/>
-          <a:stretch>
-            <a:fillRect/>
-          </a:stretch>
-        </p:blipFill>
-        <p:spPr>
-          <a:xfrm>
-            <a:off x="6412465" y="4078482"/>
-            <a:ext cx="4396270" cy="2653904"/>
-          </a:xfrm>
-          <a:prstGeom prst="rect">
-            <a:avLst/>
-          </a:prstGeom>
-        </p:spPr>
-      </p:pic>
-      <p:pic>
-        <p:nvPicPr>
-          <p:cNvPr id="11" name="Picture 10" descr="Chart, scatter chart&#10;&#10;Description automatically generated">
-            <a:extLst>
-              <a:ext uri="{FF2B5EF4-FFF2-40B4-BE49-F238E27FC236}">
-                <a16:creationId xmlns:a16="http://schemas.microsoft.com/office/drawing/2014/main" id="{291E5E7F-D376-3247-986D-6B28BC9F7A64}"/>
-              </a:ext>
-            </a:extLst>
-          </p:cNvPr>
-          <p:cNvPicPr>
-            <a:picLocks noChangeAspect="1"/>
-          </p:cNvPicPr>
-          <p:nvPr/>
-        </p:nvPicPr>
-        <p:blipFill>
-          <a:blip r:embed="rId6"/>
-          <a:stretch>
-            <a:fillRect/>
-          </a:stretch>
-        </p:blipFill>
-        <p:spPr>
-          <a:xfrm>
-            <a:off x="6376979" y="1282209"/>
-            <a:ext cx="4396270" cy="2653904"/>
-          </a:xfrm>
-          <a:prstGeom prst="rect">
-            <a:avLst/>
-          </a:prstGeom>
-        </p:spPr>
-      </p:pic>
-    </p:spTree>
-    <p:extLst>
-      <p:ext uri="{BB962C8B-B14F-4D97-AF65-F5344CB8AC3E}">
-        <p14:creationId xmlns:p14="http://schemas.microsoft.com/office/powerpoint/2010/main" val="721295254"/>
-      </p:ext>
-    </p:extLst>
-  </p:cSld>
-  <p:clrMapOvr>
-    <a:masterClrMapping/>
-  </p:clrMapOvr>
-</p:sld>
-</file>
-
 <file path=ppt/slides/slide3.xml><?xml version="1.0" encoding="utf-8"?>
 <p:sld xmlns:a="http://schemas.openxmlformats.org/drawingml/2006/main" xmlns:r="http://schemas.openxmlformats.org/officeDocument/2006/relationships" xmlns:p="http://schemas.openxmlformats.org/presentationml/2006/main">
   <p:cSld>
@@ -30882,862 +27490,6 @@
     <p:extLst>
       <p:ext uri="{BB962C8B-B14F-4D97-AF65-F5344CB8AC3E}">
         <p14:creationId xmlns:p14="http://schemas.microsoft.com/office/powerpoint/2010/main" val="4281871720"/>
-      </p:ext>
-    </p:extLst>
-  </p:cSld>
-  <p:clrMapOvr>
-    <a:masterClrMapping/>
-  </p:clrMapOvr>
-</p:sld>
-</file>
-
-<file path=ppt/slides/slide30.xml><?xml version="1.0" encoding="utf-8"?>
-<p:sld xmlns:a="http://schemas.openxmlformats.org/drawingml/2006/main" xmlns:r="http://schemas.openxmlformats.org/officeDocument/2006/relationships" xmlns:p="http://schemas.openxmlformats.org/presentationml/2006/main">
-  <p:cSld>
-    <p:spTree>
-      <p:nvGrpSpPr>
-        <p:cNvPr id="1" name=""/>
-        <p:cNvGrpSpPr/>
-        <p:nvPr/>
-      </p:nvGrpSpPr>
-      <p:grpSpPr>
-        <a:xfrm>
-          <a:off x="0" y="0"/>
-          <a:ext cx="0" cy="0"/>
-          <a:chOff x="0" y="0"/>
-          <a:chExt cx="0" cy="0"/>
-        </a:xfrm>
-      </p:grpSpPr>
-      <p:sp>
-        <p:nvSpPr>
-          <p:cNvPr id="48" name="Rectangle 47">
-            <a:extLst>
-              <a:ext uri="{FF2B5EF4-FFF2-40B4-BE49-F238E27FC236}">
-                <a16:creationId xmlns:a16="http://schemas.microsoft.com/office/drawing/2014/main" id="{ED71B86B-BC2D-9047-8277-56342C96644B}"/>
-              </a:ext>
-            </a:extLst>
-          </p:cNvPr>
-          <p:cNvSpPr/>
-          <p:nvPr/>
-        </p:nvSpPr>
-        <p:spPr>
-          <a:xfrm>
-            <a:off x="185770" y="1223118"/>
-            <a:ext cx="11859994" cy="2772087"/>
-          </a:xfrm>
-          <a:prstGeom prst="rect">
-            <a:avLst/>
-          </a:prstGeom>
-          <a:solidFill>
-            <a:schemeClr val="accent2">
-              <a:lumMod val="20000"/>
-              <a:lumOff val="80000"/>
-            </a:schemeClr>
-          </a:solidFill>
-          <a:ln>
-            <a:noFill/>
-          </a:ln>
-        </p:spPr>
-        <p:style>
-          <a:lnRef idx="2">
-            <a:schemeClr val="accent1">
-              <a:shade val="50000"/>
-            </a:schemeClr>
-          </a:lnRef>
-          <a:fillRef idx="1">
-            <a:schemeClr val="accent1"/>
-          </a:fillRef>
-          <a:effectRef idx="0">
-            <a:schemeClr val="accent1"/>
-          </a:effectRef>
-          <a:fontRef idx="minor">
-            <a:schemeClr val="lt1"/>
-          </a:fontRef>
-        </p:style>
-        <p:txBody>
-          <a:bodyPr rtlCol="0" anchor="ctr"/>
-          <a:lstStyle/>
-          <a:p>
-            <a:pPr algn="ctr"/>
-            <a:endParaRPr lang="en-US"/>
-          </a:p>
-        </p:txBody>
-      </p:sp>
-      <p:sp>
-        <p:nvSpPr>
-          <p:cNvPr id="47" name="Rectangle 46">
-            <a:extLst>
-              <a:ext uri="{FF2B5EF4-FFF2-40B4-BE49-F238E27FC236}">
-                <a16:creationId xmlns:a16="http://schemas.microsoft.com/office/drawing/2014/main" id="{D78E196A-10A1-3D45-9865-B2B9D48AAD8B}"/>
-              </a:ext>
-            </a:extLst>
-          </p:cNvPr>
-          <p:cNvSpPr/>
-          <p:nvPr/>
-        </p:nvSpPr>
-        <p:spPr>
-          <a:xfrm>
-            <a:off x="166003" y="4019391"/>
-            <a:ext cx="11859994" cy="2772087"/>
-          </a:xfrm>
-          <a:prstGeom prst="rect">
-            <a:avLst/>
-          </a:prstGeom>
-          <a:solidFill>
-            <a:schemeClr val="accent6">
-              <a:lumMod val="20000"/>
-              <a:lumOff val="80000"/>
-            </a:schemeClr>
-          </a:solidFill>
-          <a:ln>
-            <a:noFill/>
-          </a:ln>
-        </p:spPr>
-        <p:style>
-          <a:lnRef idx="2">
-            <a:schemeClr val="accent1">
-              <a:shade val="50000"/>
-            </a:schemeClr>
-          </a:lnRef>
-          <a:fillRef idx="1">
-            <a:schemeClr val="accent1"/>
-          </a:fillRef>
-          <a:effectRef idx="0">
-            <a:schemeClr val="accent1"/>
-          </a:effectRef>
-          <a:fontRef idx="minor">
-            <a:schemeClr val="lt1"/>
-          </a:fontRef>
-        </p:style>
-        <p:txBody>
-          <a:bodyPr rtlCol="0" anchor="ctr"/>
-          <a:lstStyle/>
-          <a:p>
-            <a:pPr algn="ctr"/>
-            <a:endParaRPr lang="en-US"/>
-          </a:p>
-        </p:txBody>
-      </p:sp>
-      <p:sp>
-        <p:nvSpPr>
-          <p:cNvPr id="4" name="Slide Number Placeholder 3">
-            <a:extLst>
-              <a:ext uri="{FF2B5EF4-FFF2-40B4-BE49-F238E27FC236}">
-                <a16:creationId xmlns:a16="http://schemas.microsoft.com/office/drawing/2014/main" id="{4383861C-DDFF-F94F-B844-7188E07B1951}"/>
-              </a:ext>
-            </a:extLst>
-          </p:cNvPr>
-          <p:cNvSpPr>
-            <a:spLocks noGrp="1"/>
-          </p:cNvSpPr>
-          <p:nvPr>
-            <p:ph type="sldNum" sz="quarter" idx="12"/>
-          </p:nvPr>
-        </p:nvSpPr>
-        <p:spPr/>
-        <p:txBody>
-          <a:bodyPr/>
-          <a:lstStyle/>
-          <a:p>
-            <a:fld id="{1621B6DD-29C1-4FEA-923F-71EA1347694C}" type="slidenum">
-              <a:rPr lang="en-US" smtClean="0"/>
-              <a:t>29</a:t>
-            </a:fld>
-            <a:endParaRPr lang="en-US"/>
-          </a:p>
-        </p:txBody>
-      </p:sp>
-      <p:sp>
-        <p:nvSpPr>
-          <p:cNvPr id="6" name="Title 1">
-            <a:extLst>
-              <a:ext uri="{FF2B5EF4-FFF2-40B4-BE49-F238E27FC236}">
-                <a16:creationId xmlns:a16="http://schemas.microsoft.com/office/drawing/2014/main" id="{8BB2DFB4-E4EC-CC46-BF2B-90B0CB50A619}"/>
-              </a:ext>
-            </a:extLst>
-          </p:cNvPr>
-          <p:cNvSpPr txBox="1">
-            <a:spLocks/>
-          </p:cNvSpPr>
-          <p:nvPr/>
-        </p:nvSpPr>
-        <p:spPr>
-          <a:xfrm>
-            <a:off x="720000" y="619200"/>
-            <a:ext cx="10728322" cy="666675"/>
-          </a:xfrm>
-          <a:prstGeom prst="rect">
-            <a:avLst/>
-          </a:prstGeom>
-        </p:spPr>
-        <p:txBody>
-          <a:bodyPr vert="horz" lIns="91440" tIns="45720" rIns="91440" bIns="45720" rtlCol="0" anchor="ctr">
-            <a:normAutofit fontScale="97500" lnSpcReduction="10000"/>
-          </a:bodyPr>
-          <a:lstStyle>
-            <a:lvl1pPr algn="l" defTabSz="914400" rtl="0" eaLnBrk="1" latinLnBrk="0" hangingPunct="1">
-              <a:lnSpc>
-                <a:spcPct val="90000"/>
-              </a:lnSpc>
-              <a:spcBef>
-                <a:spcPct val="0"/>
-              </a:spcBef>
-              <a:buNone/>
-              <a:defRPr sz="4400" kern="1200">
-                <a:solidFill>
-                  <a:schemeClr val="tx1"/>
-                </a:solidFill>
-                <a:latin typeface="+mj-lt"/>
-                <a:ea typeface="+mj-ea"/>
-                <a:cs typeface="+mj-cs"/>
-              </a:defRPr>
-            </a:lvl1pPr>
-          </a:lstStyle>
-          <a:p>
-            <a:r>
-              <a:rPr lang="en-US" b="1" dirty="0">
-                <a:latin typeface="Times New Roman" panose="02020603050405020304" pitchFamily="18" charset="0"/>
-                <a:cs typeface="Times New Roman" panose="02020603050405020304" pitchFamily="18" charset="0"/>
-              </a:rPr>
-              <a:t>File 101</a:t>
-            </a:r>
-          </a:p>
-        </p:txBody>
-      </p:sp>
-      <p:pic>
-        <p:nvPicPr>
-          <p:cNvPr id="3" name="Picture 2" descr="Chart, bar chart&#10;&#10;Description automatically generated">
-            <a:extLst>
-              <a:ext uri="{FF2B5EF4-FFF2-40B4-BE49-F238E27FC236}">
-                <a16:creationId xmlns:a16="http://schemas.microsoft.com/office/drawing/2014/main" id="{C42CFE0A-BEDF-C946-9D0B-671F37F09CB6}"/>
-              </a:ext>
-            </a:extLst>
-          </p:cNvPr>
-          <p:cNvPicPr>
-            <a:picLocks noChangeAspect="1"/>
-          </p:cNvPicPr>
-          <p:nvPr/>
-        </p:nvPicPr>
-        <p:blipFill>
-          <a:blip r:embed="rId3"/>
-          <a:stretch>
-            <a:fillRect/>
-          </a:stretch>
-        </p:blipFill>
-        <p:spPr>
-          <a:xfrm>
-            <a:off x="400094" y="1378526"/>
-            <a:ext cx="3868829" cy="2579219"/>
-          </a:xfrm>
-          <a:prstGeom prst="rect">
-            <a:avLst/>
-          </a:prstGeom>
-        </p:spPr>
-      </p:pic>
-      <p:pic>
-        <p:nvPicPr>
-          <p:cNvPr id="7" name="Picture 6" descr="Chart, histogram&#10;&#10;Description automatically generated">
-            <a:extLst>
-              <a:ext uri="{FF2B5EF4-FFF2-40B4-BE49-F238E27FC236}">
-                <a16:creationId xmlns:a16="http://schemas.microsoft.com/office/drawing/2014/main" id="{6E598A11-EBD0-C149-A63B-39AFD03D2E9D}"/>
-              </a:ext>
-            </a:extLst>
-          </p:cNvPr>
-          <p:cNvPicPr>
-            <a:picLocks noChangeAspect="1"/>
-          </p:cNvPicPr>
-          <p:nvPr/>
-        </p:nvPicPr>
-        <p:blipFill>
-          <a:blip r:embed="rId4"/>
-          <a:stretch>
-            <a:fillRect/>
-          </a:stretch>
-        </p:blipFill>
-        <p:spPr>
-          <a:xfrm>
-            <a:off x="4166226" y="1310061"/>
-            <a:ext cx="3971527" cy="2647684"/>
-          </a:xfrm>
-          <a:prstGeom prst="rect">
-            <a:avLst/>
-          </a:prstGeom>
-        </p:spPr>
-      </p:pic>
-      <p:pic>
-        <p:nvPicPr>
-          <p:cNvPr id="9" name="Picture 8" descr="Chart, histogram&#10;&#10;Description automatically generated">
-            <a:extLst>
-              <a:ext uri="{FF2B5EF4-FFF2-40B4-BE49-F238E27FC236}">
-                <a16:creationId xmlns:a16="http://schemas.microsoft.com/office/drawing/2014/main" id="{CD529632-C68C-D748-A4A6-F64A1954DDED}"/>
-              </a:ext>
-            </a:extLst>
-          </p:cNvPr>
-          <p:cNvPicPr>
-            <a:picLocks noChangeAspect="1"/>
-          </p:cNvPicPr>
-          <p:nvPr/>
-        </p:nvPicPr>
-        <p:blipFill>
-          <a:blip r:embed="rId5"/>
-          <a:stretch>
-            <a:fillRect/>
-          </a:stretch>
-        </p:blipFill>
-        <p:spPr>
-          <a:xfrm>
-            <a:off x="8047785" y="1310061"/>
-            <a:ext cx="3868830" cy="2579220"/>
-          </a:xfrm>
-          <a:prstGeom prst="rect">
-            <a:avLst/>
-          </a:prstGeom>
-        </p:spPr>
-      </p:pic>
-      <p:pic>
-        <p:nvPicPr>
-          <p:cNvPr id="11" name="Picture 10" descr="Chart, waterfall chart&#10;&#10;Description automatically generated">
-            <a:extLst>
-              <a:ext uri="{FF2B5EF4-FFF2-40B4-BE49-F238E27FC236}">
-                <a16:creationId xmlns:a16="http://schemas.microsoft.com/office/drawing/2014/main" id="{EF9A7ED5-A79A-E04F-98DC-15662C37681E}"/>
-              </a:ext>
-            </a:extLst>
-          </p:cNvPr>
-          <p:cNvPicPr>
-            <a:picLocks noChangeAspect="1"/>
-          </p:cNvPicPr>
-          <p:nvPr/>
-        </p:nvPicPr>
-        <p:blipFill>
-          <a:blip r:embed="rId6"/>
-          <a:stretch>
-            <a:fillRect/>
-          </a:stretch>
-        </p:blipFill>
-        <p:spPr>
-          <a:xfrm>
-            <a:off x="255442" y="4064888"/>
-            <a:ext cx="4158131" cy="2772087"/>
-          </a:xfrm>
-          <a:prstGeom prst="rect">
-            <a:avLst/>
-          </a:prstGeom>
-        </p:spPr>
-      </p:pic>
-      <p:pic>
-        <p:nvPicPr>
-          <p:cNvPr id="13" name="Picture 12" descr="Chart, histogram&#10;&#10;Description automatically generated">
-            <a:extLst>
-              <a:ext uri="{FF2B5EF4-FFF2-40B4-BE49-F238E27FC236}">
-                <a16:creationId xmlns:a16="http://schemas.microsoft.com/office/drawing/2014/main" id="{C4364D33-36C3-A643-A54E-130C2F280561}"/>
-              </a:ext>
-            </a:extLst>
-          </p:cNvPr>
-          <p:cNvPicPr>
-            <a:picLocks noChangeAspect="1"/>
-          </p:cNvPicPr>
-          <p:nvPr/>
-        </p:nvPicPr>
-        <p:blipFill>
-          <a:blip r:embed="rId7"/>
-          <a:stretch>
-            <a:fillRect/>
-          </a:stretch>
-        </p:blipFill>
-        <p:spPr>
-          <a:xfrm>
-            <a:off x="4311875" y="4143793"/>
-            <a:ext cx="3971527" cy="2647685"/>
-          </a:xfrm>
-          <a:prstGeom prst="rect">
-            <a:avLst/>
-          </a:prstGeom>
-        </p:spPr>
-      </p:pic>
-      <p:pic>
-        <p:nvPicPr>
-          <p:cNvPr id="15" name="Picture 14" descr="Chart, histogram&#10;&#10;Description automatically generated">
-            <a:extLst>
-              <a:ext uri="{FF2B5EF4-FFF2-40B4-BE49-F238E27FC236}">
-                <a16:creationId xmlns:a16="http://schemas.microsoft.com/office/drawing/2014/main" id="{7A481926-E41F-A145-9C03-0EEB19CA034B}"/>
-              </a:ext>
-            </a:extLst>
-          </p:cNvPr>
-          <p:cNvPicPr>
-            <a:picLocks noChangeAspect="1"/>
-          </p:cNvPicPr>
-          <p:nvPr/>
-        </p:nvPicPr>
-        <p:blipFill>
-          <a:blip r:embed="rId8"/>
-          <a:stretch>
-            <a:fillRect/>
-          </a:stretch>
-        </p:blipFill>
-        <p:spPr>
-          <a:xfrm>
-            <a:off x="8212630" y="4170772"/>
-            <a:ext cx="3703985" cy="2469323"/>
-          </a:xfrm>
-          <a:prstGeom prst="rect">
-            <a:avLst/>
-          </a:prstGeom>
-        </p:spPr>
-      </p:pic>
-      <p:sp>
-        <p:nvSpPr>
-          <p:cNvPr id="27" name="Rectangle 26">
-            <a:extLst>
-              <a:ext uri="{FF2B5EF4-FFF2-40B4-BE49-F238E27FC236}">
-                <a16:creationId xmlns:a16="http://schemas.microsoft.com/office/drawing/2014/main" id="{DAE92C06-EE9B-0242-889B-0E04AAA0AAC9}"/>
-              </a:ext>
-            </a:extLst>
-          </p:cNvPr>
-          <p:cNvSpPr/>
-          <p:nvPr/>
-        </p:nvSpPr>
-        <p:spPr>
-          <a:xfrm>
-            <a:off x="1960862" y="3662476"/>
-            <a:ext cx="902970" cy="295269"/>
-          </a:xfrm>
-          <a:prstGeom prst="rect">
-            <a:avLst/>
-          </a:prstGeom>
-          <a:noFill/>
-          <a:ln w="57150">
-            <a:solidFill>
-              <a:srgbClr val="C00000"/>
-            </a:solidFill>
-          </a:ln>
-        </p:spPr>
-        <p:style>
-          <a:lnRef idx="2">
-            <a:schemeClr val="accent1">
-              <a:shade val="50000"/>
-            </a:schemeClr>
-          </a:lnRef>
-          <a:fillRef idx="1">
-            <a:schemeClr val="accent1"/>
-          </a:fillRef>
-          <a:effectRef idx="0">
-            <a:schemeClr val="accent1"/>
-          </a:effectRef>
-          <a:fontRef idx="minor">
-            <a:schemeClr val="lt1"/>
-          </a:fontRef>
-        </p:style>
-        <p:txBody>
-          <a:bodyPr rtlCol="0" anchor="ctr"/>
-          <a:lstStyle/>
-          <a:p>
-            <a:pPr algn="ctr"/>
-            <a:endParaRPr lang="en-US"/>
-          </a:p>
-        </p:txBody>
-      </p:sp>
-      <p:sp>
-        <p:nvSpPr>
-          <p:cNvPr id="28" name="Rectangle 27">
-            <a:extLst>
-              <a:ext uri="{FF2B5EF4-FFF2-40B4-BE49-F238E27FC236}">
-                <a16:creationId xmlns:a16="http://schemas.microsoft.com/office/drawing/2014/main" id="{2B9FFC93-6B78-6A4B-8DD1-1335EA7A1020}"/>
-              </a:ext>
-            </a:extLst>
-          </p:cNvPr>
-          <p:cNvSpPr/>
-          <p:nvPr/>
-        </p:nvSpPr>
-        <p:spPr>
-          <a:xfrm>
-            <a:off x="1960862" y="6516129"/>
-            <a:ext cx="902970" cy="275349"/>
-          </a:xfrm>
-          <a:prstGeom prst="rect">
-            <a:avLst/>
-          </a:prstGeom>
-          <a:noFill/>
-          <a:ln w="57150">
-            <a:solidFill>
-              <a:srgbClr val="C00000"/>
-            </a:solidFill>
-          </a:ln>
-        </p:spPr>
-        <p:style>
-          <a:lnRef idx="2">
-            <a:schemeClr val="accent1">
-              <a:shade val="50000"/>
-            </a:schemeClr>
-          </a:lnRef>
-          <a:fillRef idx="1">
-            <a:schemeClr val="accent1"/>
-          </a:fillRef>
-          <a:effectRef idx="0">
-            <a:schemeClr val="accent1"/>
-          </a:effectRef>
-          <a:fontRef idx="minor">
-            <a:schemeClr val="lt1"/>
-          </a:fontRef>
-        </p:style>
-        <p:txBody>
-          <a:bodyPr rtlCol="0" anchor="ctr"/>
-          <a:lstStyle/>
-          <a:p>
-            <a:pPr algn="ctr"/>
-            <a:endParaRPr lang="en-US"/>
-          </a:p>
-        </p:txBody>
-      </p:sp>
-    </p:spTree>
-    <p:extLst>
-      <p:ext uri="{BB962C8B-B14F-4D97-AF65-F5344CB8AC3E}">
-        <p14:creationId xmlns:p14="http://schemas.microsoft.com/office/powerpoint/2010/main" val="3639131346"/>
-      </p:ext>
-    </p:extLst>
-  </p:cSld>
-  <p:clrMapOvr>
-    <a:masterClrMapping/>
-  </p:clrMapOvr>
-</p:sld>
-</file>
-
-<file path=ppt/slides/slide31.xml><?xml version="1.0" encoding="utf-8"?>
-<p:sld xmlns:a="http://schemas.openxmlformats.org/drawingml/2006/main" xmlns:r="http://schemas.openxmlformats.org/officeDocument/2006/relationships" xmlns:p="http://schemas.openxmlformats.org/presentationml/2006/main">
-  <p:cSld>
-    <p:spTree>
-      <p:nvGrpSpPr>
-        <p:cNvPr id="1" name=""/>
-        <p:cNvGrpSpPr/>
-        <p:nvPr/>
-      </p:nvGrpSpPr>
-      <p:grpSpPr>
-        <a:xfrm>
-          <a:off x="0" y="0"/>
-          <a:ext cx="0" cy="0"/>
-          <a:chOff x="0" y="0"/>
-          <a:chExt cx="0" cy="0"/>
-        </a:xfrm>
-      </p:grpSpPr>
-      <p:sp>
-        <p:nvSpPr>
-          <p:cNvPr id="48" name="Rectangle 47">
-            <a:extLst>
-              <a:ext uri="{FF2B5EF4-FFF2-40B4-BE49-F238E27FC236}">
-                <a16:creationId xmlns:a16="http://schemas.microsoft.com/office/drawing/2014/main" id="{ED71B86B-BC2D-9047-8277-56342C96644B}"/>
-              </a:ext>
-            </a:extLst>
-          </p:cNvPr>
-          <p:cNvSpPr/>
-          <p:nvPr/>
-        </p:nvSpPr>
-        <p:spPr>
-          <a:xfrm>
-            <a:off x="185770" y="1223118"/>
-            <a:ext cx="11859994" cy="2772087"/>
-          </a:xfrm>
-          <a:prstGeom prst="rect">
-            <a:avLst/>
-          </a:prstGeom>
-          <a:solidFill>
-            <a:schemeClr val="accent2">
-              <a:lumMod val="20000"/>
-              <a:lumOff val="80000"/>
-            </a:schemeClr>
-          </a:solidFill>
-          <a:ln>
-            <a:noFill/>
-          </a:ln>
-        </p:spPr>
-        <p:style>
-          <a:lnRef idx="2">
-            <a:schemeClr val="accent1">
-              <a:shade val="50000"/>
-            </a:schemeClr>
-          </a:lnRef>
-          <a:fillRef idx="1">
-            <a:schemeClr val="accent1"/>
-          </a:fillRef>
-          <a:effectRef idx="0">
-            <a:schemeClr val="accent1"/>
-          </a:effectRef>
-          <a:fontRef idx="minor">
-            <a:schemeClr val="lt1"/>
-          </a:fontRef>
-        </p:style>
-        <p:txBody>
-          <a:bodyPr rtlCol="0" anchor="ctr"/>
-          <a:lstStyle/>
-          <a:p>
-            <a:pPr algn="ctr"/>
-            <a:endParaRPr lang="en-US"/>
-          </a:p>
-        </p:txBody>
-      </p:sp>
-      <p:sp>
-        <p:nvSpPr>
-          <p:cNvPr id="47" name="Rectangle 46">
-            <a:extLst>
-              <a:ext uri="{FF2B5EF4-FFF2-40B4-BE49-F238E27FC236}">
-                <a16:creationId xmlns:a16="http://schemas.microsoft.com/office/drawing/2014/main" id="{D78E196A-10A1-3D45-9865-B2B9D48AAD8B}"/>
-              </a:ext>
-            </a:extLst>
-          </p:cNvPr>
-          <p:cNvSpPr/>
-          <p:nvPr/>
-        </p:nvSpPr>
-        <p:spPr>
-          <a:xfrm>
-            <a:off x="166003" y="4019391"/>
-            <a:ext cx="11859994" cy="2772087"/>
-          </a:xfrm>
-          <a:prstGeom prst="rect">
-            <a:avLst/>
-          </a:prstGeom>
-          <a:solidFill>
-            <a:schemeClr val="accent6">
-              <a:lumMod val="20000"/>
-              <a:lumOff val="80000"/>
-            </a:schemeClr>
-          </a:solidFill>
-          <a:ln>
-            <a:noFill/>
-          </a:ln>
-        </p:spPr>
-        <p:style>
-          <a:lnRef idx="2">
-            <a:schemeClr val="accent1">
-              <a:shade val="50000"/>
-            </a:schemeClr>
-          </a:lnRef>
-          <a:fillRef idx="1">
-            <a:schemeClr val="accent1"/>
-          </a:fillRef>
-          <a:effectRef idx="0">
-            <a:schemeClr val="accent1"/>
-          </a:effectRef>
-          <a:fontRef idx="minor">
-            <a:schemeClr val="lt1"/>
-          </a:fontRef>
-        </p:style>
-        <p:txBody>
-          <a:bodyPr rtlCol="0" anchor="ctr"/>
-          <a:lstStyle/>
-          <a:p>
-            <a:pPr algn="ctr"/>
-            <a:endParaRPr lang="en-US"/>
-          </a:p>
-        </p:txBody>
-      </p:sp>
-      <p:sp>
-        <p:nvSpPr>
-          <p:cNvPr id="4" name="Slide Number Placeholder 3">
-            <a:extLst>
-              <a:ext uri="{FF2B5EF4-FFF2-40B4-BE49-F238E27FC236}">
-                <a16:creationId xmlns:a16="http://schemas.microsoft.com/office/drawing/2014/main" id="{4383861C-DDFF-F94F-B844-7188E07B1951}"/>
-              </a:ext>
-            </a:extLst>
-          </p:cNvPr>
-          <p:cNvSpPr>
-            <a:spLocks noGrp="1"/>
-          </p:cNvSpPr>
-          <p:nvPr>
-            <p:ph type="sldNum" sz="quarter" idx="12"/>
-          </p:nvPr>
-        </p:nvSpPr>
-        <p:spPr/>
-        <p:txBody>
-          <a:bodyPr/>
-          <a:lstStyle/>
-          <a:p>
-            <a:fld id="{1621B6DD-29C1-4FEA-923F-71EA1347694C}" type="slidenum">
-              <a:rPr lang="en-US" smtClean="0"/>
-              <a:t>30</a:t>
-            </a:fld>
-            <a:endParaRPr lang="en-US"/>
-          </a:p>
-        </p:txBody>
-      </p:sp>
-      <p:sp>
-        <p:nvSpPr>
-          <p:cNvPr id="6" name="Title 1">
-            <a:extLst>
-              <a:ext uri="{FF2B5EF4-FFF2-40B4-BE49-F238E27FC236}">
-                <a16:creationId xmlns:a16="http://schemas.microsoft.com/office/drawing/2014/main" id="{8BB2DFB4-E4EC-CC46-BF2B-90B0CB50A619}"/>
-              </a:ext>
-            </a:extLst>
-          </p:cNvPr>
-          <p:cNvSpPr txBox="1">
-            <a:spLocks/>
-          </p:cNvSpPr>
-          <p:nvPr/>
-        </p:nvSpPr>
-        <p:spPr>
-          <a:xfrm>
-            <a:off x="720000" y="619200"/>
-            <a:ext cx="10728322" cy="666675"/>
-          </a:xfrm>
-          <a:prstGeom prst="rect">
-            <a:avLst/>
-          </a:prstGeom>
-        </p:spPr>
-        <p:txBody>
-          <a:bodyPr vert="horz" lIns="91440" tIns="45720" rIns="91440" bIns="45720" rtlCol="0" anchor="ctr">
-            <a:normAutofit fontScale="97500" lnSpcReduction="10000"/>
-          </a:bodyPr>
-          <a:lstStyle>
-            <a:lvl1pPr algn="l" defTabSz="914400" rtl="0" eaLnBrk="1" latinLnBrk="0" hangingPunct="1">
-              <a:lnSpc>
-                <a:spcPct val="90000"/>
-              </a:lnSpc>
-              <a:spcBef>
-                <a:spcPct val="0"/>
-              </a:spcBef>
-              <a:buNone/>
-              <a:defRPr sz="4400" kern="1200">
-                <a:solidFill>
-                  <a:schemeClr val="tx1"/>
-                </a:solidFill>
-                <a:latin typeface="+mj-lt"/>
-                <a:ea typeface="+mj-ea"/>
-                <a:cs typeface="+mj-cs"/>
-              </a:defRPr>
-            </a:lvl1pPr>
-          </a:lstStyle>
-          <a:p>
-            <a:r>
-              <a:rPr lang="en-US" b="1" dirty="0">
-                <a:latin typeface="Times New Roman" panose="02020603050405020304" pitchFamily="18" charset="0"/>
-                <a:cs typeface="Times New Roman" panose="02020603050405020304" pitchFamily="18" charset="0"/>
-              </a:rPr>
-              <a:t>File 101</a:t>
-            </a:r>
-          </a:p>
-        </p:txBody>
-      </p:sp>
-      <p:pic>
-        <p:nvPicPr>
-          <p:cNvPr id="5" name="Picture 4" descr="Chart, waterfall chart&#10;&#10;Description automatically generated">
-            <a:extLst>
-              <a:ext uri="{FF2B5EF4-FFF2-40B4-BE49-F238E27FC236}">
-                <a16:creationId xmlns:a16="http://schemas.microsoft.com/office/drawing/2014/main" id="{0BB8D6E9-41AC-5740-996C-92651C6A3385}"/>
-              </a:ext>
-            </a:extLst>
-          </p:cNvPr>
-          <p:cNvPicPr>
-            <a:picLocks noChangeAspect="1"/>
-          </p:cNvPicPr>
-          <p:nvPr/>
-        </p:nvPicPr>
-        <p:blipFill>
-          <a:blip r:embed="rId3"/>
-          <a:stretch>
-            <a:fillRect/>
-          </a:stretch>
-        </p:blipFill>
-        <p:spPr>
-          <a:xfrm>
-            <a:off x="2088051" y="1266589"/>
-            <a:ext cx="4027716" cy="2685144"/>
-          </a:xfrm>
-          <a:prstGeom prst="rect">
-            <a:avLst/>
-          </a:prstGeom>
-        </p:spPr>
-      </p:pic>
-      <p:pic>
-        <p:nvPicPr>
-          <p:cNvPr id="10" name="Picture 9" descr="Chart, scatter chart&#10;&#10;Description automatically generated">
-            <a:extLst>
-              <a:ext uri="{FF2B5EF4-FFF2-40B4-BE49-F238E27FC236}">
-                <a16:creationId xmlns:a16="http://schemas.microsoft.com/office/drawing/2014/main" id="{645898AF-DDB0-9B40-B2F5-A9724954A6EA}"/>
-              </a:ext>
-            </a:extLst>
-          </p:cNvPr>
-          <p:cNvPicPr>
-            <a:picLocks noChangeAspect="1"/>
-          </p:cNvPicPr>
-          <p:nvPr/>
-        </p:nvPicPr>
-        <p:blipFill>
-          <a:blip r:embed="rId4"/>
-          <a:stretch>
-            <a:fillRect/>
-          </a:stretch>
-        </p:blipFill>
-        <p:spPr>
-          <a:xfrm>
-            <a:off x="6506642" y="1370440"/>
-            <a:ext cx="4207915" cy="2540200"/>
-          </a:xfrm>
-          <a:prstGeom prst="rect">
-            <a:avLst/>
-          </a:prstGeom>
-        </p:spPr>
-      </p:pic>
-      <p:pic>
-        <p:nvPicPr>
-          <p:cNvPr id="13" name="Picture 12" descr="Chart, waterfall chart&#10;&#10;Description automatically generated">
-            <a:extLst>
-              <a:ext uri="{FF2B5EF4-FFF2-40B4-BE49-F238E27FC236}">
-                <a16:creationId xmlns:a16="http://schemas.microsoft.com/office/drawing/2014/main" id="{8DA4F906-70F7-3243-89EE-A88FE95662CE}"/>
-              </a:ext>
-            </a:extLst>
-          </p:cNvPr>
-          <p:cNvPicPr>
-            <a:picLocks noChangeAspect="1"/>
-          </p:cNvPicPr>
-          <p:nvPr/>
-        </p:nvPicPr>
-        <p:blipFill>
-          <a:blip r:embed="rId5"/>
-          <a:stretch>
-            <a:fillRect/>
-          </a:stretch>
-        </p:blipFill>
-        <p:spPr>
-          <a:xfrm>
-            <a:off x="2135829" y="4094714"/>
-            <a:ext cx="3932159" cy="2621439"/>
-          </a:xfrm>
-          <a:prstGeom prst="rect">
-            <a:avLst/>
-          </a:prstGeom>
-        </p:spPr>
-      </p:pic>
-      <p:pic>
-        <p:nvPicPr>
-          <p:cNvPr id="15" name="Picture 14" descr="Chart, scatter chart&#10;&#10;Description automatically generated">
-            <a:extLst>
-              <a:ext uri="{FF2B5EF4-FFF2-40B4-BE49-F238E27FC236}">
-                <a16:creationId xmlns:a16="http://schemas.microsoft.com/office/drawing/2014/main" id="{B9D1910A-5470-5D4D-9A60-5E0EB5E96A6B}"/>
-              </a:ext>
-            </a:extLst>
-          </p:cNvPr>
-          <p:cNvPicPr>
-            <a:picLocks noChangeAspect="1"/>
-          </p:cNvPicPr>
-          <p:nvPr/>
-        </p:nvPicPr>
-        <p:blipFill>
-          <a:blip r:embed="rId6"/>
-          <a:stretch>
-            <a:fillRect/>
-          </a:stretch>
-        </p:blipFill>
-        <p:spPr>
-          <a:xfrm>
-            <a:off x="6506642" y="4175954"/>
-            <a:ext cx="4207915" cy="2540199"/>
-          </a:xfrm>
-          <a:prstGeom prst="rect">
-            <a:avLst/>
-          </a:prstGeom>
-        </p:spPr>
-      </p:pic>
-    </p:spTree>
-    <p:extLst>
-      <p:ext uri="{BB962C8B-B14F-4D97-AF65-F5344CB8AC3E}">
-        <p14:creationId xmlns:p14="http://schemas.microsoft.com/office/powerpoint/2010/main" val="2886417708"/>
       </p:ext>
     </p:extLst>
   </p:cSld>

</xml_diff>